<commit_message>
Preserve layout artwork and explicit text alignment in Office renderers
</commit_message>
<xml_diff>
--- a/slides/planb-starter.pptx
+++ b/slides/planb-starter.pptx
@@ -1357,7 +1357,7 @@
 </file>
 
 <file path=ppt/slideLayouts/slideLayout1.xml><?xml version="1.0" encoding="utf-8"?>
-<p:sldLayout xmlns:a="http://schemas.openxmlformats.org/drawingml/2006/main" xmlns:r="http://schemas.openxmlformats.org/officeDocument/2006/relationships" xmlns:p="http://schemas.openxmlformats.org/presentationml/2006/main" type="cust" preserve="1" showMasterSp="0">
+<p:sldLayout xmlns:a="http://schemas.openxmlformats.org/drawingml/2006/main" xmlns:r="http://schemas.openxmlformats.org/officeDocument/2006/relationships" xmlns:p="http://schemas.openxmlformats.org/presentationml/2006/main" type="cust" preserve="1" showMasterSp="1">
   <p:cSld name="Plan B / Cover">
     <p:bg>
       <p:bgPr>
@@ -1403,19 +1403,20 @@
           </a:bodyPr>
           <a:lstStyle/>
           <a:p>
-            <a:pPr>
-              <a:lnSpc>
-                <a:spcPct val="112000"/>
-              </a:lnSpc>
-              <a:spcAft>
-                <a:spcPts val="1200"/>
-              </a:spcAft>
+            <a:pPr algn="l" marL="0" indent="0">
               <a:defRPr sz="1100" b="1">
                 <a:solidFill>
                   <a:srgbClr val="082952"/>
                 </a:solidFill>
                 <a:latin typeface="Inter"/>
               </a:defRPr>
+              <a:lnSpc>
+                <a:spcPct val="112000"/>
+              </a:lnSpc>
+              <a:spcAft>
+                <a:spcPts val="1200"/>
+              </a:spcAft>
+              <a:buNone/>
             </a:pPr>
             <a:r>
               <a:t>Plan B Foundation</a:t>
@@ -1445,19 +1446,20 @@
           </a:bodyPr>
           <a:lstStyle/>
           <a:p>
-            <a:pPr>
-              <a:lnSpc>
-                <a:spcPct val="112000"/>
-              </a:lnSpc>
-              <a:spcAft>
-                <a:spcPts val="1200"/>
-              </a:spcAft>
+            <a:pPr algn="l" marL="0" indent="0">
               <a:defRPr sz="1100" b="0">
                 <a:solidFill>
                   <a:srgbClr val="082952"/>
                 </a:solidFill>
                 <a:latin typeface="Inter"/>
               </a:defRPr>
+              <a:lnSpc>
+                <a:spcPct val="112000"/>
+              </a:lnSpc>
+              <a:spcAft>
+                <a:spcPts val="1200"/>
+              </a:spcAft>
+              <a:buNone/>
             </a:pPr>
             <a:r>
               <a:t>Civic Digital Commons</a:t>
@@ -1489,38 +1491,40 @@
           </a:bodyPr>
           <a:lstStyle/>
           <a:p>
-            <a:pPr>
-              <a:lnSpc>
-                <a:spcPct val="112000"/>
-              </a:lnSpc>
-              <a:spcAft>
-                <a:spcPts val="1200"/>
-              </a:spcAft>
+            <a:pPr algn="l" marL="0" indent="0">
               <a:defRPr sz="4800" b="1">
                 <a:solidFill>
                   <a:srgbClr val="082952"/>
                 </a:solidFill>
                 <a:latin typeface="Inter"/>
               </a:defRPr>
+              <a:lnSpc>
+                <a:spcPct val="112000"/>
+              </a:lnSpc>
+              <a:spcAft>
+                <a:spcPts val="1200"/>
+              </a:spcAft>
+              <a:buNone/>
             </a:pPr>
             <a:r>
               <a:t>[Presentation</a:t>
             </a:r>
           </a:p>
           <a:p>
-            <a:pPr>
-              <a:lnSpc>
-                <a:spcPct val="112000"/>
-              </a:lnSpc>
-              <a:spcAft>
-                <a:spcPts val="1200"/>
-              </a:spcAft>
+            <a:pPr algn="l" marL="0" indent="0">
               <a:defRPr sz="4800" b="1">
                 <a:solidFill>
                   <a:srgbClr val="082952"/>
                 </a:solidFill>
                 <a:latin typeface="Inter"/>
               </a:defRPr>
+              <a:lnSpc>
+                <a:spcPct val="112000"/>
+              </a:lnSpc>
+              <a:spcAft>
+                <a:spcPts val="1200"/>
+              </a:spcAft>
+              <a:buNone/>
             </a:pPr>
             <a:r>
               <a:t>title]</a:t>
@@ -1552,19 +1556,20 @@
           </a:bodyPr>
           <a:lstStyle/>
           <a:p>
-            <a:pPr>
-              <a:lnSpc>
-                <a:spcPct val="112000"/>
-              </a:lnSpc>
-              <a:spcAft>
-                <a:spcPts val="1200"/>
-              </a:spcAft>
+            <a:pPr algn="l" marL="0" indent="0">
               <a:defRPr sz="2400" b="0">
                 <a:solidFill>
                   <a:srgbClr val="030B20"/>
                 </a:solidFill>
                 <a:latin typeface="Inter"/>
               </a:defRPr>
+              <a:lnSpc>
+                <a:spcPct val="112000"/>
+              </a:lnSpc>
+              <a:spcAft>
+                <a:spcPts val="1200"/>
+              </a:spcAft>
+              <a:buNone/>
             </a:pPr>
             <a:r>
               <a:t>[A clear sentence about the civic purpose]</a:t>
@@ -1596,38 +1601,40 @@
           </a:bodyPr>
           <a:lstStyle/>
           <a:p>
-            <a:pPr>
-              <a:lnSpc>
-                <a:spcPct val="112000"/>
-              </a:lnSpc>
-              <a:spcAft>
-                <a:spcPts val="1200"/>
-              </a:spcAft>
+            <a:pPr algn="l" marL="0" indent="0">
               <a:defRPr sz="1700" b="0">
                 <a:solidFill>
                   <a:srgbClr val="030B20"/>
                 </a:solidFill>
                 <a:latin typeface="Inter"/>
               </a:defRPr>
+              <a:lnSpc>
+                <a:spcPct val="112000"/>
+              </a:lnSpc>
+              <a:spcAft>
+                <a:spcPts val="1200"/>
+              </a:spcAft>
+              <a:buNone/>
             </a:pPr>
             <a:r>
               <a:t>[Presenter / team]</a:t>
             </a:r>
           </a:p>
           <a:p>
-            <a:pPr>
-              <a:lnSpc>
-                <a:spcPct val="112000"/>
-              </a:lnSpc>
-              <a:spcAft>
-                <a:spcPts val="1200"/>
-              </a:spcAft>
+            <a:pPr algn="l" marL="0" indent="0">
               <a:defRPr sz="1700" b="0">
                 <a:solidFill>
                   <a:srgbClr val="030B20"/>
                 </a:solidFill>
                 <a:latin typeface="Inter"/>
               </a:defRPr>
+              <a:lnSpc>
+                <a:spcPct val="112000"/>
+              </a:lnSpc>
+              <a:spcAft>
+                <a:spcPts val="1200"/>
+              </a:spcAft>
+              <a:buNone/>
             </a:pPr>
             <a:r>
               <a:t>[Event · date]</a:t>
@@ -1728,76 +1735,80 @@
           </a:bodyPr>
           <a:lstStyle/>
           <a:p>
-            <a:pPr>
-              <a:lnSpc>
-                <a:spcPct val="112000"/>
-              </a:lnSpc>
-              <a:spcAft>
-                <a:spcPts val="1200"/>
-              </a:spcAft>
+            <a:pPr algn="l" marL="0" indent="0">
               <a:defRPr sz="2900" b="1">
                 <a:solidFill>
                   <a:srgbClr val="FFFEFA"/>
                 </a:solidFill>
                 <a:latin typeface="Inter"/>
               </a:defRPr>
+              <a:lnSpc>
+                <a:spcPct val="112000"/>
+              </a:lnSpc>
+              <a:spcAft>
+                <a:spcPts val="1200"/>
+              </a:spcAft>
+              <a:buNone/>
             </a:pPr>
             <a:r>
               <a:t>Open.</a:t>
             </a:r>
           </a:p>
           <a:p>
-            <a:pPr>
-              <a:lnSpc>
-                <a:spcPct val="112000"/>
-              </a:lnSpc>
-              <a:spcAft>
-                <a:spcPts val="1200"/>
-              </a:spcAft>
+            <a:pPr algn="l" marL="0" indent="0">
               <a:defRPr sz="2900" b="1">
                 <a:solidFill>
                   <a:srgbClr val="FFFEFA"/>
                 </a:solidFill>
                 <a:latin typeface="Inter"/>
               </a:defRPr>
+              <a:lnSpc>
+                <a:spcPct val="112000"/>
+              </a:lnSpc>
+              <a:spcAft>
+                <a:spcPts val="1200"/>
+              </a:spcAft>
+              <a:buNone/>
             </a:pPr>
             <a:r>
               <a:t>Capable.</a:t>
             </a:r>
           </a:p>
           <a:p>
-            <a:pPr>
-              <a:lnSpc>
-                <a:spcPct val="112000"/>
-              </a:lnSpc>
-              <a:spcAft>
-                <a:spcPts val="1200"/>
-              </a:spcAft>
+            <a:pPr algn="l" marL="0" indent="0">
               <a:defRPr sz="2900" b="1">
                 <a:solidFill>
                   <a:srgbClr val="FFFEFA"/>
                 </a:solidFill>
                 <a:latin typeface="Inter"/>
               </a:defRPr>
+              <a:lnSpc>
+                <a:spcPct val="112000"/>
+              </a:lnSpc>
+              <a:spcAft>
+                <a:spcPts val="1200"/>
+              </a:spcAft>
+              <a:buNone/>
             </a:pPr>
             <a:r>
               <a:t>Curious.</a:t>
             </a:r>
           </a:p>
           <a:p>
-            <a:pPr>
-              <a:lnSpc>
-                <a:spcPct val="112000"/>
-              </a:lnSpc>
-              <a:spcAft>
-                <a:spcPts val="1200"/>
-              </a:spcAft>
+            <a:pPr algn="l" marL="0" indent="0">
               <a:defRPr sz="2900" b="1">
                 <a:solidFill>
                   <a:srgbClr val="FFFEFA"/>
                 </a:solidFill>
                 <a:latin typeface="Inter"/>
               </a:defRPr>
+              <a:lnSpc>
+                <a:spcPct val="112000"/>
+              </a:lnSpc>
+              <a:spcAft>
+                <a:spcPts val="1200"/>
+              </a:spcAft>
+              <a:buNone/>
             </a:pPr>
             <a:r>
               <a:t>Grounded.</a:t>
@@ -1876,7 +1887,7 @@
 </file>
 
 <file path=ppt/slideLayouts/slideLayout10.xml><?xml version="1.0" encoding="utf-8"?>
-<p:sldLayout xmlns:a="http://schemas.openxmlformats.org/drawingml/2006/main" xmlns:r="http://schemas.openxmlformats.org/officeDocument/2006/relationships" xmlns:p="http://schemas.openxmlformats.org/presentationml/2006/main" type="cust" preserve="1" showMasterSp="0">
+<p:sldLayout xmlns:a="http://schemas.openxmlformats.org/drawingml/2006/main" xmlns:r="http://schemas.openxmlformats.org/officeDocument/2006/relationships" xmlns:p="http://schemas.openxmlformats.org/presentationml/2006/main" type="cust" preserve="1" showMasterSp="1">
   <p:cSld name="Plan B / Template guide">
     <p:bg>
       <p:bgPr>
@@ -1922,19 +1933,20 @@
           </a:bodyPr>
           <a:lstStyle/>
           <a:p>
-            <a:pPr>
-              <a:lnSpc>
-                <a:spcPct val="112000"/>
-              </a:lnSpc>
-              <a:spcAft>
-                <a:spcPts val="1200"/>
-              </a:spcAft>
+            <a:pPr algn="l" marL="0" indent="0">
               <a:defRPr sz="1100" b="1">
                 <a:solidFill>
                   <a:srgbClr val="082952"/>
                 </a:solidFill>
                 <a:latin typeface="Inter"/>
               </a:defRPr>
+              <a:lnSpc>
+                <a:spcPct val="112000"/>
+              </a:lnSpc>
+              <a:spcAft>
+                <a:spcPts val="1200"/>
+              </a:spcAft>
+              <a:buNone/>
             </a:pPr>
             <a:r>
               <a:t>Plan B Foundation</a:t>
@@ -1964,19 +1976,20 @@
           </a:bodyPr>
           <a:lstStyle/>
           <a:p>
-            <a:pPr>
-              <a:lnSpc>
-                <a:spcPct val="112000"/>
-              </a:lnSpc>
-              <a:spcAft>
-                <a:spcPts val="1200"/>
-              </a:spcAft>
+            <a:pPr algn="l" marL="0" indent="0">
               <a:defRPr sz="1100" b="0">
                 <a:solidFill>
                   <a:srgbClr val="082952"/>
                 </a:solidFill>
                 <a:latin typeface="Inter"/>
               </a:defRPr>
+              <a:lnSpc>
+                <a:spcPct val="112000"/>
+              </a:lnSpc>
+              <a:spcAft>
+                <a:spcPts val="1200"/>
+              </a:spcAft>
+              <a:buNone/>
             </a:pPr>
             <a:r>
               <a:t>Civic Digital Commons</a:t>
@@ -2008,19 +2021,20 @@
           </a:bodyPr>
           <a:lstStyle/>
           <a:p>
-            <a:pPr>
-              <a:lnSpc>
-                <a:spcPct val="112000"/>
-              </a:lnSpc>
-              <a:spcAft>
-                <a:spcPts val="1200"/>
-              </a:spcAft>
+            <a:pPr algn="l" marL="0" indent="0">
               <a:defRPr sz="3600" b="1">
                 <a:solidFill>
                   <a:srgbClr val="082952"/>
                 </a:solidFill>
                 <a:latin typeface="Inter"/>
               </a:defRPr>
+              <a:lnSpc>
+                <a:spcPct val="112000"/>
+              </a:lnSpc>
+              <a:spcAft>
+                <a:spcPts val="1200"/>
+              </a:spcAft>
+              <a:buNone/>
             </a:pPr>
             <a:r>
               <a:t>Make it yours. Keep it Plan B.</a:t>
@@ -2052,19 +2066,20 @@
           </a:bodyPr>
           <a:lstStyle/>
           <a:p>
-            <a:pPr>
-              <a:lnSpc>
-                <a:spcPct val="112000"/>
-              </a:lnSpc>
-              <a:spcAft>
-                <a:spcPts val="1200"/>
-              </a:spcAft>
+            <a:pPr algn="l" marL="0" indent="0">
               <a:defRPr sz="1900" b="0">
                 <a:solidFill>
                   <a:srgbClr val="030B20"/>
                 </a:solidFill>
                 <a:latin typeface="Inter"/>
               </a:defRPr>
+              <a:lnSpc>
+                <a:spcPct val="112000"/>
+              </a:lnSpc>
+              <a:spcAft>
+                <a:spcPts val="1200"/>
+              </a:spcAft>
+              <a:buNone/>
             </a:pPr>
             <a:r>
               <a:t>Delete this guidance slide before presenting.</a:t>
@@ -2096,38 +2111,40 @@
           </a:bodyPr>
           <a:lstStyle/>
           <a:p>
-            <a:pPr>
-              <a:lnSpc>
-                <a:spcPct val="112000"/>
-              </a:lnSpc>
-              <a:spcAft>
-                <a:spcPts val="1200"/>
-              </a:spcAft>
+            <a:pPr algn="l" marL="0" indent="0">
               <a:defRPr sz="2300" b="0">
                 <a:solidFill>
                   <a:srgbClr val="030B20"/>
                 </a:solidFill>
                 <a:latin typeface="Inter"/>
               </a:defRPr>
+              <a:lnSpc>
+                <a:spcPct val="112000"/>
+              </a:lnSpc>
+              <a:spcAft>
+                <a:spcPts val="1200"/>
+              </a:spcAft>
+              <a:buNone/>
             </a:pPr>
             <a:r>
               <a:t>Use the layouts</a:t>
             </a:r>
           </a:p>
           <a:p>
-            <a:pPr>
-              <a:lnSpc>
-                <a:spcPct val="112000"/>
-              </a:lnSpc>
-              <a:spcAft>
-                <a:spcPts val="1200"/>
-              </a:spcAft>
+            <a:pPr algn="l" marL="0" indent="0">
               <a:defRPr sz="2300" b="0">
                 <a:solidFill>
                   <a:srgbClr val="030B20"/>
                 </a:solidFill>
                 <a:latin typeface="Inter"/>
               </a:defRPr>
+              <a:lnSpc>
+                <a:spcPct val="112000"/>
+              </a:lnSpc>
+              <a:spcAft>
+                <a:spcPts val="1200"/>
+              </a:spcAft>
+              <a:buNone/>
             </a:pPr>
             <a:r>
               <a:t>Install Inter, then choose Home → New Slide. Replace bracketed prompts. Duplicate the chart or table example to retain its styling.</a:t>
@@ -2159,38 +2176,40 @@
           </a:bodyPr>
           <a:lstStyle/>
           <a:p>
-            <a:pPr>
-              <a:lnSpc>
-                <a:spcPct val="112000"/>
-              </a:lnSpc>
-              <a:spcAft>
-                <a:spcPts val="1200"/>
-              </a:spcAft>
+            <a:pPr algn="l" marL="0" indent="0">
               <a:defRPr sz="2300" b="0">
                 <a:solidFill>
                   <a:srgbClr val="030B20"/>
                 </a:solidFill>
                 <a:latin typeface="Inter"/>
               </a:defRPr>
+              <a:lnSpc>
+                <a:spcPct val="112000"/>
+              </a:lnSpc>
+              <a:spcAft>
+                <a:spcPts val="1200"/>
+              </a:spcAft>
+              <a:buNone/>
             </a:pPr>
             <a:r>
               <a:t>Keep it clear</a:t>
             </a:r>
           </a:p>
           <a:p>
-            <a:pPr>
-              <a:lnSpc>
-                <a:spcPct val="112000"/>
-              </a:lnSpc>
-              <a:spcAft>
-                <a:spcPts val="1200"/>
-              </a:spcAft>
+            <a:pPr algn="l" marL="0" indent="0">
               <a:defRPr sz="2300" b="0">
                 <a:solidFill>
                   <a:srgbClr val="030B20"/>
                 </a:solidFill>
                 <a:latin typeface="Inter"/>
               </a:defRPr>
+              <a:lnSpc>
+                <a:spcPct val="112000"/>
+              </a:lnSpc>
+              <a:spcAft>
+                <a:spcPts val="1200"/>
+              </a:spcAft>
+              <a:buNone/>
             </a:pPr>
             <a:r>
               <a:t>One idea per slide. Use navy and warm white. Choose gold or a small gradient as the exceptional signal. Aim for 20pt or larger body text.</a:t>
@@ -2392,19 +2411,20 @@
           </a:bodyPr>
           <a:lstStyle/>
           <a:p>
-            <a:pPr>
-              <a:lnSpc>
-                <a:spcPct val="112000"/>
-              </a:lnSpc>
-              <a:spcAft>
-                <a:spcPts val="1200"/>
-              </a:spcAft>
+            <a:pPr algn="l" marL="0" indent="0">
               <a:defRPr sz="1500" b="0">
                 <a:solidFill>
                   <a:srgbClr val="082952"/>
                 </a:solidFill>
                 <a:latin typeface="Inter"/>
               </a:defRPr>
+              <a:lnSpc>
+                <a:spcPct val="112000"/>
+              </a:lnSpc>
+              <a:spcAft>
+                <a:spcPts val="1200"/>
+              </a:spcAft>
+              <a:buNone/>
             </a:pPr>
             <a:r>
               <a:t>Full guidance: plan-b.foundation/branding/</a:t>
@@ -2426,7 +2446,7 @@
 </file>
 
 <file path=ppt/slideLayouts/slideLayout11.xml><?xml version="1.0" encoding="utf-8"?>
-<p:sldLayout xmlns:a="http://schemas.openxmlformats.org/drawingml/2006/main" xmlns:r="http://schemas.openxmlformats.org/officeDocument/2006/relationships" xmlns:p="http://schemas.openxmlformats.org/presentationml/2006/main" type="cust" preserve="1" showMasterSp="0">
+<p:sldLayout xmlns:a="http://schemas.openxmlformats.org/drawingml/2006/main" xmlns:r="http://schemas.openxmlformats.org/officeDocument/2006/relationships" xmlns:p="http://schemas.openxmlformats.org/presentationml/2006/main" type="cust" preserve="1" showMasterSp="1">
   <p:cSld name="Plan B / Blank">
     <p:bg>
       <p:bgPr>
@@ -2464,7 +2484,7 @@
 </file>
 
 <file path=ppt/slideLayouts/slideLayout2.xml><?xml version="1.0" encoding="utf-8"?>
-<p:sldLayout xmlns:a="http://schemas.openxmlformats.org/drawingml/2006/main" xmlns:r="http://schemas.openxmlformats.org/officeDocument/2006/relationships" xmlns:p="http://schemas.openxmlformats.org/presentationml/2006/main" type="cust" preserve="1" showMasterSp="0">
+<p:sldLayout xmlns:a="http://schemas.openxmlformats.org/drawingml/2006/main" xmlns:r="http://schemas.openxmlformats.org/officeDocument/2006/relationships" xmlns:p="http://schemas.openxmlformats.org/presentationml/2006/main" type="cust" preserve="1" showMasterSp="1">
   <p:cSld name="Plan B / Section">
     <p:bg>
       <p:bgPr>
@@ -2510,19 +2530,20 @@
           </a:bodyPr>
           <a:lstStyle/>
           <a:p>
-            <a:pPr>
-              <a:lnSpc>
-                <a:spcPct val="112000"/>
-              </a:lnSpc>
-              <a:spcAft>
-                <a:spcPts val="1200"/>
-              </a:spcAft>
+            <a:pPr algn="l" marL="0" indent="0">
               <a:defRPr sz="1100" b="1">
                 <a:solidFill>
                   <a:srgbClr val="FFFEFA"/>
                 </a:solidFill>
                 <a:latin typeface="Inter"/>
               </a:defRPr>
+              <a:lnSpc>
+                <a:spcPct val="112000"/>
+              </a:lnSpc>
+              <a:spcAft>
+                <a:spcPts val="1200"/>
+              </a:spcAft>
+              <a:buNone/>
             </a:pPr>
             <a:r>
               <a:t>Plan B Foundation</a:t>
@@ -2552,19 +2573,20 @@
           </a:bodyPr>
           <a:lstStyle/>
           <a:p>
-            <a:pPr>
-              <a:lnSpc>
-                <a:spcPct val="112000"/>
-              </a:lnSpc>
-              <a:spcAft>
-                <a:spcPts val="1200"/>
-              </a:spcAft>
+            <a:pPr algn="l" marL="0" indent="0">
               <a:defRPr sz="1100" b="0">
                 <a:solidFill>
                   <a:srgbClr val="FFFEFA"/>
                 </a:solidFill>
                 <a:latin typeface="Inter"/>
               </a:defRPr>
+              <a:lnSpc>
+                <a:spcPct val="112000"/>
+              </a:lnSpc>
+              <a:spcAft>
+                <a:spcPts val="1200"/>
+              </a:spcAft>
+              <a:buNone/>
             </a:pPr>
             <a:r>
               <a:t>Civic Digital Commons</a:t>
@@ -2596,19 +2618,20 @@
           </a:bodyPr>
           <a:lstStyle/>
           <a:p>
-            <a:pPr>
-              <a:lnSpc>
-                <a:spcPct val="112000"/>
-              </a:lnSpc>
-              <a:spcAft>
-                <a:spcPts val="1200"/>
-              </a:spcAft>
+            <a:pPr algn="l" marL="0" indent="0">
               <a:defRPr sz="4800" b="1">
                 <a:solidFill>
                   <a:srgbClr val="FFFEFA"/>
                 </a:solidFill>
                 <a:latin typeface="Inter"/>
               </a:defRPr>
+              <a:lnSpc>
+                <a:spcPct val="112000"/>
+              </a:lnSpc>
+              <a:spcAft>
+                <a:spcPts val="1200"/>
+              </a:spcAft>
+              <a:buNone/>
             </a:pPr>
             <a:r>
               <a:t>[Section title]</a:t>
@@ -2640,19 +2663,20 @@
           </a:bodyPr>
           <a:lstStyle/>
           <a:p>
-            <a:pPr>
-              <a:lnSpc>
-                <a:spcPct val="112000"/>
-              </a:lnSpc>
-              <a:spcAft>
-                <a:spcPts val="1200"/>
-              </a:spcAft>
+            <a:pPr algn="l" marL="0" indent="0">
               <a:defRPr sz="2500" b="0">
                 <a:solidFill>
                   <a:srgbClr val="FFFEFA"/>
                 </a:solidFill>
                 <a:latin typeface="Inter"/>
               </a:defRPr>
+              <a:lnSpc>
+                <a:spcPct val="112000"/>
+              </a:lnSpc>
+              <a:spcAft>
+                <a:spcPts val="1200"/>
+              </a:spcAft>
+              <a:buNone/>
             </a:pPr>
             <a:r>
               <a:t>[One sentence that sets the direction]</a:t>
@@ -2717,7 +2741,7 @@
 </file>
 
 <file path=ppt/slideLayouts/slideLayout3.xml><?xml version="1.0" encoding="utf-8"?>
-<p:sldLayout xmlns:a="http://schemas.openxmlformats.org/drawingml/2006/main" xmlns:r="http://schemas.openxmlformats.org/officeDocument/2006/relationships" xmlns:p="http://schemas.openxmlformats.org/presentationml/2006/main" type="cust" preserve="1" showMasterSp="0">
+<p:sldLayout xmlns:a="http://schemas.openxmlformats.org/drawingml/2006/main" xmlns:r="http://schemas.openxmlformats.org/officeDocument/2006/relationships" xmlns:p="http://schemas.openxmlformats.org/presentationml/2006/main" type="cust" preserve="1" showMasterSp="1">
   <p:cSld name="Plan B / Title and content">
     <p:bg>
       <p:bgPr>
@@ -2763,19 +2787,20 @@
           </a:bodyPr>
           <a:lstStyle/>
           <a:p>
-            <a:pPr>
-              <a:lnSpc>
-                <a:spcPct val="112000"/>
-              </a:lnSpc>
-              <a:spcAft>
-                <a:spcPts val="1200"/>
-              </a:spcAft>
+            <a:pPr algn="l" marL="0" indent="0">
               <a:defRPr sz="1100" b="1">
                 <a:solidFill>
                   <a:srgbClr val="082952"/>
                 </a:solidFill>
                 <a:latin typeface="Inter"/>
               </a:defRPr>
+              <a:lnSpc>
+                <a:spcPct val="112000"/>
+              </a:lnSpc>
+              <a:spcAft>
+                <a:spcPts val="1200"/>
+              </a:spcAft>
+              <a:buNone/>
             </a:pPr>
             <a:r>
               <a:t>Plan B Foundation</a:t>
@@ -2805,19 +2830,20 @@
           </a:bodyPr>
           <a:lstStyle/>
           <a:p>
-            <a:pPr>
-              <a:lnSpc>
-                <a:spcPct val="112000"/>
-              </a:lnSpc>
-              <a:spcAft>
-                <a:spcPts val="1200"/>
-              </a:spcAft>
+            <a:pPr algn="l" marL="0" indent="0">
               <a:defRPr sz="1100" b="0">
                 <a:solidFill>
                   <a:srgbClr val="082952"/>
                 </a:solidFill>
                 <a:latin typeface="Inter"/>
               </a:defRPr>
+              <a:lnSpc>
+                <a:spcPct val="112000"/>
+              </a:lnSpc>
+              <a:spcAft>
+                <a:spcPts val="1200"/>
+              </a:spcAft>
+              <a:buNone/>
             </a:pPr>
             <a:r>
               <a:t>Civic Digital Commons</a:t>
@@ -2849,19 +2875,20 @@
           </a:bodyPr>
           <a:lstStyle/>
           <a:p>
-            <a:pPr>
-              <a:lnSpc>
-                <a:spcPct val="112000"/>
-              </a:lnSpc>
-              <a:spcAft>
-                <a:spcPts val="1200"/>
-              </a:spcAft>
+            <a:pPr algn="l" marL="0" indent="0">
               <a:defRPr sz="3600" b="1">
                 <a:solidFill>
                   <a:srgbClr val="082952"/>
                 </a:solidFill>
                 <a:latin typeface="Inter"/>
               </a:defRPr>
+              <a:lnSpc>
+                <a:spcPct val="112000"/>
+              </a:lnSpc>
+              <a:spcAft>
+                <a:spcPts val="1200"/>
+              </a:spcAft>
+              <a:buNone/>
             </a:pPr>
             <a:r>
               <a:t>[Lead with the point]</a:t>
@@ -2893,19 +2920,20 @@
           </a:bodyPr>
           <a:lstStyle/>
           <a:p>
-            <a:pPr>
-              <a:lnSpc>
-                <a:spcPct val="112000"/>
-              </a:lnSpc>
-              <a:spcAft>
-                <a:spcPts val="1200"/>
-              </a:spcAft>
+            <a:pPr algn="l" marL="0" indent="0">
               <a:defRPr sz="1900" b="0">
                 <a:solidFill>
                   <a:srgbClr val="030B20"/>
                 </a:solidFill>
                 <a:latin typeface="Inter"/>
               </a:defRPr>
+              <a:lnSpc>
+                <a:spcPct val="112000"/>
+              </a:lnSpc>
+              <a:spcAft>
+                <a:spcPts val="1200"/>
+              </a:spcAft>
+              <a:buNone/>
             </a:pPr>
             <a:r>
               <a:t>[Explain why this matters to the audience]</a:t>
@@ -2937,57 +2965,60 @@
           </a:bodyPr>
           <a:lstStyle/>
           <a:p>
-            <a:pPr>
-              <a:lnSpc>
-                <a:spcPct val="112000"/>
-              </a:lnSpc>
-              <a:spcAft>
-                <a:spcPts val="1200"/>
-              </a:spcAft>
+            <a:pPr algn="l" marL="0" indent="0">
               <a:defRPr sz="2700" b="0">
                 <a:solidFill>
                   <a:srgbClr val="030B20"/>
                 </a:solidFill>
                 <a:latin typeface="Inter"/>
               </a:defRPr>
+              <a:lnSpc>
+                <a:spcPct val="112000"/>
+              </a:lnSpc>
+              <a:spcAft>
+                <a:spcPts val="1200"/>
+              </a:spcAft>
+              <a:buNone/>
             </a:pPr>
             <a:r>
               <a:t>[First idea — one concise sentence]</a:t>
             </a:r>
           </a:p>
           <a:p>
-            <a:pPr>
-              <a:lnSpc>
-                <a:spcPct val="112000"/>
-              </a:lnSpc>
-              <a:spcAft>
-                <a:spcPts val="1200"/>
-              </a:spcAft>
+            <a:pPr algn="l" marL="0" indent="0">
               <a:defRPr sz="2700" b="0">
                 <a:solidFill>
                   <a:srgbClr val="030B20"/>
                 </a:solidFill>
                 <a:latin typeface="Inter"/>
               </a:defRPr>
+              <a:lnSpc>
+                <a:spcPct val="112000"/>
+              </a:lnSpc>
+              <a:spcAft>
+                <a:spcPts val="1200"/>
+              </a:spcAft>
+              <a:buNone/>
             </a:pPr>
             <a:r>
               <a:t>[Second idea — one concise sentence]</a:t>
             </a:r>
           </a:p>
           <a:p>
-            <a:pPr>
-              <a:lnSpc>
-                <a:spcPct val="112000"/>
-              </a:lnSpc>
-              <a:spcAft>
-                <a:spcPts val="1200"/>
-              </a:spcAft>
+            <a:pPr algn="l" marL="0" indent="0">
               <a:defRPr sz="2700" b="0">
                 <a:solidFill>
                   <a:srgbClr val="030B20"/>
                 </a:solidFill>
                 <a:latin typeface="Inter"/>
               </a:defRPr>
+              <a:lnSpc>
+                <a:spcPct val="112000"/>
+              </a:lnSpc>
+              <a:spcAft>
+                <a:spcPts val="1200"/>
+              </a:spcAft>
+              <a:buNone/>
             </a:pPr>
             <a:r>
               <a:t>[Third idea — one concise sentence]</a:t>
@@ -3052,7 +3083,7 @@
 </file>
 
 <file path=ppt/slideLayouts/slideLayout4.xml><?xml version="1.0" encoding="utf-8"?>
-<p:sldLayout xmlns:a="http://schemas.openxmlformats.org/drawingml/2006/main" xmlns:r="http://schemas.openxmlformats.org/officeDocument/2006/relationships" xmlns:p="http://schemas.openxmlformats.org/presentationml/2006/main" type="cust" preserve="1" showMasterSp="0">
+<p:sldLayout xmlns:a="http://schemas.openxmlformats.org/drawingml/2006/main" xmlns:r="http://schemas.openxmlformats.org/officeDocument/2006/relationships" xmlns:p="http://schemas.openxmlformats.org/presentationml/2006/main" type="cust" preserve="1" showMasterSp="1">
   <p:cSld name="Plan B / Two columns">
     <p:bg>
       <p:bgPr>
@@ -3098,19 +3129,20 @@
           </a:bodyPr>
           <a:lstStyle/>
           <a:p>
-            <a:pPr>
-              <a:lnSpc>
-                <a:spcPct val="112000"/>
-              </a:lnSpc>
-              <a:spcAft>
-                <a:spcPts val="1200"/>
-              </a:spcAft>
+            <a:pPr algn="l" marL="0" indent="0">
               <a:defRPr sz="1100" b="1">
                 <a:solidFill>
                   <a:srgbClr val="082952"/>
                 </a:solidFill>
                 <a:latin typeface="Inter"/>
               </a:defRPr>
+              <a:lnSpc>
+                <a:spcPct val="112000"/>
+              </a:lnSpc>
+              <a:spcAft>
+                <a:spcPts val="1200"/>
+              </a:spcAft>
+              <a:buNone/>
             </a:pPr>
             <a:r>
               <a:t>Plan B Foundation</a:t>
@@ -3140,19 +3172,20 @@
           </a:bodyPr>
           <a:lstStyle/>
           <a:p>
-            <a:pPr>
-              <a:lnSpc>
-                <a:spcPct val="112000"/>
-              </a:lnSpc>
-              <a:spcAft>
-                <a:spcPts val="1200"/>
-              </a:spcAft>
+            <a:pPr algn="l" marL="0" indent="0">
               <a:defRPr sz="1100" b="0">
                 <a:solidFill>
                   <a:srgbClr val="082952"/>
                 </a:solidFill>
                 <a:latin typeface="Inter"/>
               </a:defRPr>
+              <a:lnSpc>
+                <a:spcPct val="112000"/>
+              </a:lnSpc>
+              <a:spcAft>
+                <a:spcPts val="1200"/>
+              </a:spcAft>
+              <a:buNone/>
             </a:pPr>
             <a:r>
               <a:t>Civic Digital Commons</a:t>
@@ -3184,19 +3217,20 @@
           </a:bodyPr>
           <a:lstStyle/>
           <a:p>
-            <a:pPr>
-              <a:lnSpc>
-                <a:spcPct val="112000"/>
-              </a:lnSpc>
-              <a:spcAft>
-                <a:spcPts val="1200"/>
-              </a:spcAft>
+            <a:pPr algn="l" marL="0" indent="0">
               <a:defRPr sz="3600" b="1">
                 <a:solidFill>
                   <a:srgbClr val="082952"/>
                 </a:solidFill>
                 <a:latin typeface="Inter"/>
               </a:defRPr>
+              <a:lnSpc>
+                <a:spcPct val="112000"/>
+              </a:lnSpc>
+              <a:spcAft>
+                <a:spcPts val="1200"/>
+              </a:spcAft>
+              <a:buNone/>
             </a:pPr>
             <a:r>
               <a:t>[Compare two ideas]</a:t>
@@ -3228,19 +3262,20 @@
           </a:bodyPr>
           <a:lstStyle/>
           <a:p>
-            <a:pPr>
-              <a:lnSpc>
-                <a:spcPct val="112000"/>
-              </a:lnSpc>
-              <a:spcAft>
-                <a:spcPts val="1200"/>
-              </a:spcAft>
+            <a:pPr algn="l" marL="0" indent="0">
               <a:defRPr sz="2600" b="1">
                 <a:solidFill>
                   <a:srgbClr val="082952"/>
                 </a:solidFill>
                 <a:latin typeface="Inter"/>
               </a:defRPr>
+              <a:lnSpc>
+                <a:spcPct val="112000"/>
+              </a:lnSpc>
+              <a:spcAft>
+                <a:spcPts val="1200"/>
+              </a:spcAft>
+              <a:buNone/>
             </a:pPr>
             <a:r>
               <a:t>[First perspective]</a:t>
@@ -3272,19 +3307,20 @@
           </a:bodyPr>
           <a:lstStyle/>
           <a:p>
-            <a:pPr>
-              <a:lnSpc>
-                <a:spcPct val="112000"/>
-              </a:lnSpc>
-              <a:spcAft>
-                <a:spcPts val="1200"/>
-              </a:spcAft>
+            <a:pPr algn="l" marL="0" indent="0">
               <a:defRPr sz="2400" b="0">
                 <a:solidFill>
                   <a:srgbClr val="030B20"/>
                 </a:solidFill>
                 <a:latin typeface="Inter"/>
               </a:defRPr>
+              <a:lnSpc>
+                <a:spcPct val="112000"/>
+              </a:lnSpc>
+              <a:spcAft>
+                <a:spcPts val="1200"/>
+              </a:spcAft>
+              <a:buNone/>
             </a:pPr>
             <a:r>
               <a:t>[Explain the idea in 40 words or fewer. Keep sentences concrete and easy to read.]</a:t>
@@ -3316,19 +3352,20 @@
           </a:bodyPr>
           <a:lstStyle/>
           <a:p>
-            <a:pPr>
-              <a:lnSpc>
-                <a:spcPct val="112000"/>
-              </a:lnSpc>
-              <a:spcAft>
-                <a:spcPts val="1200"/>
-              </a:spcAft>
+            <a:pPr algn="l" marL="0" indent="0">
               <a:defRPr sz="2600" b="1">
                 <a:solidFill>
                   <a:srgbClr val="082952"/>
                 </a:solidFill>
                 <a:latin typeface="Inter"/>
               </a:defRPr>
+              <a:lnSpc>
+                <a:spcPct val="112000"/>
+              </a:lnSpc>
+              <a:spcAft>
+                <a:spcPts val="1200"/>
+              </a:spcAft>
+              <a:buNone/>
             </a:pPr>
             <a:r>
               <a:t>[Second perspective]</a:t>
@@ -3360,19 +3397,20 @@
           </a:bodyPr>
           <a:lstStyle/>
           <a:p>
-            <a:pPr>
-              <a:lnSpc>
-                <a:spcPct val="112000"/>
-              </a:lnSpc>
-              <a:spcAft>
-                <a:spcPts val="1200"/>
-              </a:spcAft>
+            <a:pPr algn="l" marL="0" indent="0">
               <a:defRPr sz="2400" b="0">
                 <a:solidFill>
                   <a:srgbClr val="030B20"/>
                 </a:solidFill>
                 <a:latin typeface="Inter"/>
               </a:defRPr>
+              <a:lnSpc>
+                <a:spcPct val="112000"/>
+              </a:lnSpc>
+              <a:spcAft>
+                <a:spcPts val="1200"/>
+              </a:spcAft>
+              <a:buNone/>
             </a:pPr>
             <a:r>
               <a:t>[Explain the difference or consequence. Use the same level of detail as the first column.]</a:t>
@@ -3437,7 +3475,7 @@
 </file>
 
 <file path=ppt/slideLayouts/slideLayout5.xml><?xml version="1.0" encoding="utf-8"?>
-<p:sldLayout xmlns:a="http://schemas.openxmlformats.org/drawingml/2006/main" xmlns:r="http://schemas.openxmlformats.org/officeDocument/2006/relationships" xmlns:p="http://schemas.openxmlformats.org/presentationml/2006/main" type="cust" preserve="1" showMasterSp="0">
+<p:sldLayout xmlns:a="http://schemas.openxmlformats.org/drawingml/2006/main" xmlns:r="http://schemas.openxmlformats.org/officeDocument/2006/relationships" xmlns:p="http://schemas.openxmlformats.org/presentationml/2006/main" type="cust" preserve="1" showMasterSp="1">
   <p:cSld name="Plan B / Image and story">
     <p:bg>
       <p:bgPr>
@@ -3483,19 +3521,20 @@
           </a:bodyPr>
           <a:lstStyle/>
           <a:p>
-            <a:pPr>
-              <a:lnSpc>
-                <a:spcPct val="112000"/>
-              </a:lnSpc>
-              <a:spcAft>
-                <a:spcPts val="1200"/>
-              </a:spcAft>
+            <a:pPr algn="l" marL="0" indent="0">
               <a:defRPr sz="1100" b="1">
                 <a:solidFill>
                   <a:srgbClr val="082952"/>
                 </a:solidFill>
                 <a:latin typeface="Inter"/>
               </a:defRPr>
+              <a:lnSpc>
+                <a:spcPct val="112000"/>
+              </a:lnSpc>
+              <a:spcAft>
+                <a:spcPts val="1200"/>
+              </a:spcAft>
+              <a:buNone/>
             </a:pPr>
             <a:r>
               <a:t>Plan B Foundation</a:t>
@@ -3525,19 +3564,20 @@
           </a:bodyPr>
           <a:lstStyle/>
           <a:p>
-            <a:pPr>
-              <a:lnSpc>
-                <a:spcPct val="112000"/>
-              </a:lnSpc>
-              <a:spcAft>
-                <a:spcPts val="1200"/>
-              </a:spcAft>
+            <a:pPr algn="l" marL="0" indent="0">
               <a:defRPr sz="1100" b="0">
                 <a:solidFill>
                   <a:srgbClr val="082952"/>
                 </a:solidFill>
                 <a:latin typeface="Inter"/>
               </a:defRPr>
+              <a:lnSpc>
+                <a:spcPct val="112000"/>
+              </a:lnSpc>
+              <a:spcAft>
+                <a:spcPts val="1200"/>
+              </a:spcAft>
+              <a:buNone/>
             </a:pPr>
             <a:r>
               <a:t>Civic Digital Commons</a:t>
@@ -3569,19 +3609,20 @@
           </a:bodyPr>
           <a:lstStyle/>
           <a:p>
-            <a:pPr>
-              <a:lnSpc>
-                <a:spcPct val="112000"/>
-              </a:lnSpc>
-              <a:spcAft>
-                <a:spcPts val="1200"/>
-              </a:spcAft>
+            <a:pPr algn="l" marL="0" indent="0">
               <a:defRPr sz="3600" b="1">
                 <a:solidFill>
                   <a:srgbClr val="082952"/>
                 </a:solidFill>
                 <a:latin typeface="Inter"/>
               </a:defRPr>
+              <a:lnSpc>
+                <a:spcPct val="112000"/>
+              </a:lnSpc>
+              <a:spcAft>
+                <a:spcPts val="1200"/>
+              </a:spcAft>
+              <a:buNone/>
             </a:pPr>
             <a:r>
               <a:t>[Make the place visible]</a:t>
@@ -3636,11 +3677,9 @@
       </p:sp>
       <p:sp>
         <p:nvSpPr>
-          <p:cNvPr id="6" name="Placeholder 1"/>
-          <p:cNvSpPr txBox="1"/>
-          <p:nvPr>
-            <p:ph type="pic" idx="1"/>
-          </p:nvPr>
+          <p:cNvPr id="6" name="Insert a documentary photograph"/>
+          <p:cNvSpPr txBox="1"/>
+          <p:nvPr/>
         </p:nvSpPr>
         <p:spPr>
           <a:xfrm>
@@ -3658,19 +3697,65 @@
           </a:bodyPr>
           <a:lstStyle/>
           <a:p>
-            <a:pPr>
-              <a:lnSpc>
-                <a:spcPct val="112000"/>
-              </a:lnSpc>
-              <a:spcAft>
-                <a:spcPts val="1200"/>
-              </a:spcAft>
+            <a:pPr algn="l" marL="0" indent="0">
               <a:defRPr sz="2600" b="1">
                 <a:solidFill>
                   <a:srgbClr val="082952"/>
                 </a:solidFill>
                 <a:latin typeface="Inter"/>
               </a:defRPr>
+              <a:lnSpc>
+                <a:spcPct val="112000"/>
+              </a:lnSpc>
+              <a:spcAft>
+                <a:spcPts val="1200"/>
+              </a:spcAft>
+              <a:buNone/>
+            </a:pPr>
+            <a:r>
+              <a:t>Insert a documentary photograph</a:t>
+            </a:r>
+          </a:p>
+        </p:txBody>
+      </p:sp>
+      <p:sp>
+        <p:nvSpPr>
+          <p:cNvPr id="7" name="Placeholder 1"/>
+          <p:cNvSpPr txBox="1"/>
+          <p:nvPr>
+            <p:ph type="pic" idx="1"/>
+          </p:nvPr>
+        </p:nvSpPr>
+        <p:spPr>
+          <a:xfrm>
+            <a:off x="914400" y="2834640"/>
+            <a:ext cx="6035040" cy="1051560"/>
+          </a:xfrm>
+          <a:prstGeom prst="rect">
+            <a:avLst/>
+          </a:prstGeom>
+          <a:noFill/>
+        </p:spPr>
+        <p:txBody>
+          <a:bodyPr wrap="square" lIns="0" rIns="0" tIns="0" bIns="0">
+            <a:spAutoFit/>
+          </a:bodyPr>
+          <a:lstStyle/>
+          <a:p>
+            <a:pPr algn="l" marL="0" indent="0">
+              <a:defRPr sz="2600" b="1">
+                <a:solidFill>
+                  <a:srgbClr val="082952"/>
+                </a:solidFill>
+                <a:latin typeface="Inter"/>
+              </a:defRPr>
+              <a:lnSpc>
+                <a:spcPct val="112000"/>
+              </a:lnSpc>
+              <a:spcAft>
+                <a:spcPts val="1200"/>
+              </a:spcAft>
+              <a:buNone/>
             </a:pPr>
             <a:r>
               <a:t>[Insert a documentary photograph]</a:t>
@@ -3680,7 +3765,7 @@
       </p:sp>
       <p:sp>
         <p:nvSpPr>
-          <p:cNvPr id="7" name="Placeholder 2"/>
+          <p:cNvPr id="8" name="Placeholder 2"/>
           <p:cNvSpPr txBox="1"/>
           <p:nvPr>
             <p:ph type="body" idx="2"/>
@@ -3702,19 +3787,20 @@
           </a:bodyPr>
           <a:lstStyle/>
           <a:p>
-            <a:pPr>
-              <a:lnSpc>
-                <a:spcPct val="112000"/>
-              </a:lnSpc>
-              <a:spcAft>
-                <a:spcPts val="1200"/>
-              </a:spcAft>
+            <a:pPr algn="l" marL="0" indent="0">
               <a:defRPr sz="2700" b="1">
                 <a:solidFill>
                   <a:srgbClr val="082952"/>
                 </a:solidFill>
                 <a:latin typeface="Inter"/>
               </a:defRPr>
+              <a:lnSpc>
+                <a:spcPct val="112000"/>
+              </a:lnSpc>
+              <a:spcAft>
+                <a:spcPts val="1200"/>
+              </a:spcAft>
+              <a:buNone/>
             </a:pPr>
             <a:r>
               <a:t>[What should we notice?]</a:t>
@@ -3724,7 +3810,7 @@
       </p:sp>
       <p:sp>
         <p:nvSpPr>
-          <p:cNvPr id="8" name="Placeholder 3"/>
+          <p:cNvPr id="9" name="Placeholder 3"/>
           <p:cNvSpPr txBox="1"/>
           <p:nvPr>
             <p:ph type="body" idx="3"/>
@@ -3746,19 +3832,20 @@
           </a:bodyPr>
           <a:lstStyle/>
           <a:p>
-            <a:pPr>
-              <a:lnSpc>
-                <a:spcPct val="112000"/>
-              </a:lnSpc>
-              <a:spcAft>
-                <a:spcPts val="1200"/>
-              </a:spcAft>
+            <a:pPr algn="l" marL="0" indent="0">
               <a:defRPr sz="2200" b="0">
                 <a:solidFill>
                   <a:srgbClr val="030B20"/>
                 </a:solidFill>
                 <a:latin typeface="Inter"/>
               </a:defRPr>
+              <a:lnSpc>
+                <a:spcPct val="112000"/>
+              </a:lnSpc>
+              <a:spcAft>
+                <a:spcPts val="1200"/>
+              </a:spcAft>
+              <a:buNone/>
             </a:pPr>
             <a:r>
               <a:t>[Connect the image to the public purpose. Use real Lugano, civic spaces, workshops or people making and learning.]</a:t>
@@ -3768,7 +3855,7 @@
       </p:sp>
       <p:sp>
         <p:nvSpPr>
-          <p:cNvPr id="9" name="Placeholder 4"/>
+          <p:cNvPr id="10" name="Placeholder 4"/>
           <p:cNvSpPr txBox="1"/>
           <p:nvPr>
             <p:ph type="body" idx="4"/>
@@ -3790,19 +3877,20 @@
           </a:bodyPr>
           <a:lstStyle/>
           <a:p>
-            <a:pPr>
-              <a:lnSpc>
-                <a:spcPct val="112000"/>
-              </a:lnSpc>
-              <a:spcAft>
-                <a:spcPts val="1200"/>
-              </a:spcAft>
+            <a:pPr algn="l" marL="0" indent="0">
               <a:defRPr sz="1200" b="0">
                 <a:solidFill>
                   <a:srgbClr val="030B20"/>
                 </a:solidFill>
                 <a:latin typeface="Inter"/>
               </a:defRPr>
+              <a:lnSpc>
+                <a:spcPct val="112000"/>
+              </a:lnSpc>
+              <a:spcAft>
+                <a:spcPts val="1200"/>
+              </a:spcAft>
+              <a:buNone/>
             </a:pPr>
             <a:r>
               <a:t>[Photo credit / source / permission]</a:t>
@@ -3824,7 +3912,7 @@
 </file>
 
 <file path=ppt/slideLayouts/slideLayout6.xml><?xml version="1.0" encoding="utf-8"?>
-<p:sldLayout xmlns:a="http://schemas.openxmlformats.org/drawingml/2006/main" xmlns:r="http://schemas.openxmlformats.org/officeDocument/2006/relationships" xmlns:p="http://schemas.openxmlformats.org/presentationml/2006/main" type="cust" preserve="1" showMasterSp="0">
+<p:sldLayout xmlns:a="http://schemas.openxmlformats.org/drawingml/2006/main" xmlns:r="http://schemas.openxmlformats.org/officeDocument/2006/relationships" xmlns:p="http://schemas.openxmlformats.org/presentationml/2006/main" type="cust" preserve="1" showMasterSp="1">
   <p:cSld name="Plan B / Chart and takeaway">
     <p:bg>
       <p:bgPr>
@@ -3870,19 +3958,20 @@
           </a:bodyPr>
           <a:lstStyle/>
           <a:p>
-            <a:pPr>
-              <a:lnSpc>
-                <a:spcPct val="112000"/>
-              </a:lnSpc>
-              <a:spcAft>
-                <a:spcPts val="1200"/>
-              </a:spcAft>
+            <a:pPr algn="l" marL="0" indent="0">
               <a:defRPr sz="1100" b="1">
                 <a:solidFill>
                   <a:srgbClr val="082952"/>
                 </a:solidFill>
                 <a:latin typeface="Inter"/>
               </a:defRPr>
+              <a:lnSpc>
+                <a:spcPct val="112000"/>
+              </a:lnSpc>
+              <a:spcAft>
+                <a:spcPts val="1200"/>
+              </a:spcAft>
+              <a:buNone/>
             </a:pPr>
             <a:r>
               <a:t>Plan B Foundation</a:t>
@@ -3912,19 +4001,20 @@
           </a:bodyPr>
           <a:lstStyle/>
           <a:p>
-            <a:pPr>
-              <a:lnSpc>
-                <a:spcPct val="112000"/>
-              </a:lnSpc>
-              <a:spcAft>
-                <a:spcPts val="1200"/>
-              </a:spcAft>
+            <a:pPr algn="l" marL="0" indent="0">
               <a:defRPr sz="1100" b="0">
                 <a:solidFill>
                   <a:srgbClr val="082952"/>
                 </a:solidFill>
                 <a:latin typeface="Inter"/>
               </a:defRPr>
+              <a:lnSpc>
+                <a:spcPct val="112000"/>
+              </a:lnSpc>
+              <a:spcAft>
+                <a:spcPts val="1200"/>
+              </a:spcAft>
+              <a:buNone/>
             </a:pPr>
             <a:r>
               <a:t>Civic Digital Commons</a:t>
@@ -3956,19 +4046,20 @@
           </a:bodyPr>
           <a:lstStyle/>
           <a:p>
-            <a:pPr>
-              <a:lnSpc>
-                <a:spcPct val="112000"/>
-              </a:lnSpc>
-              <a:spcAft>
-                <a:spcPts val="1200"/>
-              </a:spcAft>
+            <a:pPr algn="l" marL="0" indent="0">
               <a:defRPr sz="3600" b="1">
                 <a:solidFill>
                   <a:srgbClr val="082952"/>
                 </a:solidFill>
                 <a:latin typeface="Inter"/>
               </a:defRPr>
+              <a:lnSpc>
+                <a:spcPct val="112000"/>
+              </a:lnSpc>
+              <a:spcAft>
+                <a:spcPts val="1200"/>
+              </a:spcAft>
+              <a:buNone/>
             </a:pPr>
             <a:r>
               <a:t>[Say what the data shows]</a:t>
@@ -4000,19 +4091,20 @@
           </a:bodyPr>
           <a:lstStyle/>
           <a:p>
-            <a:pPr>
-              <a:lnSpc>
-                <a:spcPct val="112000"/>
-              </a:lnSpc>
-              <a:spcAft>
-                <a:spcPts val="1200"/>
-              </a:spcAft>
+            <a:pPr algn="l" marL="0" indent="0">
               <a:defRPr sz="1900" b="0">
                 <a:solidFill>
                   <a:srgbClr val="030B20"/>
                 </a:solidFill>
                 <a:latin typeface="Inter"/>
               </a:defRPr>
+              <a:lnSpc>
+                <a:spcPct val="112000"/>
+              </a:lnSpc>
+              <a:spcAft>
+                <a:spcPts val="1200"/>
+              </a:spcAft>
+              <a:buNone/>
             </a:pPr>
             <a:r>
               <a:t>[Unit, population and time period]</a:t>
@@ -4044,19 +4136,20 @@
           </a:bodyPr>
           <a:lstStyle/>
           <a:p>
-            <a:pPr>
-              <a:lnSpc>
-                <a:spcPct val="112000"/>
-              </a:lnSpc>
-              <a:spcAft>
-                <a:spcPts val="1200"/>
-              </a:spcAft>
+            <a:pPr algn="l" marL="0" indent="0">
               <a:defRPr sz="2200" b="0">
                 <a:solidFill>
                   <a:srgbClr val="082952"/>
                 </a:solidFill>
                 <a:latin typeface="Inter"/>
               </a:defRPr>
+              <a:lnSpc>
+                <a:spcPct val="112000"/>
+              </a:lnSpc>
+              <a:spcAft>
+                <a:spcPts val="1200"/>
+              </a:spcAft>
+              <a:buNone/>
             </a:pPr>
             <a:r>
               <a:t>[Insert chart]</a:t>
@@ -4088,19 +4181,20 @@
           </a:bodyPr>
           <a:lstStyle/>
           <a:p>
-            <a:pPr>
-              <a:lnSpc>
-                <a:spcPct val="112000"/>
-              </a:lnSpc>
-              <a:spcAft>
-                <a:spcPts val="1200"/>
-              </a:spcAft>
+            <a:pPr algn="l" marL="0" indent="0">
               <a:defRPr sz="2700" b="1">
                 <a:solidFill>
                   <a:srgbClr val="082952"/>
                 </a:solidFill>
                 <a:latin typeface="Inter"/>
               </a:defRPr>
+              <a:lnSpc>
+                <a:spcPct val="112000"/>
+              </a:lnSpc>
+              <a:spcAft>
+                <a:spcPts val="1200"/>
+              </a:spcAft>
+              <a:buNone/>
             </a:pPr>
             <a:r>
               <a:t>[The takeaway]</a:t>
@@ -4132,19 +4226,20 @@
           </a:bodyPr>
           <a:lstStyle/>
           <a:p>
-            <a:pPr>
-              <a:lnSpc>
-                <a:spcPct val="112000"/>
-              </a:lnSpc>
-              <a:spcAft>
-                <a:spcPts val="1200"/>
-              </a:spcAft>
+            <a:pPr algn="l" marL="0" indent="0">
               <a:defRPr sz="2200" b="0">
                 <a:solidFill>
                   <a:srgbClr val="030B20"/>
                 </a:solidFill>
                 <a:latin typeface="Inter"/>
               </a:defRPr>
+              <a:lnSpc>
+                <a:spcPct val="112000"/>
+              </a:lnSpc>
+              <a:spcAft>
+                <a:spcPts val="1200"/>
+              </a:spcAft>
+              <a:buNone/>
             </a:pPr>
             <a:r>
               <a:t>[Explain the implication and the limits of the evidence.]</a:t>
@@ -4176,19 +4271,20 @@
           </a:bodyPr>
           <a:lstStyle/>
           <a:p>
-            <a:pPr>
-              <a:lnSpc>
-                <a:spcPct val="112000"/>
-              </a:lnSpc>
-              <a:spcAft>
-                <a:spcPts val="1200"/>
-              </a:spcAft>
+            <a:pPr algn="l" marL="0" indent="0">
               <a:defRPr sz="1200" b="0">
                 <a:solidFill>
                   <a:srgbClr val="030B20"/>
                 </a:solidFill>
                 <a:latin typeface="Inter"/>
               </a:defRPr>
+              <a:lnSpc>
+                <a:spcPct val="112000"/>
+              </a:lnSpc>
+              <a:spcAft>
+                <a:spcPts val="1200"/>
+              </a:spcAft>
+              <a:buNone/>
             </a:pPr>
             <a:r>
               <a:t>ILLUSTRATIVE DATA ONLY · Replace values and add a source before presenting.</a:t>
@@ -4210,7 +4306,7 @@
 </file>
 
 <file path=ppt/slideLayouts/slideLayout7.xml><?xml version="1.0" encoding="utf-8"?>
-<p:sldLayout xmlns:a="http://schemas.openxmlformats.org/drawingml/2006/main" xmlns:r="http://schemas.openxmlformats.org/officeDocument/2006/relationships" xmlns:p="http://schemas.openxmlformats.org/presentationml/2006/main" type="cust" preserve="1" showMasterSp="0">
+<p:sldLayout xmlns:a="http://schemas.openxmlformats.org/drawingml/2006/main" xmlns:r="http://schemas.openxmlformats.org/officeDocument/2006/relationships" xmlns:p="http://schemas.openxmlformats.org/presentationml/2006/main" type="cust" preserve="1" showMasterSp="1">
   <p:cSld name="Plan B / Table">
     <p:bg>
       <p:bgPr>
@@ -4256,19 +4352,20 @@
           </a:bodyPr>
           <a:lstStyle/>
           <a:p>
-            <a:pPr>
-              <a:lnSpc>
-                <a:spcPct val="112000"/>
-              </a:lnSpc>
-              <a:spcAft>
-                <a:spcPts val="1200"/>
-              </a:spcAft>
+            <a:pPr algn="l" marL="0" indent="0">
               <a:defRPr sz="1100" b="1">
                 <a:solidFill>
                   <a:srgbClr val="082952"/>
                 </a:solidFill>
                 <a:latin typeface="Inter"/>
               </a:defRPr>
+              <a:lnSpc>
+                <a:spcPct val="112000"/>
+              </a:lnSpc>
+              <a:spcAft>
+                <a:spcPts val="1200"/>
+              </a:spcAft>
+              <a:buNone/>
             </a:pPr>
             <a:r>
               <a:t>Plan B Foundation</a:t>
@@ -4298,19 +4395,20 @@
           </a:bodyPr>
           <a:lstStyle/>
           <a:p>
-            <a:pPr>
-              <a:lnSpc>
-                <a:spcPct val="112000"/>
-              </a:lnSpc>
-              <a:spcAft>
-                <a:spcPts val="1200"/>
-              </a:spcAft>
+            <a:pPr algn="l" marL="0" indent="0">
               <a:defRPr sz="1100" b="0">
                 <a:solidFill>
                   <a:srgbClr val="082952"/>
                 </a:solidFill>
                 <a:latin typeface="Inter"/>
               </a:defRPr>
+              <a:lnSpc>
+                <a:spcPct val="112000"/>
+              </a:lnSpc>
+              <a:spcAft>
+                <a:spcPts val="1200"/>
+              </a:spcAft>
+              <a:buNone/>
             </a:pPr>
             <a:r>
               <a:t>Civic Digital Commons</a:t>
@@ -4342,19 +4440,20 @@
           </a:bodyPr>
           <a:lstStyle/>
           <a:p>
-            <a:pPr>
-              <a:lnSpc>
-                <a:spcPct val="112000"/>
-              </a:lnSpc>
-              <a:spcAft>
-                <a:spcPts val="1200"/>
-              </a:spcAft>
+            <a:pPr algn="l" marL="0" indent="0">
               <a:defRPr sz="3600" b="1">
                 <a:solidFill>
                   <a:srgbClr val="082952"/>
                 </a:solidFill>
                 <a:latin typeface="Inter"/>
               </a:defRPr>
+              <a:lnSpc>
+                <a:spcPct val="112000"/>
+              </a:lnSpc>
+              <a:spcAft>
+                <a:spcPts val="1200"/>
+              </a:spcAft>
+              <a:buNone/>
             </a:pPr>
             <a:r>
               <a:t>[Make a decision easier]</a:t>
@@ -4386,19 +4485,20 @@
           </a:bodyPr>
           <a:lstStyle/>
           <a:p>
-            <a:pPr>
-              <a:lnSpc>
-                <a:spcPct val="112000"/>
-              </a:lnSpc>
-              <a:spcAft>
-                <a:spcPts val="1200"/>
-              </a:spcAft>
+            <a:pPr algn="l" marL="0" indent="0">
               <a:defRPr sz="1900" b="0">
                 <a:solidFill>
                   <a:srgbClr val="030B20"/>
                 </a:solidFill>
                 <a:latin typeface="Inter"/>
               </a:defRPr>
+              <a:lnSpc>
+                <a:spcPct val="112000"/>
+              </a:lnSpc>
+              <a:spcAft>
+                <a:spcPts val="1200"/>
+              </a:spcAft>
+              <a:buNone/>
             </a:pPr>
             <a:r>
               <a:t>[Explain what the comparison includes]</a:t>
@@ -4430,19 +4530,20 @@
           </a:bodyPr>
           <a:lstStyle/>
           <a:p>
-            <a:pPr>
-              <a:lnSpc>
-                <a:spcPct val="112000"/>
-              </a:lnSpc>
-              <a:spcAft>
-                <a:spcPts val="1200"/>
-              </a:spcAft>
+            <a:pPr algn="l" marL="0" indent="0">
               <a:defRPr sz="2200" b="0">
                 <a:solidFill>
                   <a:srgbClr val="082952"/>
                 </a:solidFill>
                 <a:latin typeface="Inter"/>
               </a:defRPr>
+              <a:lnSpc>
+                <a:spcPct val="112000"/>
+              </a:lnSpc>
+              <a:spcAft>
+                <a:spcPts val="1200"/>
+              </a:spcAft>
+              <a:buNone/>
             </a:pPr>
             <a:r>
               <a:t>[Insert table]</a:t>
@@ -4474,19 +4575,20 @@
           </a:bodyPr>
           <a:lstStyle/>
           <a:p>
-            <a:pPr>
-              <a:lnSpc>
-                <a:spcPct val="112000"/>
-              </a:lnSpc>
-              <a:spcAft>
-                <a:spcPts val="1200"/>
-              </a:spcAft>
+            <a:pPr algn="l" marL="0" indent="0">
               <a:defRPr sz="1300" b="0">
                 <a:solidFill>
                   <a:srgbClr val="030B20"/>
                 </a:solidFill>
                 <a:latin typeface="Inter"/>
               </a:defRPr>
+              <a:lnSpc>
+                <a:spcPct val="112000"/>
+              </a:lnSpc>
+              <a:spcAft>
+                <a:spcPts val="1200"/>
+              </a:spcAft>
+              <a:buNone/>
             </a:pPr>
             <a:r>
               <a:t>[Source / definitions / caveat]</a:t>
@@ -4508,7 +4610,7 @@
 </file>
 
 <file path=ppt/slideLayouts/slideLayout8.xml><?xml version="1.0" encoding="utf-8"?>
-<p:sldLayout xmlns:a="http://schemas.openxmlformats.org/drawingml/2006/main" xmlns:r="http://schemas.openxmlformats.org/officeDocument/2006/relationships" xmlns:p="http://schemas.openxmlformats.org/presentationml/2006/main" type="cust" preserve="1" showMasterSp="0">
+<p:sldLayout xmlns:a="http://schemas.openxmlformats.org/drawingml/2006/main" xmlns:r="http://schemas.openxmlformats.org/officeDocument/2006/relationships" xmlns:p="http://schemas.openxmlformats.org/presentationml/2006/main" type="cust" preserve="1" showMasterSp="1">
   <p:cSld name="Plan B / Quotation">
     <p:bg>
       <p:bgPr>
@@ -4554,19 +4656,20 @@
           </a:bodyPr>
           <a:lstStyle/>
           <a:p>
-            <a:pPr>
-              <a:lnSpc>
-                <a:spcPct val="112000"/>
-              </a:lnSpc>
-              <a:spcAft>
-                <a:spcPts val="1200"/>
-              </a:spcAft>
+            <a:pPr algn="l" marL="0" indent="0">
               <a:defRPr sz="1100" b="1">
                 <a:solidFill>
                   <a:srgbClr val="082952"/>
                 </a:solidFill>
                 <a:latin typeface="Inter"/>
               </a:defRPr>
+              <a:lnSpc>
+                <a:spcPct val="112000"/>
+              </a:lnSpc>
+              <a:spcAft>
+                <a:spcPts val="1200"/>
+              </a:spcAft>
+              <a:buNone/>
             </a:pPr>
             <a:r>
               <a:t>Plan B Foundation</a:t>
@@ -4596,19 +4699,20 @@
           </a:bodyPr>
           <a:lstStyle/>
           <a:p>
-            <a:pPr>
-              <a:lnSpc>
-                <a:spcPct val="112000"/>
-              </a:lnSpc>
-              <a:spcAft>
-                <a:spcPts val="1200"/>
-              </a:spcAft>
+            <a:pPr algn="l" marL="0" indent="0">
               <a:defRPr sz="1100" b="0">
                 <a:solidFill>
                   <a:srgbClr val="082952"/>
                 </a:solidFill>
                 <a:latin typeface="Inter"/>
               </a:defRPr>
+              <a:lnSpc>
+                <a:spcPct val="112000"/>
+              </a:lnSpc>
+              <a:spcAft>
+                <a:spcPts val="1200"/>
+              </a:spcAft>
+              <a:buNone/>
             </a:pPr>
             <a:r>
               <a:t>Civic Digital Commons</a:t>
@@ -4640,38 +4744,40 @@
           </a:bodyPr>
           <a:lstStyle/>
           <a:p>
-            <a:pPr>
-              <a:lnSpc>
-                <a:spcPct val="112000"/>
-              </a:lnSpc>
-              <a:spcAft>
-                <a:spcPts val="1200"/>
-              </a:spcAft>
+            <a:pPr algn="l" marL="0" indent="0">
               <a:defRPr sz="4200" b="1">
                 <a:solidFill>
                   <a:srgbClr val="082952"/>
                 </a:solidFill>
                 <a:latin typeface="Inter"/>
               </a:defRPr>
+              <a:lnSpc>
+                <a:spcPct val="112000"/>
+              </a:lnSpc>
+              <a:spcAft>
+                <a:spcPts val="1200"/>
+              </a:spcAft>
+              <a:buNone/>
             </a:pPr>
             <a:r>
               <a:t>[A short quotation,</a:t>
             </a:r>
           </a:p>
           <a:p>
-            <a:pPr>
-              <a:lnSpc>
-                <a:spcPct val="112000"/>
-              </a:lnSpc>
-              <a:spcAft>
-                <a:spcPts val="1200"/>
-              </a:spcAft>
+            <a:pPr algn="l" marL="0" indent="0">
               <a:defRPr sz="4200" b="1">
                 <a:solidFill>
                   <a:srgbClr val="082952"/>
                 </a:solidFill>
                 <a:latin typeface="Inter"/>
               </a:defRPr>
+              <a:lnSpc>
+                <a:spcPct val="112000"/>
+              </a:lnSpc>
+              <a:spcAft>
+                <a:spcPts val="1200"/>
+              </a:spcAft>
+              <a:buNone/>
             </a:pPr>
             <a:r>
               <a:t>accurately attributed.]</a:t>
@@ -4703,38 +4809,40 @@
           </a:bodyPr>
           <a:lstStyle/>
           <a:p>
-            <a:pPr>
-              <a:lnSpc>
-                <a:spcPct val="112000"/>
-              </a:lnSpc>
-              <a:spcAft>
-                <a:spcPts val="1200"/>
-              </a:spcAft>
+            <a:pPr algn="l" marL="0" indent="0">
               <a:defRPr sz="2000" b="0">
                 <a:solidFill>
                   <a:srgbClr val="030B20"/>
                 </a:solidFill>
                 <a:latin typeface="Inter"/>
               </a:defRPr>
+              <a:lnSpc>
+                <a:spcPct val="112000"/>
+              </a:lnSpc>
+              <a:spcAft>
+                <a:spcPts val="1200"/>
+              </a:spcAft>
+              <a:buNone/>
             </a:pPr>
             <a:r>
               <a:t>[Speaker / role]</a:t>
             </a:r>
           </a:p>
           <a:p>
-            <a:pPr>
-              <a:lnSpc>
-                <a:spcPct val="112000"/>
-              </a:lnSpc>
-              <a:spcAft>
-                <a:spcPts val="1200"/>
-              </a:spcAft>
+            <a:pPr algn="l" marL="0" indent="0">
               <a:defRPr sz="2000" b="0">
                 <a:solidFill>
                   <a:srgbClr val="030B20"/>
                 </a:solidFill>
                 <a:latin typeface="Inter"/>
               </a:defRPr>
+              <a:lnSpc>
+                <a:spcPct val="112000"/>
+              </a:lnSpc>
+              <a:spcAft>
+                <a:spcPts val="1200"/>
+              </a:spcAft>
+              <a:buNone/>
             </a:pPr>
             <a:r>
               <a:t>[Source · date]</a:t>
@@ -4799,7 +4907,7 @@
 </file>
 
 <file path=ppt/slideLayouts/slideLayout9.xml><?xml version="1.0" encoding="utf-8"?>
-<p:sldLayout xmlns:a="http://schemas.openxmlformats.org/drawingml/2006/main" xmlns:r="http://schemas.openxmlformats.org/officeDocument/2006/relationships" xmlns:p="http://schemas.openxmlformats.org/presentationml/2006/main" type="cust" preserve="1" showMasterSp="0">
+<p:sldLayout xmlns:a="http://schemas.openxmlformats.org/drawingml/2006/main" xmlns:r="http://schemas.openxmlformats.org/officeDocument/2006/relationships" xmlns:p="http://schemas.openxmlformats.org/presentationml/2006/main" type="cust" preserve="1" showMasterSp="1">
   <p:cSld name="Plan B / Next steps">
     <p:bg>
       <p:bgPr>
@@ -4845,19 +4953,20 @@
           </a:bodyPr>
           <a:lstStyle/>
           <a:p>
-            <a:pPr>
-              <a:lnSpc>
-                <a:spcPct val="112000"/>
-              </a:lnSpc>
-              <a:spcAft>
-                <a:spcPts val="1200"/>
-              </a:spcAft>
+            <a:pPr algn="l" marL="0" indent="0">
               <a:defRPr sz="1100" b="1">
                 <a:solidFill>
                   <a:srgbClr val="082952"/>
                 </a:solidFill>
                 <a:latin typeface="Inter"/>
               </a:defRPr>
+              <a:lnSpc>
+                <a:spcPct val="112000"/>
+              </a:lnSpc>
+              <a:spcAft>
+                <a:spcPts val="1200"/>
+              </a:spcAft>
+              <a:buNone/>
             </a:pPr>
             <a:r>
               <a:t>Plan B Foundation</a:t>
@@ -4887,19 +4996,20 @@
           </a:bodyPr>
           <a:lstStyle/>
           <a:p>
-            <a:pPr>
-              <a:lnSpc>
-                <a:spcPct val="112000"/>
-              </a:lnSpc>
-              <a:spcAft>
-                <a:spcPts val="1200"/>
-              </a:spcAft>
+            <a:pPr algn="l" marL="0" indent="0">
               <a:defRPr sz="1100" b="0">
                 <a:solidFill>
                   <a:srgbClr val="082952"/>
                 </a:solidFill>
                 <a:latin typeface="Inter"/>
               </a:defRPr>
+              <a:lnSpc>
+                <a:spcPct val="112000"/>
+              </a:lnSpc>
+              <a:spcAft>
+                <a:spcPts val="1200"/>
+              </a:spcAft>
+              <a:buNone/>
             </a:pPr>
             <a:r>
               <a:t>Civic Digital Commons</a:t>
@@ -4931,19 +5041,20 @@
           </a:bodyPr>
           <a:lstStyle/>
           <a:p>
-            <a:pPr>
-              <a:lnSpc>
-                <a:spcPct val="112000"/>
-              </a:lnSpc>
-              <a:spcAft>
-                <a:spcPts val="1200"/>
-              </a:spcAft>
+            <a:pPr algn="l" marL="0" indent="0">
               <a:defRPr sz="3600" b="1">
                 <a:solidFill>
                   <a:srgbClr val="082952"/>
                 </a:solidFill>
                 <a:latin typeface="Inter"/>
               </a:defRPr>
+              <a:lnSpc>
+                <a:spcPct val="112000"/>
+              </a:lnSpc>
+              <a:spcAft>
+                <a:spcPts val="1200"/>
+              </a:spcAft>
+              <a:buNone/>
             </a:pPr>
             <a:r>
               <a:t>[What happens next?]</a:t>
@@ -4975,19 +5086,20 @@
           </a:bodyPr>
           <a:lstStyle/>
           <a:p>
-            <a:pPr>
-              <a:lnSpc>
-                <a:spcPct val="112000"/>
-              </a:lnSpc>
-              <a:spcAft>
-                <a:spcPts val="1200"/>
-              </a:spcAft>
+            <a:pPr algn="l" marL="0" indent="0">
               <a:defRPr sz="2800" b="1">
                 <a:solidFill>
                   <a:srgbClr val="082952"/>
                 </a:solidFill>
                 <a:latin typeface="Inter"/>
               </a:defRPr>
+              <a:lnSpc>
+                <a:spcPct val="112000"/>
+              </a:lnSpc>
+              <a:spcAft>
+                <a:spcPts val="1200"/>
+              </a:spcAft>
+              <a:buNone/>
             </a:pPr>
             <a:r>
               <a:t>[Learn]</a:t>
@@ -5019,38 +5131,40 @@
           </a:bodyPr>
           <a:lstStyle/>
           <a:p>
-            <a:pPr>
-              <a:lnSpc>
-                <a:spcPct val="112000"/>
-              </a:lnSpc>
-              <a:spcAft>
-                <a:spcPts val="1200"/>
-              </a:spcAft>
+            <a:pPr algn="l" marL="0" indent="0">
               <a:defRPr sz="2300" b="0">
                 <a:solidFill>
                   <a:srgbClr val="030B20"/>
                 </a:solidFill>
                 <a:latin typeface="Inter"/>
               </a:defRPr>
+              <a:lnSpc>
+                <a:spcPct val="112000"/>
+              </a:lnSpc>
+              <a:spcAft>
+                <a:spcPts val="1200"/>
+              </a:spcAft>
+              <a:buNone/>
             </a:pPr>
             <a:r>
               <a:t>[Concrete next action]</a:t>
             </a:r>
           </a:p>
           <a:p>
-            <a:pPr>
-              <a:lnSpc>
-                <a:spcPct val="112000"/>
-              </a:lnSpc>
-              <a:spcAft>
-                <a:spcPts val="1200"/>
-              </a:spcAft>
+            <a:pPr algn="l" marL="0" indent="0">
               <a:defRPr sz="2300" b="0">
                 <a:solidFill>
                   <a:srgbClr val="030B20"/>
                 </a:solidFill>
                 <a:latin typeface="Inter"/>
               </a:defRPr>
+              <a:lnSpc>
+                <a:spcPct val="112000"/>
+              </a:lnSpc>
+              <a:spcAft>
+                <a:spcPts val="1200"/>
+              </a:spcAft>
+              <a:buNone/>
             </a:pPr>
             <a:r>
               <a:t>[Owner · timing]</a:t>
@@ -5082,19 +5196,20 @@
           </a:bodyPr>
           <a:lstStyle/>
           <a:p>
-            <a:pPr>
-              <a:lnSpc>
-                <a:spcPct val="112000"/>
-              </a:lnSpc>
-              <a:spcAft>
-                <a:spcPts val="1200"/>
-              </a:spcAft>
+            <a:pPr algn="l" marL="0" indent="0">
               <a:defRPr sz="2800" b="1">
                 <a:solidFill>
                   <a:srgbClr val="082952"/>
                 </a:solidFill>
                 <a:latin typeface="Inter"/>
               </a:defRPr>
+              <a:lnSpc>
+                <a:spcPct val="112000"/>
+              </a:lnSpc>
+              <a:spcAft>
+                <a:spcPts val="1200"/>
+              </a:spcAft>
+              <a:buNone/>
             </a:pPr>
             <a:r>
               <a:t>[Test]</a:t>
@@ -5126,38 +5241,40 @@
           </a:bodyPr>
           <a:lstStyle/>
           <a:p>
-            <a:pPr>
-              <a:lnSpc>
-                <a:spcPct val="112000"/>
-              </a:lnSpc>
-              <a:spcAft>
-                <a:spcPts val="1200"/>
-              </a:spcAft>
+            <a:pPr algn="l" marL="0" indent="0">
               <a:defRPr sz="2300" b="0">
                 <a:solidFill>
                   <a:srgbClr val="030B20"/>
                 </a:solidFill>
                 <a:latin typeface="Inter"/>
               </a:defRPr>
+              <a:lnSpc>
+                <a:spcPct val="112000"/>
+              </a:lnSpc>
+              <a:spcAft>
+                <a:spcPts val="1200"/>
+              </a:spcAft>
+              <a:buNone/>
             </a:pPr>
             <a:r>
               <a:t>[Concrete next action]</a:t>
             </a:r>
           </a:p>
           <a:p>
-            <a:pPr>
-              <a:lnSpc>
-                <a:spcPct val="112000"/>
-              </a:lnSpc>
-              <a:spcAft>
-                <a:spcPts val="1200"/>
-              </a:spcAft>
+            <a:pPr algn="l" marL="0" indent="0">
               <a:defRPr sz="2300" b="0">
                 <a:solidFill>
                   <a:srgbClr val="030B20"/>
                 </a:solidFill>
                 <a:latin typeface="Inter"/>
               </a:defRPr>
+              <a:lnSpc>
+                <a:spcPct val="112000"/>
+              </a:lnSpc>
+              <a:spcAft>
+                <a:spcPts val="1200"/>
+              </a:spcAft>
+              <a:buNone/>
             </a:pPr>
             <a:r>
               <a:t>[Owner · timing]</a:t>
@@ -5189,19 +5306,20 @@
           </a:bodyPr>
           <a:lstStyle/>
           <a:p>
-            <a:pPr>
-              <a:lnSpc>
-                <a:spcPct val="112000"/>
-              </a:lnSpc>
-              <a:spcAft>
-                <a:spcPts val="1200"/>
-              </a:spcAft>
+            <a:pPr algn="l" marL="0" indent="0">
               <a:defRPr sz="2800" b="1">
                 <a:solidFill>
                   <a:srgbClr val="082952"/>
                 </a:solidFill>
                 <a:latin typeface="Inter"/>
               </a:defRPr>
+              <a:lnSpc>
+                <a:spcPct val="112000"/>
+              </a:lnSpc>
+              <a:spcAft>
+                <a:spcPts val="1200"/>
+              </a:spcAft>
+              <a:buNone/>
             </a:pPr>
             <a:r>
               <a:t>[Contribute]</a:t>
@@ -5233,38 +5351,40 @@
           </a:bodyPr>
           <a:lstStyle/>
           <a:p>
-            <a:pPr>
-              <a:lnSpc>
-                <a:spcPct val="112000"/>
-              </a:lnSpc>
-              <a:spcAft>
-                <a:spcPts val="1200"/>
-              </a:spcAft>
+            <a:pPr algn="l" marL="0" indent="0">
               <a:defRPr sz="2300" b="0">
                 <a:solidFill>
                   <a:srgbClr val="030B20"/>
                 </a:solidFill>
                 <a:latin typeface="Inter"/>
               </a:defRPr>
+              <a:lnSpc>
+                <a:spcPct val="112000"/>
+              </a:lnSpc>
+              <a:spcAft>
+                <a:spcPts val="1200"/>
+              </a:spcAft>
+              <a:buNone/>
             </a:pPr>
             <a:r>
               <a:t>[Concrete next action]</a:t>
             </a:r>
           </a:p>
           <a:p>
-            <a:pPr>
-              <a:lnSpc>
-                <a:spcPct val="112000"/>
-              </a:lnSpc>
-              <a:spcAft>
-                <a:spcPts val="1200"/>
-              </a:spcAft>
+            <a:pPr algn="l" marL="0" indent="0">
               <a:defRPr sz="2300" b="0">
                 <a:solidFill>
                   <a:srgbClr val="030B20"/>
                 </a:solidFill>
                 <a:latin typeface="Inter"/>
               </a:defRPr>
+              <a:lnSpc>
+                <a:spcPct val="112000"/>
+              </a:lnSpc>
+              <a:spcAft>
+                <a:spcPts val="1200"/>
+              </a:spcAft>
+              <a:buNone/>
             </a:pPr>
             <a:r>
               <a:t>[Owner · timing]</a:t>
@@ -5296,19 +5416,20 @@
           </a:bodyPr>
           <a:lstStyle/>
           <a:p>
-            <a:pPr>
-              <a:lnSpc>
-                <a:spcPct val="112000"/>
-              </a:lnSpc>
-              <a:spcAft>
-                <a:spcPts val="1200"/>
-              </a:spcAft>
+            <a:pPr algn="l" marL="0" indent="0">
               <a:defRPr sz="1900" b="0">
                 <a:solidFill>
                   <a:srgbClr val="082952"/>
                 </a:solidFill>
                 <a:latin typeface="Inter"/>
               </a:defRPr>
+              <a:lnSpc>
+                <a:spcPct val="112000"/>
+              </a:lnSpc>
+              <a:spcAft>
+                <a:spcPts val="1200"/>
+              </a:spcAft>
+              <a:buNone/>
             </a:pPr>
             <a:r>
               <a:t>[Contact / project URL]</a:t>
@@ -5351,220 +5472,6 @@
           <a:chExt cx="0" cy="0"/>
         </a:xfrm>
       </p:grpSpPr>
-      <p:sp>
-        <p:nvSpPr>
-          <p:cNvPr id="2" name="Title Placeholder 1"/>
-          <p:cNvSpPr>
-            <a:spLocks noGrp="1"/>
-          </p:cNvSpPr>
-          <p:nvPr>
-            <p:ph type="title"/>
-          </p:nvPr>
-        </p:nvSpPr>
-        <p:spPr>
-          <a:xfrm>
-            <a:off x="457200" y="274638"/>
-            <a:ext cx="8229600" cy="1143000"/>
-          </a:xfrm>
-          <a:prstGeom prst="rect">
-            <a:avLst/>
-          </a:prstGeom>
-        </p:spPr>
-        <p:txBody>
-          <a:bodyPr vert="horz" lIns="91440" tIns="45720" rIns="91440" bIns="45720" rtlCol="0" anchor="ctr">
-            <a:normAutofit/>
-          </a:bodyPr>
-          <a:lstStyle/>
-          <a:p>
-            <a:r>
-              <a:rPr lang="en-US" smtClean="0"/>
-              <a:t>Click to edit Master title style</a:t>
-            </a:r>
-            <a:endParaRPr lang="en-US"/>
-          </a:p>
-        </p:txBody>
-      </p:sp>
-      <p:sp>
-        <p:nvSpPr>
-          <p:cNvPr id="3" name="Text Placeholder 2"/>
-          <p:cNvSpPr>
-            <a:spLocks noGrp="1"/>
-          </p:cNvSpPr>
-          <p:nvPr>
-            <p:ph type="body" idx="1"/>
-          </p:nvPr>
-        </p:nvSpPr>
-        <p:spPr>
-          <a:xfrm>
-            <a:off x="457200" y="1600200"/>
-            <a:ext cx="8229600" cy="4525963"/>
-          </a:xfrm>
-          <a:prstGeom prst="rect">
-            <a:avLst/>
-          </a:prstGeom>
-        </p:spPr>
-        <p:txBody>
-          <a:bodyPr vert="horz" lIns="91440" tIns="45720" rIns="91440" bIns="45720" rtlCol="0">
-            <a:normAutofit/>
-          </a:bodyPr>
-          <a:lstStyle/>
-          <a:p>
-            <a:pPr lvl="0"/>
-            <a:r>
-              <a:rPr lang="en-US" smtClean="0"/>
-              <a:t>Click to edit Master text styles</a:t>
-            </a:r>
-          </a:p>
-          <a:p>
-            <a:pPr lvl="1"/>
-            <a:r>
-              <a:rPr lang="en-US" smtClean="0"/>
-              <a:t>Second level</a:t>
-            </a:r>
-          </a:p>
-          <a:p>
-            <a:pPr lvl="2"/>
-            <a:r>
-              <a:rPr lang="en-US" smtClean="0"/>
-              <a:t>Third level</a:t>
-            </a:r>
-          </a:p>
-          <a:p>
-            <a:pPr lvl="3"/>
-            <a:r>
-              <a:rPr lang="en-US" smtClean="0"/>
-              <a:t>Fourth level</a:t>
-            </a:r>
-          </a:p>
-          <a:p>
-            <a:pPr lvl="4"/>
-            <a:r>
-              <a:rPr lang="en-US" smtClean="0"/>
-              <a:t>Fifth level</a:t>
-            </a:r>
-            <a:endParaRPr lang="en-US"/>
-          </a:p>
-        </p:txBody>
-      </p:sp>
-      <p:sp>
-        <p:nvSpPr>
-          <p:cNvPr id="4" name="Date Placeholder 3"/>
-          <p:cNvSpPr>
-            <a:spLocks noGrp="1"/>
-          </p:cNvSpPr>
-          <p:nvPr>
-            <p:ph type="dt" sz="half" idx="2"/>
-          </p:nvPr>
-        </p:nvSpPr>
-        <p:spPr>
-          <a:xfrm>
-            <a:off x="457200" y="6356350"/>
-            <a:ext cx="2133600" cy="365125"/>
-          </a:xfrm>
-          <a:prstGeom prst="rect">
-            <a:avLst/>
-          </a:prstGeom>
-        </p:spPr>
-        <p:txBody>
-          <a:bodyPr vert="horz" lIns="91440" tIns="45720" rIns="91440" bIns="45720" rtlCol="0" anchor="ctr"/>
-          <a:lstStyle>
-            <a:lvl1pPr algn="l">
-              <a:defRPr sz="1200">
-                <a:solidFill>
-                  <a:schemeClr val="tx1">
-                    <a:tint val="75000"/>
-                  </a:schemeClr>
-                </a:solidFill>
-              </a:defRPr>
-            </a:lvl1pPr>
-          </a:lstStyle>
-          <a:p>
-            <a:fld id="{5BCAD085-E8A6-8845-BD4E-CB4CCA059FC4}" type="datetimeFigureOut">
-              <a:rPr lang="en-US" smtClean="0"/>
-              <a:t>1/27/13</a:t>
-            </a:fld>
-            <a:endParaRPr lang="en-US"/>
-          </a:p>
-        </p:txBody>
-      </p:sp>
-      <p:sp>
-        <p:nvSpPr>
-          <p:cNvPr id="5" name="Footer Placeholder 4"/>
-          <p:cNvSpPr>
-            <a:spLocks noGrp="1"/>
-          </p:cNvSpPr>
-          <p:nvPr>
-            <p:ph type="ftr" sz="quarter" idx="3"/>
-          </p:nvPr>
-        </p:nvSpPr>
-        <p:spPr>
-          <a:xfrm>
-            <a:off x="3124200" y="6356350"/>
-            <a:ext cx="2895600" cy="365125"/>
-          </a:xfrm>
-          <a:prstGeom prst="rect">
-            <a:avLst/>
-          </a:prstGeom>
-        </p:spPr>
-        <p:txBody>
-          <a:bodyPr vert="horz" lIns="91440" tIns="45720" rIns="91440" bIns="45720" rtlCol="0" anchor="ctr"/>
-          <a:lstStyle>
-            <a:lvl1pPr algn="ctr">
-              <a:defRPr sz="1200">
-                <a:solidFill>
-                  <a:schemeClr val="tx1">
-                    <a:tint val="75000"/>
-                  </a:schemeClr>
-                </a:solidFill>
-              </a:defRPr>
-            </a:lvl1pPr>
-          </a:lstStyle>
-          <a:p>
-            <a:endParaRPr lang="en-US"/>
-          </a:p>
-        </p:txBody>
-      </p:sp>
-      <p:sp>
-        <p:nvSpPr>
-          <p:cNvPr id="6" name="Slide Number Placeholder 5"/>
-          <p:cNvSpPr>
-            <a:spLocks noGrp="1"/>
-          </p:cNvSpPr>
-          <p:nvPr>
-            <p:ph type="sldNum" sz="quarter" idx="4"/>
-          </p:nvPr>
-        </p:nvSpPr>
-        <p:spPr>
-          <a:xfrm>
-            <a:off x="6553200" y="6356350"/>
-            <a:ext cx="2133600" cy="365125"/>
-          </a:xfrm>
-          <a:prstGeom prst="rect">
-            <a:avLst/>
-          </a:prstGeom>
-        </p:spPr>
-        <p:txBody>
-          <a:bodyPr vert="horz" lIns="91440" tIns="45720" rIns="91440" bIns="45720" rtlCol="0" anchor="ctr"/>
-          <a:lstStyle>
-            <a:lvl1pPr algn="r">
-              <a:defRPr sz="1200">
-                <a:solidFill>
-                  <a:schemeClr val="tx1">
-                    <a:tint val="75000"/>
-                  </a:schemeClr>
-                </a:solidFill>
-              </a:defRPr>
-            </a:lvl1pPr>
-          </a:lstStyle>
-          <a:p>
-            <a:fld id="{C1FF6DA9-008F-8B48-92A6-B652298478BF}" type="slidenum">
-              <a:rPr lang="en-US" smtClean="0"/>
-              <a:t>‹#›</a:t>
-            </a:fld>
-            <a:endParaRPr lang="en-US"/>
-          </a:p>
-        </p:txBody>
-      </p:sp>
     </p:spTree>
     <p:extLst>
       <p:ext uri="{BB962C8B-B14F-4D97-AF65-F5344CB8AC3E}">
@@ -5840,7 +5747,7 @@
 </file>
 
 <file path=ppt/slides/slide1.xml><?xml version="1.0" encoding="utf-8"?>
-<p:sld xmlns:a="http://schemas.openxmlformats.org/drawingml/2006/main" xmlns:p="http://schemas.openxmlformats.org/presentationml/2006/main" xmlns:r="http://schemas.openxmlformats.org/officeDocument/2006/relationships" showMasterSp="0">
+<p:sld xmlns:a="http://schemas.openxmlformats.org/drawingml/2006/main" xmlns:p="http://schemas.openxmlformats.org/presentationml/2006/main" xmlns:r="http://schemas.openxmlformats.org/officeDocument/2006/relationships" showMasterSp="1">
   <p:cSld>
     <p:bg>
       <p:bgPr>
@@ -5881,38 +5788,40 @@
           </a:bodyPr>
           <a:lstStyle/>
           <a:p>
-            <a:pPr>
-              <a:lnSpc>
-                <a:spcPct val="112000"/>
-              </a:lnSpc>
-              <a:spcAft>
-                <a:spcPts val="1200"/>
-              </a:spcAft>
+            <a:pPr algn="l" marL="0" indent="0">
               <a:defRPr sz="4800" b="1">
                 <a:solidFill>
                   <a:srgbClr val="082952"/>
                 </a:solidFill>
                 <a:latin typeface="Inter"/>
               </a:defRPr>
+              <a:lnSpc>
+                <a:spcPct val="112000"/>
+              </a:lnSpc>
+              <a:spcAft>
+                <a:spcPts val="1200"/>
+              </a:spcAft>
+              <a:buNone/>
             </a:pPr>
             <a:r>
               <a:t>[Presentation</a:t>
             </a:r>
           </a:p>
           <a:p>
-            <a:pPr>
-              <a:lnSpc>
-                <a:spcPct val="112000"/>
-              </a:lnSpc>
-              <a:spcAft>
-                <a:spcPts val="1200"/>
-              </a:spcAft>
+            <a:pPr algn="l" marL="0" indent="0">
               <a:defRPr sz="4800" b="1">
                 <a:solidFill>
                   <a:srgbClr val="082952"/>
                 </a:solidFill>
                 <a:latin typeface="Inter"/>
               </a:defRPr>
+              <a:lnSpc>
+                <a:spcPct val="112000"/>
+              </a:lnSpc>
+              <a:spcAft>
+                <a:spcPts val="1200"/>
+              </a:spcAft>
+              <a:buNone/>
             </a:pPr>
             <a:r>
               <a:t>title]</a:t>
@@ -5944,19 +5853,20 @@
           </a:bodyPr>
           <a:lstStyle/>
           <a:p>
-            <a:pPr>
-              <a:lnSpc>
-                <a:spcPct val="112000"/>
-              </a:lnSpc>
-              <a:spcAft>
-                <a:spcPts val="1200"/>
-              </a:spcAft>
+            <a:pPr algn="l" marL="0" indent="0">
               <a:defRPr sz="2400" b="0">
                 <a:solidFill>
                   <a:srgbClr val="030B20"/>
                 </a:solidFill>
                 <a:latin typeface="Inter"/>
               </a:defRPr>
+              <a:lnSpc>
+                <a:spcPct val="112000"/>
+              </a:lnSpc>
+              <a:spcAft>
+                <a:spcPts val="1200"/>
+              </a:spcAft>
+              <a:buNone/>
             </a:pPr>
             <a:r>
               <a:t>[A clear sentence about the civic purpose]</a:t>
@@ -5988,38 +5898,40 @@
           </a:bodyPr>
           <a:lstStyle/>
           <a:p>
-            <a:pPr>
-              <a:lnSpc>
-                <a:spcPct val="112000"/>
-              </a:lnSpc>
-              <a:spcAft>
-                <a:spcPts val="1200"/>
-              </a:spcAft>
+            <a:pPr algn="l" marL="0" indent="0">
               <a:defRPr sz="1700" b="0">
                 <a:solidFill>
                   <a:srgbClr val="030B20"/>
                 </a:solidFill>
                 <a:latin typeface="Inter"/>
               </a:defRPr>
+              <a:lnSpc>
+                <a:spcPct val="112000"/>
+              </a:lnSpc>
+              <a:spcAft>
+                <a:spcPts val="1200"/>
+              </a:spcAft>
+              <a:buNone/>
             </a:pPr>
             <a:r>
               <a:t>[Presenter / team]</a:t>
             </a:r>
           </a:p>
           <a:p>
-            <a:pPr>
-              <a:lnSpc>
-                <a:spcPct val="112000"/>
-              </a:lnSpc>
-              <a:spcAft>
-                <a:spcPts val="1200"/>
-              </a:spcAft>
+            <a:pPr algn="l" marL="0" indent="0">
               <a:defRPr sz="1700" b="0">
                 <a:solidFill>
                   <a:srgbClr val="030B20"/>
                 </a:solidFill>
                 <a:latin typeface="Inter"/>
               </a:defRPr>
+              <a:lnSpc>
+                <a:spcPct val="112000"/>
+              </a:lnSpc>
+              <a:spcAft>
+                <a:spcPts val="1200"/>
+              </a:spcAft>
+              <a:buNone/>
             </a:pPr>
             <a:r>
               <a:t>[Event · date]</a:t>
@@ -6036,7 +5948,7 @@
 </file>
 
 <file path=ppt/slides/slide10.xml><?xml version="1.0" encoding="utf-8"?>
-<p:sld xmlns:a="http://schemas.openxmlformats.org/drawingml/2006/main" xmlns:p="http://schemas.openxmlformats.org/presentationml/2006/main" xmlns:r="http://schemas.openxmlformats.org/officeDocument/2006/relationships" showMasterSp="0">
+<p:sld xmlns:a="http://schemas.openxmlformats.org/drawingml/2006/main" xmlns:p="http://schemas.openxmlformats.org/presentationml/2006/main" xmlns:r="http://schemas.openxmlformats.org/officeDocument/2006/relationships" showMasterSp="1">
   <p:cSld>
     <p:bg>
       <p:bgPr>
@@ -6077,19 +5989,20 @@
           </a:bodyPr>
           <a:lstStyle/>
           <a:p>
-            <a:pPr>
-              <a:lnSpc>
-                <a:spcPct val="112000"/>
-              </a:lnSpc>
-              <a:spcAft>
-                <a:spcPts val="1200"/>
-              </a:spcAft>
+            <a:pPr algn="l" marL="0" indent="0">
               <a:defRPr sz="3600" b="1">
                 <a:solidFill>
                   <a:srgbClr val="082952"/>
                 </a:solidFill>
                 <a:latin typeface="Inter"/>
               </a:defRPr>
+              <a:lnSpc>
+                <a:spcPct val="112000"/>
+              </a:lnSpc>
+              <a:spcAft>
+                <a:spcPts val="1200"/>
+              </a:spcAft>
+              <a:buNone/>
             </a:pPr>
             <a:r>
               <a:t>Make it yours. Keep it Plan B.</a:t>
@@ -6121,19 +6034,20 @@
           </a:bodyPr>
           <a:lstStyle/>
           <a:p>
-            <a:pPr>
-              <a:lnSpc>
-                <a:spcPct val="112000"/>
-              </a:lnSpc>
-              <a:spcAft>
-                <a:spcPts val="1200"/>
-              </a:spcAft>
+            <a:pPr algn="l" marL="0" indent="0">
               <a:defRPr sz="1900" b="0">
                 <a:solidFill>
                   <a:srgbClr val="030B20"/>
                 </a:solidFill>
                 <a:latin typeface="Inter"/>
               </a:defRPr>
+              <a:lnSpc>
+                <a:spcPct val="112000"/>
+              </a:lnSpc>
+              <a:spcAft>
+                <a:spcPts val="1200"/>
+              </a:spcAft>
+              <a:buNone/>
             </a:pPr>
             <a:r>
               <a:t>Delete this guidance slide before presenting.</a:t>
@@ -6165,38 +6079,40 @@
           </a:bodyPr>
           <a:lstStyle/>
           <a:p>
-            <a:pPr>
-              <a:lnSpc>
-                <a:spcPct val="112000"/>
-              </a:lnSpc>
-              <a:spcAft>
-                <a:spcPts val="1200"/>
-              </a:spcAft>
+            <a:pPr algn="l" marL="0" indent="0">
               <a:defRPr sz="2300" b="0">
                 <a:solidFill>
                   <a:srgbClr val="030B20"/>
                 </a:solidFill>
                 <a:latin typeface="Inter"/>
               </a:defRPr>
+              <a:lnSpc>
+                <a:spcPct val="112000"/>
+              </a:lnSpc>
+              <a:spcAft>
+                <a:spcPts val="1200"/>
+              </a:spcAft>
+              <a:buNone/>
             </a:pPr>
             <a:r>
               <a:t>Use the layouts</a:t>
             </a:r>
           </a:p>
           <a:p>
-            <a:pPr>
-              <a:lnSpc>
-                <a:spcPct val="112000"/>
-              </a:lnSpc>
-              <a:spcAft>
-                <a:spcPts val="1200"/>
-              </a:spcAft>
+            <a:pPr algn="l" marL="0" indent="0">
               <a:defRPr sz="2300" b="0">
                 <a:solidFill>
                   <a:srgbClr val="030B20"/>
                 </a:solidFill>
                 <a:latin typeface="Inter"/>
               </a:defRPr>
+              <a:lnSpc>
+                <a:spcPct val="112000"/>
+              </a:lnSpc>
+              <a:spcAft>
+                <a:spcPts val="1200"/>
+              </a:spcAft>
+              <a:buNone/>
             </a:pPr>
             <a:r>
               <a:t>Install Inter, then choose Home → New Slide. Replace bracketed prompts. Duplicate the chart or table example to retain its styling.</a:t>
@@ -6228,38 +6144,40 @@
           </a:bodyPr>
           <a:lstStyle/>
           <a:p>
-            <a:pPr>
-              <a:lnSpc>
-                <a:spcPct val="112000"/>
-              </a:lnSpc>
-              <a:spcAft>
-                <a:spcPts val="1200"/>
-              </a:spcAft>
+            <a:pPr algn="l" marL="0" indent="0">
               <a:defRPr sz="2300" b="0">
                 <a:solidFill>
                   <a:srgbClr val="030B20"/>
                 </a:solidFill>
                 <a:latin typeface="Inter"/>
               </a:defRPr>
+              <a:lnSpc>
+                <a:spcPct val="112000"/>
+              </a:lnSpc>
+              <a:spcAft>
+                <a:spcPts val="1200"/>
+              </a:spcAft>
+              <a:buNone/>
             </a:pPr>
             <a:r>
               <a:t>Keep it clear</a:t>
             </a:r>
           </a:p>
           <a:p>
-            <a:pPr>
-              <a:lnSpc>
-                <a:spcPct val="112000"/>
-              </a:lnSpc>
-              <a:spcAft>
-                <a:spcPts val="1200"/>
-              </a:spcAft>
+            <a:pPr algn="l" marL="0" indent="0">
               <a:defRPr sz="2300" b="0">
                 <a:solidFill>
                   <a:srgbClr val="030B20"/>
                 </a:solidFill>
                 <a:latin typeface="Inter"/>
               </a:defRPr>
+              <a:lnSpc>
+                <a:spcPct val="112000"/>
+              </a:lnSpc>
+              <a:spcAft>
+                <a:spcPts val="1200"/>
+              </a:spcAft>
+              <a:buNone/>
             </a:pPr>
             <a:r>
               <a:t>One idea per slide. Use navy and warm white. Choose gold or a small gradient as the exceptional signal. Aim for 20pt or larger body text.</a:t>
@@ -6276,7 +6194,7 @@
 </file>
 
 <file path=ppt/slides/slide2.xml><?xml version="1.0" encoding="utf-8"?>
-<p:sld xmlns:a="http://schemas.openxmlformats.org/drawingml/2006/main" xmlns:p="http://schemas.openxmlformats.org/presentationml/2006/main" xmlns:r="http://schemas.openxmlformats.org/officeDocument/2006/relationships" showMasterSp="0">
+<p:sld xmlns:a="http://schemas.openxmlformats.org/drawingml/2006/main" xmlns:p="http://schemas.openxmlformats.org/presentationml/2006/main" xmlns:r="http://schemas.openxmlformats.org/officeDocument/2006/relationships" showMasterSp="1">
   <p:cSld>
     <p:bg>
       <p:bgPr>
@@ -6317,19 +6235,20 @@
           </a:bodyPr>
           <a:lstStyle/>
           <a:p>
-            <a:pPr>
-              <a:lnSpc>
-                <a:spcPct val="112000"/>
-              </a:lnSpc>
-              <a:spcAft>
-                <a:spcPts val="1200"/>
-              </a:spcAft>
+            <a:pPr algn="l" marL="0" indent="0">
               <a:defRPr sz="4800" b="1">
                 <a:solidFill>
                   <a:srgbClr val="FFFEFA"/>
                 </a:solidFill>
                 <a:latin typeface="Inter"/>
               </a:defRPr>
+              <a:lnSpc>
+                <a:spcPct val="112000"/>
+              </a:lnSpc>
+              <a:spcAft>
+                <a:spcPts val="1200"/>
+              </a:spcAft>
+              <a:buNone/>
             </a:pPr>
             <a:r>
               <a:t>[Section title]</a:t>
@@ -6361,19 +6280,20 @@
           </a:bodyPr>
           <a:lstStyle/>
           <a:p>
-            <a:pPr>
-              <a:lnSpc>
-                <a:spcPct val="112000"/>
-              </a:lnSpc>
-              <a:spcAft>
-                <a:spcPts val="1200"/>
-              </a:spcAft>
+            <a:pPr algn="l" marL="0" indent="0">
               <a:defRPr sz="2500" b="0">
                 <a:solidFill>
                   <a:srgbClr val="FFFEFA"/>
                 </a:solidFill>
                 <a:latin typeface="Inter"/>
               </a:defRPr>
+              <a:lnSpc>
+                <a:spcPct val="112000"/>
+              </a:lnSpc>
+              <a:spcAft>
+                <a:spcPts val="1200"/>
+              </a:spcAft>
+              <a:buNone/>
             </a:pPr>
             <a:r>
               <a:t>[One sentence that sets the direction]</a:t>
@@ -6390,7 +6310,7 @@
 </file>
 
 <file path=ppt/slides/slide3.xml><?xml version="1.0" encoding="utf-8"?>
-<p:sld xmlns:a="http://schemas.openxmlformats.org/drawingml/2006/main" xmlns:p="http://schemas.openxmlformats.org/presentationml/2006/main" xmlns:r="http://schemas.openxmlformats.org/officeDocument/2006/relationships" showMasterSp="0">
+<p:sld xmlns:a="http://schemas.openxmlformats.org/drawingml/2006/main" xmlns:p="http://schemas.openxmlformats.org/presentationml/2006/main" xmlns:r="http://schemas.openxmlformats.org/officeDocument/2006/relationships" showMasterSp="1">
   <p:cSld>
     <p:bg>
       <p:bgPr>
@@ -6431,19 +6351,20 @@
           </a:bodyPr>
           <a:lstStyle/>
           <a:p>
-            <a:pPr>
-              <a:lnSpc>
-                <a:spcPct val="112000"/>
-              </a:lnSpc>
-              <a:spcAft>
-                <a:spcPts val="1200"/>
-              </a:spcAft>
+            <a:pPr algn="l" marL="0" indent="0">
               <a:defRPr sz="3600" b="1">
                 <a:solidFill>
                   <a:srgbClr val="082952"/>
                 </a:solidFill>
                 <a:latin typeface="Inter"/>
               </a:defRPr>
+              <a:lnSpc>
+                <a:spcPct val="112000"/>
+              </a:lnSpc>
+              <a:spcAft>
+                <a:spcPts val="1200"/>
+              </a:spcAft>
+              <a:buNone/>
             </a:pPr>
             <a:r>
               <a:t>[Lead with the point]</a:t>
@@ -6475,19 +6396,20 @@
           </a:bodyPr>
           <a:lstStyle/>
           <a:p>
-            <a:pPr>
-              <a:lnSpc>
-                <a:spcPct val="112000"/>
-              </a:lnSpc>
-              <a:spcAft>
-                <a:spcPts val="1200"/>
-              </a:spcAft>
+            <a:pPr algn="l" marL="0" indent="0">
               <a:defRPr sz="1900" b="0">
                 <a:solidFill>
                   <a:srgbClr val="030B20"/>
                 </a:solidFill>
                 <a:latin typeface="Inter"/>
               </a:defRPr>
+              <a:lnSpc>
+                <a:spcPct val="112000"/>
+              </a:lnSpc>
+              <a:spcAft>
+                <a:spcPts val="1200"/>
+              </a:spcAft>
+              <a:buNone/>
             </a:pPr>
             <a:r>
               <a:t>[Explain why this matters to the audience]</a:t>
@@ -6519,57 +6441,60 @@
           </a:bodyPr>
           <a:lstStyle/>
           <a:p>
-            <a:pPr>
-              <a:lnSpc>
-                <a:spcPct val="112000"/>
-              </a:lnSpc>
-              <a:spcAft>
-                <a:spcPts val="1200"/>
-              </a:spcAft>
+            <a:pPr algn="l" marL="0" indent="0">
               <a:defRPr sz="2700" b="0">
                 <a:solidFill>
                   <a:srgbClr val="030B20"/>
                 </a:solidFill>
                 <a:latin typeface="Inter"/>
               </a:defRPr>
+              <a:lnSpc>
+                <a:spcPct val="112000"/>
+              </a:lnSpc>
+              <a:spcAft>
+                <a:spcPts val="1200"/>
+              </a:spcAft>
+              <a:buNone/>
             </a:pPr>
             <a:r>
               <a:t>[First idea — one concise sentence]</a:t>
             </a:r>
           </a:p>
           <a:p>
-            <a:pPr>
-              <a:lnSpc>
-                <a:spcPct val="112000"/>
-              </a:lnSpc>
-              <a:spcAft>
-                <a:spcPts val="1200"/>
-              </a:spcAft>
+            <a:pPr algn="l" marL="0" indent="0">
               <a:defRPr sz="2700" b="0">
                 <a:solidFill>
                   <a:srgbClr val="030B20"/>
                 </a:solidFill>
                 <a:latin typeface="Inter"/>
               </a:defRPr>
+              <a:lnSpc>
+                <a:spcPct val="112000"/>
+              </a:lnSpc>
+              <a:spcAft>
+                <a:spcPts val="1200"/>
+              </a:spcAft>
+              <a:buNone/>
             </a:pPr>
             <a:r>
               <a:t>[Second idea — one concise sentence]</a:t>
             </a:r>
           </a:p>
           <a:p>
-            <a:pPr>
-              <a:lnSpc>
-                <a:spcPct val="112000"/>
-              </a:lnSpc>
-              <a:spcAft>
-                <a:spcPts val="1200"/>
-              </a:spcAft>
+            <a:pPr algn="l" marL="0" indent="0">
               <a:defRPr sz="2700" b="0">
                 <a:solidFill>
                   <a:srgbClr val="030B20"/>
                 </a:solidFill>
                 <a:latin typeface="Inter"/>
               </a:defRPr>
+              <a:lnSpc>
+                <a:spcPct val="112000"/>
+              </a:lnSpc>
+              <a:spcAft>
+                <a:spcPts val="1200"/>
+              </a:spcAft>
+              <a:buNone/>
             </a:pPr>
             <a:r>
               <a:t>[Third idea — one concise sentence]</a:t>
@@ -6586,7 +6511,7 @@
 </file>
 
 <file path=ppt/slides/slide4.xml><?xml version="1.0" encoding="utf-8"?>
-<p:sld xmlns:a="http://schemas.openxmlformats.org/drawingml/2006/main" xmlns:p="http://schemas.openxmlformats.org/presentationml/2006/main" xmlns:r="http://schemas.openxmlformats.org/officeDocument/2006/relationships" showMasterSp="0">
+<p:sld xmlns:a="http://schemas.openxmlformats.org/drawingml/2006/main" xmlns:p="http://schemas.openxmlformats.org/presentationml/2006/main" xmlns:r="http://schemas.openxmlformats.org/officeDocument/2006/relationships" showMasterSp="1">
   <p:cSld>
     <p:bg>
       <p:bgPr>
@@ -6627,19 +6552,20 @@
           </a:bodyPr>
           <a:lstStyle/>
           <a:p>
-            <a:pPr>
-              <a:lnSpc>
-                <a:spcPct val="112000"/>
-              </a:lnSpc>
-              <a:spcAft>
-                <a:spcPts val="1200"/>
-              </a:spcAft>
+            <a:pPr algn="l" marL="0" indent="0">
               <a:defRPr sz="3600" b="1">
                 <a:solidFill>
                   <a:srgbClr val="082952"/>
                 </a:solidFill>
                 <a:latin typeface="Inter"/>
               </a:defRPr>
+              <a:lnSpc>
+                <a:spcPct val="112000"/>
+              </a:lnSpc>
+              <a:spcAft>
+                <a:spcPts val="1200"/>
+              </a:spcAft>
+              <a:buNone/>
             </a:pPr>
             <a:r>
               <a:t>[Compare two ideas]</a:t>
@@ -6671,19 +6597,20 @@
           </a:bodyPr>
           <a:lstStyle/>
           <a:p>
-            <a:pPr>
-              <a:lnSpc>
-                <a:spcPct val="112000"/>
-              </a:lnSpc>
-              <a:spcAft>
-                <a:spcPts val="1200"/>
-              </a:spcAft>
+            <a:pPr algn="l" marL="0" indent="0">
               <a:defRPr sz="2600" b="1">
                 <a:solidFill>
                   <a:srgbClr val="082952"/>
                 </a:solidFill>
                 <a:latin typeface="Inter"/>
               </a:defRPr>
+              <a:lnSpc>
+                <a:spcPct val="112000"/>
+              </a:lnSpc>
+              <a:spcAft>
+                <a:spcPts val="1200"/>
+              </a:spcAft>
+              <a:buNone/>
             </a:pPr>
             <a:r>
               <a:t>[First perspective]</a:t>
@@ -6715,19 +6642,20 @@
           </a:bodyPr>
           <a:lstStyle/>
           <a:p>
-            <a:pPr>
-              <a:lnSpc>
-                <a:spcPct val="112000"/>
-              </a:lnSpc>
-              <a:spcAft>
-                <a:spcPts val="1200"/>
-              </a:spcAft>
+            <a:pPr algn="l" marL="0" indent="0">
               <a:defRPr sz="2400" b="0">
                 <a:solidFill>
                   <a:srgbClr val="030B20"/>
                 </a:solidFill>
                 <a:latin typeface="Inter"/>
               </a:defRPr>
+              <a:lnSpc>
+                <a:spcPct val="112000"/>
+              </a:lnSpc>
+              <a:spcAft>
+                <a:spcPts val="1200"/>
+              </a:spcAft>
+              <a:buNone/>
             </a:pPr>
             <a:r>
               <a:t>[Explain the idea in 40 words or fewer. Keep sentences concrete and easy to read.]</a:t>
@@ -6759,19 +6687,20 @@
           </a:bodyPr>
           <a:lstStyle/>
           <a:p>
-            <a:pPr>
-              <a:lnSpc>
-                <a:spcPct val="112000"/>
-              </a:lnSpc>
-              <a:spcAft>
-                <a:spcPts val="1200"/>
-              </a:spcAft>
+            <a:pPr algn="l" marL="0" indent="0">
               <a:defRPr sz="2600" b="1">
                 <a:solidFill>
                   <a:srgbClr val="082952"/>
                 </a:solidFill>
                 <a:latin typeface="Inter"/>
               </a:defRPr>
+              <a:lnSpc>
+                <a:spcPct val="112000"/>
+              </a:lnSpc>
+              <a:spcAft>
+                <a:spcPts val="1200"/>
+              </a:spcAft>
+              <a:buNone/>
             </a:pPr>
             <a:r>
               <a:t>[Second perspective]</a:t>
@@ -6803,19 +6732,20 @@
           </a:bodyPr>
           <a:lstStyle/>
           <a:p>
-            <a:pPr>
-              <a:lnSpc>
-                <a:spcPct val="112000"/>
-              </a:lnSpc>
-              <a:spcAft>
-                <a:spcPts val="1200"/>
-              </a:spcAft>
+            <a:pPr algn="l" marL="0" indent="0">
               <a:defRPr sz="2400" b="0">
                 <a:solidFill>
                   <a:srgbClr val="030B20"/>
                 </a:solidFill>
                 <a:latin typeface="Inter"/>
               </a:defRPr>
+              <a:lnSpc>
+                <a:spcPct val="112000"/>
+              </a:lnSpc>
+              <a:spcAft>
+                <a:spcPts val="1200"/>
+              </a:spcAft>
+              <a:buNone/>
             </a:pPr>
             <a:r>
               <a:t>[Explain the difference or consequence. Use the same level of detail as the first column.]</a:t>
@@ -6832,7 +6762,7 @@
 </file>
 
 <file path=ppt/slides/slide5.xml><?xml version="1.0" encoding="utf-8"?>
-<p:sld xmlns:a="http://schemas.openxmlformats.org/drawingml/2006/main" xmlns:p="http://schemas.openxmlformats.org/presentationml/2006/main" xmlns:r="http://schemas.openxmlformats.org/officeDocument/2006/relationships" showMasterSp="0">
+<p:sld xmlns:a="http://schemas.openxmlformats.org/drawingml/2006/main" xmlns:p="http://schemas.openxmlformats.org/presentationml/2006/main" xmlns:r="http://schemas.openxmlformats.org/officeDocument/2006/relationships" showMasterSp="1">
   <p:cSld>
     <p:bg>
       <p:bgPr>
@@ -6873,19 +6803,20 @@
           </a:bodyPr>
           <a:lstStyle/>
           <a:p>
-            <a:pPr>
-              <a:lnSpc>
-                <a:spcPct val="112000"/>
-              </a:lnSpc>
-              <a:spcAft>
-                <a:spcPts val="1200"/>
-              </a:spcAft>
+            <a:pPr algn="l" marL="0" indent="0">
               <a:defRPr sz="3600" b="1">
                 <a:solidFill>
                   <a:srgbClr val="082952"/>
                 </a:solidFill>
                 <a:latin typeface="Inter"/>
               </a:defRPr>
+              <a:lnSpc>
+                <a:spcPct val="112000"/>
+              </a:lnSpc>
+              <a:spcAft>
+                <a:spcPts val="1200"/>
+              </a:spcAft>
+              <a:buNone/>
             </a:pPr>
             <a:r>
               <a:t>[Make the place visible]</a:t>
@@ -6895,7 +6826,7 @@
       </p:sp>
       <p:sp>
         <p:nvSpPr>
-          <p:cNvPr id="6" name="Placeholder 1"/>
+          <p:cNvPr id="7" name="Placeholder 1"/>
           <p:cNvSpPr txBox="1"/>
           <p:nvPr>
             <p:ph type="pic" idx="1"/>
@@ -6917,19 +6848,20 @@
           </a:bodyPr>
           <a:lstStyle/>
           <a:p>
-            <a:pPr>
-              <a:lnSpc>
-                <a:spcPct val="112000"/>
-              </a:lnSpc>
-              <a:spcAft>
-                <a:spcPts val="1200"/>
-              </a:spcAft>
+            <a:pPr algn="l" marL="0" indent="0">
               <a:defRPr sz="2600" b="1">
                 <a:solidFill>
                   <a:srgbClr val="082952"/>
                 </a:solidFill>
                 <a:latin typeface="Inter"/>
               </a:defRPr>
+              <a:lnSpc>
+                <a:spcPct val="112000"/>
+              </a:lnSpc>
+              <a:spcAft>
+                <a:spcPts val="1200"/>
+              </a:spcAft>
+              <a:buNone/>
             </a:pPr>
             <a:r>
               <a:t>[Insert a documentary photograph]</a:t>
@@ -6939,7 +6871,7 @@
       </p:sp>
       <p:sp>
         <p:nvSpPr>
-          <p:cNvPr id="7" name="Placeholder 2"/>
+          <p:cNvPr id="8" name="Placeholder 2"/>
           <p:cNvSpPr txBox="1"/>
           <p:nvPr>
             <p:ph type="body" idx="2"/>
@@ -6961,19 +6893,20 @@
           </a:bodyPr>
           <a:lstStyle/>
           <a:p>
-            <a:pPr>
-              <a:lnSpc>
-                <a:spcPct val="112000"/>
-              </a:lnSpc>
-              <a:spcAft>
-                <a:spcPts val="1200"/>
-              </a:spcAft>
+            <a:pPr algn="l" marL="0" indent="0">
               <a:defRPr sz="2700" b="1">
                 <a:solidFill>
                   <a:srgbClr val="082952"/>
                 </a:solidFill>
                 <a:latin typeface="Inter"/>
               </a:defRPr>
+              <a:lnSpc>
+                <a:spcPct val="112000"/>
+              </a:lnSpc>
+              <a:spcAft>
+                <a:spcPts val="1200"/>
+              </a:spcAft>
+              <a:buNone/>
             </a:pPr>
             <a:r>
               <a:t>[What should we notice?]</a:t>
@@ -6983,7 +6916,7 @@
       </p:sp>
       <p:sp>
         <p:nvSpPr>
-          <p:cNvPr id="8" name="Placeholder 3"/>
+          <p:cNvPr id="9" name="Placeholder 3"/>
           <p:cNvSpPr txBox="1"/>
           <p:nvPr>
             <p:ph type="body" idx="3"/>
@@ -7005,19 +6938,20 @@
           </a:bodyPr>
           <a:lstStyle/>
           <a:p>
-            <a:pPr>
-              <a:lnSpc>
-                <a:spcPct val="112000"/>
-              </a:lnSpc>
-              <a:spcAft>
-                <a:spcPts val="1200"/>
-              </a:spcAft>
+            <a:pPr algn="l" marL="0" indent="0">
               <a:defRPr sz="2200" b="0">
                 <a:solidFill>
                   <a:srgbClr val="030B20"/>
                 </a:solidFill>
                 <a:latin typeface="Inter"/>
               </a:defRPr>
+              <a:lnSpc>
+                <a:spcPct val="112000"/>
+              </a:lnSpc>
+              <a:spcAft>
+                <a:spcPts val="1200"/>
+              </a:spcAft>
+              <a:buNone/>
             </a:pPr>
             <a:r>
               <a:t>[Connect the image to the public purpose. Use real Lugano, civic spaces, workshops or people making and learning.]</a:t>
@@ -7027,7 +6961,7 @@
       </p:sp>
       <p:sp>
         <p:nvSpPr>
-          <p:cNvPr id="9" name="Placeholder 4"/>
+          <p:cNvPr id="10" name="Placeholder 4"/>
           <p:cNvSpPr txBox="1"/>
           <p:nvPr>
             <p:ph type="body" idx="4"/>
@@ -7049,19 +6983,20 @@
           </a:bodyPr>
           <a:lstStyle/>
           <a:p>
-            <a:pPr>
-              <a:lnSpc>
-                <a:spcPct val="112000"/>
-              </a:lnSpc>
-              <a:spcAft>
-                <a:spcPts val="1200"/>
-              </a:spcAft>
+            <a:pPr algn="l" marL="0" indent="0">
               <a:defRPr sz="1200" b="0">
                 <a:solidFill>
                   <a:srgbClr val="030B20"/>
                 </a:solidFill>
                 <a:latin typeface="Inter"/>
               </a:defRPr>
+              <a:lnSpc>
+                <a:spcPct val="112000"/>
+              </a:lnSpc>
+              <a:spcAft>
+                <a:spcPts val="1200"/>
+              </a:spcAft>
+              <a:buNone/>
             </a:pPr>
             <a:r>
               <a:t>[Photo credit / source / permission]</a:t>
@@ -7078,7 +7013,7 @@
 </file>
 
 <file path=ppt/slides/slide6.xml><?xml version="1.0" encoding="utf-8"?>
-<p:sld xmlns:a="http://schemas.openxmlformats.org/drawingml/2006/main" xmlns:p="http://schemas.openxmlformats.org/presentationml/2006/main" xmlns:r="http://schemas.openxmlformats.org/officeDocument/2006/relationships" showMasterSp="0">
+<p:sld xmlns:a="http://schemas.openxmlformats.org/drawingml/2006/main" xmlns:p="http://schemas.openxmlformats.org/presentationml/2006/main" xmlns:r="http://schemas.openxmlformats.org/officeDocument/2006/relationships" showMasterSp="1">
   <p:cSld>
     <p:bg>
       <p:bgPr>
@@ -7119,19 +7054,20 @@
           </a:bodyPr>
           <a:lstStyle/>
           <a:p>
-            <a:pPr>
-              <a:lnSpc>
-                <a:spcPct val="112000"/>
-              </a:lnSpc>
-              <a:spcAft>
-                <a:spcPts val="1200"/>
-              </a:spcAft>
+            <a:pPr algn="l" marL="0" indent="0">
               <a:defRPr sz="3600" b="1">
                 <a:solidFill>
                   <a:srgbClr val="082952"/>
                 </a:solidFill>
                 <a:latin typeface="Inter"/>
               </a:defRPr>
+              <a:lnSpc>
+                <a:spcPct val="112000"/>
+              </a:lnSpc>
+              <a:spcAft>
+                <a:spcPts val="1200"/>
+              </a:spcAft>
+              <a:buNone/>
             </a:pPr>
             <a:r>
               <a:t>[Say what the data shows]</a:t>
@@ -7163,19 +7099,20 @@
           </a:bodyPr>
           <a:lstStyle/>
           <a:p>
-            <a:pPr>
-              <a:lnSpc>
-                <a:spcPct val="112000"/>
-              </a:lnSpc>
-              <a:spcAft>
-                <a:spcPts val="1200"/>
-              </a:spcAft>
+            <a:pPr algn="l" marL="0" indent="0">
               <a:defRPr sz="1900" b="0">
                 <a:solidFill>
                   <a:srgbClr val="030B20"/>
                 </a:solidFill>
                 <a:latin typeface="Inter"/>
               </a:defRPr>
+              <a:lnSpc>
+                <a:spcPct val="112000"/>
+              </a:lnSpc>
+              <a:spcAft>
+                <a:spcPts val="1200"/>
+              </a:spcAft>
+              <a:buNone/>
             </a:pPr>
             <a:r>
               <a:t>[Unit, population and time period]</a:t>
@@ -7207,19 +7144,20 @@
           </a:bodyPr>
           <a:lstStyle/>
           <a:p>
-            <a:pPr>
-              <a:lnSpc>
-                <a:spcPct val="112000"/>
-              </a:lnSpc>
-              <a:spcAft>
-                <a:spcPts val="1200"/>
-              </a:spcAft>
+            <a:pPr algn="l" marL="0" indent="0">
               <a:defRPr sz="2700" b="1">
                 <a:solidFill>
                   <a:srgbClr val="082952"/>
                 </a:solidFill>
                 <a:latin typeface="Inter"/>
               </a:defRPr>
+              <a:lnSpc>
+                <a:spcPct val="112000"/>
+              </a:lnSpc>
+              <a:spcAft>
+                <a:spcPts val="1200"/>
+              </a:spcAft>
+              <a:buNone/>
             </a:pPr>
             <a:r>
               <a:t>[The takeaway]</a:t>
@@ -7251,19 +7189,20 @@
           </a:bodyPr>
           <a:lstStyle/>
           <a:p>
-            <a:pPr>
-              <a:lnSpc>
-                <a:spcPct val="112000"/>
-              </a:lnSpc>
-              <a:spcAft>
-                <a:spcPts val="1200"/>
-              </a:spcAft>
+            <a:pPr algn="l" marL="0" indent="0">
               <a:defRPr sz="2200" b="0">
                 <a:solidFill>
                   <a:srgbClr val="030B20"/>
                 </a:solidFill>
                 <a:latin typeface="Inter"/>
               </a:defRPr>
+              <a:lnSpc>
+                <a:spcPct val="112000"/>
+              </a:lnSpc>
+              <a:spcAft>
+                <a:spcPts val="1200"/>
+              </a:spcAft>
+              <a:buNone/>
             </a:pPr>
             <a:r>
               <a:t>[Explain the implication and the limits of the evidence.]</a:t>
@@ -7295,19 +7234,20 @@
           </a:bodyPr>
           <a:lstStyle/>
           <a:p>
-            <a:pPr>
-              <a:lnSpc>
-                <a:spcPct val="112000"/>
-              </a:lnSpc>
-              <a:spcAft>
-                <a:spcPts val="1200"/>
-              </a:spcAft>
+            <a:pPr algn="l" marL="0" indent="0">
               <a:defRPr sz="1200" b="0">
                 <a:solidFill>
                   <a:srgbClr val="030B20"/>
                 </a:solidFill>
                 <a:latin typeface="Inter"/>
               </a:defRPr>
+              <a:lnSpc>
+                <a:spcPct val="112000"/>
+              </a:lnSpc>
+              <a:spcAft>
+                <a:spcPts val="1200"/>
+              </a:spcAft>
+              <a:buNone/>
             </a:pPr>
             <a:r>
               <a:t>ILLUSTRATIVE DATA ONLY · Replace values and add a source before presenting.</a:t>
@@ -7342,7 +7282,7 @@
 </file>
 
 <file path=ppt/slides/slide7.xml><?xml version="1.0" encoding="utf-8"?>
-<p:sld xmlns:a="http://schemas.openxmlformats.org/drawingml/2006/main" xmlns:p="http://schemas.openxmlformats.org/presentationml/2006/main" xmlns:r="http://schemas.openxmlformats.org/officeDocument/2006/relationships" showMasterSp="0">
+<p:sld xmlns:a="http://schemas.openxmlformats.org/drawingml/2006/main" xmlns:p="http://schemas.openxmlformats.org/presentationml/2006/main" xmlns:r="http://schemas.openxmlformats.org/officeDocument/2006/relationships" showMasterSp="1">
   <p:cSld>
     <p:bg>
       <p:bgPr>
@@ -7383,19 +7323,20 @@
           </a:bodyPr>
           <a:lstStyle/>
           <a:p>
-            <a:pPr>
-              <a:lnSpc>
-                <a:spcPct val="112000"/>
-              </a:lnSpc>
-              <a:spcAft>
-                <a:spcPts val="1200"/>
-              </a:spcAft>
+            <a:pPr algn="l" marL="0" indent="0">
               <a:defRPr sz="3600" b="1">
                 <a:solidFill>
                   <a:srgbClr val="082952"/>
                 </a:solidFill>
                 <a:latin typeface="Inter"/>
               </a:defRPr>
+              <a:lnSpc>
+                <a:spcPct val="112000"/>
+              </a:lnSpc>
+              <a:spcAft>
+                <a:spcPts val="1200"/>
+              </a:spcAft>
+              <a:buNone/>
             </a:pPr>
             <a:r>
               <a:t>[Make a decision easier]</a:t>
@@ -7427,19 +7368,20 @@
           </a:bodyPr>
           <a:lstStyle/>
           <a:p>
-            <a:pPr>
-              <a:lnSpc>
-                <a:spcPct val="112000"/>
-              </a:lnSpc>
-              <a:spcAft>
-                <a:spcPts val="1200"/>
-              </a:spcAft>
+            <a:pPr algn="l" marL="0" indent="0">
               <a:defRPr sz="1900" b="0">
                 <a:solidFill>
                   <a:srgbClr val="030B20"/>
                 </a:solidFill>
                 <a:latin typeface="Inter"/>
               </a:defRPr>
+              <a:lnSpc>
+                <a:spcPct val="112000"/>
+              </a:lnSpc>
+              <a:spcAft>
+                <a:spcPts val="1200"/>
+              </a:spcAft>
+              <a:buNone/>
             </a:pPr>
             <a:r>
               <a:t>[Explain what the comparison includes]</a:t>
@@ -7471,19 +7413,20 @@
           </a:bodyPr>
           <a:lstStyle/>
           <a:p>
-            <a:pPr>
-              <a:lnSpc>
-                <a:spcPct val="112000"/>
-              </a:lnSpc>
-              <a:spcAft>
-                <a:spcPts val="1200"/>
-              </a:spcAft>
+            <a:pPr algn="l" marL="0" indent="0">
               <a:defRPr sz="1300" b="0">
                 <a:solidFill>
                   <a:srgbClr val="030B20"/>
                 </a:solidFill>
                 <a:latin typeface="Inter"/>
               </a:defRPr>
+              <a:lnSpc>
+                <a:spcPct val="112000"/>
+              </a:lnSpc>
+              <a:spcAft>
+                <a:spcPts val="1200"/>
+              </a:spcAft>
+              <a:buNone/>
             </a:pPr>
             <a:r>
               <a:t>[Source / definitions / caveat]</a:t>
@@ -7823,7 +7766,7 @@
 </file>
 
 <file path=ppt/slides/slide8.xml><?xml version="1.0" encoding="utf-8"?>
-<p:sld xmlns:a="http://schemas.openxmlformats.org/drawingml/2006/main" xmlns:p="http://schemas.openxmlformats.org/presentationml/2006/main" xmlns:r="http://schemas.openxmlformats.org/officeDocument/2006/relationships" showMasterSp="0">
+<p:sld xmlns:a="http://schemas.openxmlformats.org/drawingml/2006/main" xmlns:p="http://schemas.openxmlformats.org/presentationml/2006/main" xmlns:r="http://schemas.openxmlformats.org/officeDocument/2006/relationships" showMasterSp="1">
   <p:cSld>
     <p:bg>
       <p:bgPr>
@@ -7864,38 +7807,40 @@
           </a:bodyPr>
           <a:lstStyle/>
           <a:p>
-            <a:pPr>
-              <a:lnSpc>
-                <a:spcPct val="112000"/>
-              </a:lnSpc>
-              <a:spcAft>
-                <a:spcPts val="1200"/>
-              </a:spcAft>
+            <a:pPr algn="l" marL="0" indent="0">
               <a:defRPr sz="4200" b="1">
                 <a:solidFill>
                   <a:srgbClr val="082952"/>
                 </a:solidFill>
                 <a:latin typeface="Inter"/>
               </a:defRPr>
+              <a:lnSpc>
+                <a:spcPct val="112000"/>
+              </a:lnSpc>
+              <a:spcAft>
+                <a:spcPts val="1200"/>
+              </a:spcAft>
+              <a:buNone/>
             </a:pPr>
             <a:r>
               <a:t>[A short quotation,</a:t>
             </a:r>
           </a:p>
           <a:p>
-            <a:pPr>
-              <a:lnSpc>
-                <a:spcPct val="112000"/>
-              </a:lnSpc>
-              <a:spcAft>
-                <a:spcPts val="1200"/>
-              </a:spcAft>
+            <a:pPr algn="l" marL="0" indent="0">
               <a:defRPr sz="4200" b="1">
                 <a:solidFill>
                   <a:srgbClr val="082952"/>
                 </a:solidFill>
                 <a:latin typeface="Inter"/>
               </a:defRPr>
+              <a:lnSpc>
+                <a:spcPct val="112000"/>
+              </a:lnSpc>
+              <a:spcAft>
+                <a:spcPts val="1200"/>
+              </a:spcAft>
+              <a:buNone/>
             </a:pPr>
             <a:r>
               <a:t>accurately attributed.]</a:t>
@@ -7927,38 +7872,40 @@
           </a:bodyPr>
           <a:lstStyle/>
           <a:p>
-            <a:pPr>
-              <a:lnSpc>
-                <a:spcPct val="112000"/>
-              </a:lnSpc>
-              <a:spcAft>
-                <a:spcPts val="1200"/>
-              </a:spcAft>
+            <a:pPr algn="l" marL="0" indent="0">
               <a:defRPr sz="2000" b="0">
                 <a:solidFill>
                   <a:srgbClr val="030B20"/>
                 </a:solidFill>
                 <a:latin typeface="Inter"/>
               </a:defRPr>
+              <a:lnSpc>
+                <a:spcPct val="112000"/>
+              </a:lnSpc>
+              <a:spcAft>
+                <a:spcPts val="1200"/>
+              </a:spcAft>
+              <a:buNone/>
             </a:pPr>
             <a:r>
               <a:t>[Speaker / role]</a:t>
             </a:r>
           </a:p>
           <a:p>
-            <a:pPr>
-              <a:lnSpc>
-                <a:spcPct val="112000"/>
-              </a:lnSpc>
-              <a:spcAft>
-                <a:spcPts val="1200"/>
-              </a:spcAft>
+            <a:pPr algn="l" marL="0" indent="0">
               <a:defRPr sz="2000" b="0">
                 <a:solidFill>
                   <a:srgbClr val="030B20"/>
                 </a:solidFill>
                 <a:latin typeface="Inter"/>
               </a:defRPr>
+              <a:lnSpc>
+                <a:spcPct val="112000"/>
+              </a:lnSpc>
+              <a:spcAft>
+                <a:spcPts val="1200"/>
+              </a:spcAft>
+              <a:buNone/>
             </a:pPr>
             <a:r>
               <a:t>[Source · date]</a:t>
@@ -7975,7 +7922,7 @@
 </file>
 
 <file path=ppt/slides/slide9.xml><?xml version="1.0" encoding="utf-8"?>
-<p:sld xmlns:a="http://schemas.openxmlformats.org/drawingml/2006/main" xmlns:p="http://schemas.openxmlformats.org/presentationml/2006/main" xmlns:r="http://schemas.openxmlformats.org/officeDocument/2006/relationships" showMasterSp="0">
+<p:sld xmlns:a="http://schemas.openxmlformats.org/drawingml/2006/main" xmlns:p="http://schemas.openxmlformats.org/presentationml/2006/main" xmlns:r="http://schemas.openxmlformats.org/officeDocument/2006/relationships" showMasterSp="1">
   <p:cSld>
     <p:bg>
       <p:bgPr>
@@ -8016,19 +7963,20 @@
           </a:bodyPr>
           <a:lstStyle/>
           <a:p>
-            <a:pPr>
-              <a:lnSpc>
-                <a:spcPct val="112000"/>
-              </a:lnSpc>
-              <a:spcAft>
-                <a:spcPts val="1200"/>
-              </a:spcAft>
+            <a:pPr algn="l" marL="0" indent="0">
               <a:defRPr sz="3600" b="1">
                 <a:solidFill>
                   <a:srgbClr val="082952"/>
                 </a:solidFill>
                 <a:latin typeface="Inter"/>
               </a:defRPr>
+              <a:lnSpc>
+                <a:spcPct val="112000"/>
+              </a:lnSpc>
+              <a:spcAft>
+                <a:spcPts val="1200"/>
+              </a:spcAft>
+              <a:buNone/>
             </a:pPr>
             <a:r>
               <a:t>[What happens next?]</a:t>
@@ -8060,19 +8008,20 @@
           </a:bodyPr>
           <a:lstStyle/>
           <a:p>
-            <a:pPr>
-              <a:lnSpc>
-                <a:spcPct val="112000"/>
-              </a:lnSpc>
-              <a:spcAft>
-                <a:spcPts val="1200"/>
-              </a:spcAft>
+            <a:pPr algn="l" marL="0" indent="0">
               <a:defRPr sz="2800" b="1">
                 <a:solidFill>
                   <a:srgbClr val="082952"/>
                 </a:solidFill>
                 <a:latin typeface="Inter"/>
               </a:defRPr>
+              <a:lnSpc>
+                <a:spcPct val="112000"/>
+              </a:lnSpc>
+              <a:spcAft>
+                <a:spcPts val="1200"/>
+              </a:spcAft>
+              <a:buNone/>
             </a:pPr>
             <a:r>
               <a:t>[Learn]</a:t>
@@ -8104,38 +8053,40 @@
           </a:bodyPr>
           <a:lstStyle/>
           <a:p>
-            <a:pPr>
-              <a:lnSpc>
-                <a:spcPct val="112000"/>
-              </a:lnSpc>
-              <a:spcAft>
-                <a:spcPts val="1200"/>
-              </a:spcAft>
+            <a:pPr algn="l" marL="0" indent="0">
               <a:defRPr sz="2300" b="0">
                 <a:solidFill>
                   <a:srgbClr val="030B20"/>
                 </a:solidFill>
                 <a:latin typeface="Inter"/>
               </a:defRPr>
+              <a:lnSpc>
+                <a:spcPct val="112000"/>
+              </a:lnSpc>
+              <a:spcAft>
+                <a:spcPts val="1200"/>
+              </a:spcAft>
+              <a:buNone/>
             </a:pPr>
             <a:r>
               <a:t>[Concrete next action]</a:t>
             </a:r>
           </a:p>
           <a:p>
-            <a:pPr>
-              <a:lnSpc>
-                <a:spcPct val="112000"/>
-              </a:lnSpc>
-              <a:spcAft>
-                <a:spcPts val="1200"/>
-              </a:spcAft>
+            <a:pPr algn="l" marL="0" indent="0">
               <a:defRPr sz="2300" b="0">
                 <a:solidFill>
                   <a:srgbClr val="030B20"/>
                 </a:solidFill>
                 <a:latin typeface="Inter"/>
               </a:defRPr>
+              <a:lnSpc>
+                <a:spcPct val="112000"/>
+              </a:lnSpc>
+              <a:spcAft>
+                <a:spcPts val="1200"/>
+              </a:spcAft>
+              <a:buNone/>
             </a:pPr>
             <a:r>
               <a:t>[Owner · timing]</a:t>
@@ -8167,19 +8118,20 @@
           </a:bodyPr>
           <a:lstStyle/>
           <a:p>
-            <a:pPr>
-              <a:lnSpc>
-                <a:spcPct val="112000"/>
-              </a:lnSpc>
-              <a:spcAft>
-                <a:spcPts val="1200"/>
-              </a:spcAft>
+            <a:pPr algn="l" marL="0" indent="0">
               <a:defRPr sz="2800" b="1">
                 <a:solidFill>
                   <a:srgbClr val="082952"/>
                 </a:solidFill>
                 <a:latin typeface="Inter"/>
               </a:defRPr>
+              <a:lnSpc>
+                <a:spcPct val="112000"/>
+              </a:lnSpc>
+              <a:spcAft>
+                <a:spcPts val="1200"/>
+              </a:spcAft>
+              <a:buNone/>
             </a:pPr>
             <a:r>
               <a:t>[Test]</a:t>
@@ -8211,38 +8163,40 @@
           </a:bodyPr>
           <a:lstStyle/>
           <a:p>
-            <a:pPr>
-              <a:lnSpc>
-                <a:spcPct val="112000"/>
-              </a:lnSpc>
-              <a:spcAft>
-                <a:spcPts val="1200"/>
-              </a:spcAft>
+            <a:pPr algn="l" marL="0" indent="0">
               <a:defRPr sz="2300" b="0">
                 <a:solidFill>
                   <a:srgbClr val="030B20"/>
                 </a:solidFill>
                 <a:latin typeface="Inter"/>
               </a:defRPr>
+              <a:lnSpc>
+                <a:spcPct val="112000"/>
+              </a:lnSpc>
+              <a:spcAft>
+                <a:spcPts val="1200"/>
+              </a:spcAft>
+              <a:buNone/>
             </a:pPr>
             <a:r>
               <a:t>[Concrete next action]</a:t>
             </a:r>
           </a:p>
           <a:p>
-            <a:pPr>
-              <a:lnSpc>
-                <a:spcPct val="112000"/>
-              </a:lnSpc>
-              <a:spcAft>
-                <a:spcPts val="1200"/>
-              </a:spcAft>
+            <a:pPr algn="l" marL="0" indent="0">
               <a:defRPr sz="2300" b="0">
                 <a:solidFill>
                   <a:srgbClr val="030B20"/>
                 </a:solidFill>
                 <a:latin typeface="Inter"/>
               </a:defRPr>
+              <a:lnSpc>
+                <a:spcPct val="112000"/>
+              </a:lnSpc>
+              <a:spcAft>
+                <a:spcPts val="1200"/>
+              </a:spcAft>
+              <a:buNone/>
             </a:pPr>
             <a:r>
               <a:t>[Owner · timing]</a:t>
@@ -8274,19 +8228,20 @@
           </a:bodyPr>
           <a:lstStyle/>
           <a:p>
-            <a:pPr>
-              <a:lnSpc>
-                <a:spcPct val="112000"/>
-              </a:lnSpc>
-              <a:spcAft>
-                <a:spcPts val="1200"/>
-              </a:spcAft>
+            <a:pPr algn="l" marL="0" indent="0">
               <a:defRPr sz="2800" b="1">
                 <a:solidFill>
                   <a:srgbClr val="082952"/>
                 </a:solidFill>
                 <a:latin typeface="Inter"/>
               </a:defRPr>
+              <a:lnSpc>
+                <a:spcPct val="112000"/>
+              </a:lnSpc>
+              <a:spcAft>
+                <a:spcPts val="1200"/>
+              </a:spcAft>
+              <a:buNone/>
             </a:pPr>
             <a:r>
               <a:t>[Contribute]</a:t>
@@ -8318,38 +8273,40 @@
           </a:bodyPr>
           <a:lstStyle/>
           <a:p>
-            <a:pPr>
-              <a:lnSpc>
-                <a:spcPct val="112000"/>
-              </a:lnSpc>
-              <a:spcAft>
-                <a:spcPts val="1200"/>
-              </a:spcAft>
+            <a:pPr algn="l" marL="0" indent="0">
               <a:defRPr sz="2300" b="0">
                 <a:solidFill>
                   <a:srgbClr val="030B20"/>
                 </a:solidFill>
                 <a:latin typeface="Inter"/>
               </a:defRPr>
+              <a:lnSpc>
+                <a:spcPct val="112000"/>
+              </a:lnSpc>
+              <a:spcAft>
+                <a:spcPts val="1200"/>
+              </a:spcAft>
+              <a:buNone/>
             </a:pPr>
             <a:r>
               <a:t>[Concrete next action]</a:t>
             </a:r>
           </a:p>
           <a:p>
-            <a:pPr>
-              <a:lnSpc>
-                <a:spcPct val="112000"/>
-              </a:lnSpc>
-              <a:spcAft>
-                <a:spcPts val="1200"/>
-              </a:spcAft>
+            <a:pPr algn="l" marL="0" indent="0">
               <a:defRPr sz="2300" b="0">
                 <a:solidFill>
                   <a:srgbClr val="030B20"/>
                 </a:solidFill>
                 <a:latin typeface="Inter"/>
               </a:defRPr>
+              <a:lnSpc>
+                <a:spcPct val="112000"/>
+              </a:lnSpc>
+              <a:spcAft>
+                <a:spcPts val="1200"/>
+              </a:spcAft>
+              <a:buNone/>
             </a:pPr>
             <a:r>
               <a:t>[Owner · timing]</a:t>
@@ -8381,19 +8338,20 @@
           </a:bodyPr>
           <a:lstStyle/>
           <a:p>
-            <a:pPr>
-              <a:lnSpc>
-                <a:spcPct val="112000"/>
-              </a:lnSpc>
-              <a:spcAft>
-                <a:spcPts val="1200"/>
-              </a:spcAft>
+            <a:pPr algn="l" marL="0" indent="0">
               <a:defRPr sz="1900" b="0">
                 <a:solidFill>
                   <a:srgbClr val="082952"/>
                 </a:solidFill>
                 <a:latin typeface="Inter"/>
               </a:defRPr>
+              <a:lnSpc>
+                <a:spcPct val="112000"/>
+              </a:lnSpc>
+              <a:spcAft>
+                <a:spcPts val="1200"/>
+              </a:spcAft>
+              <a:buNone/>
             </a:pPr>
             <a:r>
               <a:t>[Contact / project URL]</a:t>

</xml_diff>

<commit_message>
Finalize photo placeholder geometry and flat presentation shapes
</commit_message>
<xml_diff>
--- a/slides/planb-starter.pptx
+++ b/slides/planb-starter.pptx
@@ -1662,6 +1662,7 @@
           <a:ln>
             <a:noFill/>
           </a:ln>
+          <a:effectLst/>
         </p:spPr>
         <p:style>
           <a:lnRef idx="1">
@@ -1850,6 +1851,7 @@
           <a:ln>
             <a:noFill/>
           </a:ln>
+          <a:effectLst/>
         </p:spPr>
         <p:style>
           <a:lnRef idx="1">
@@ -2237,6 +2239,7 @@
           <a:ln>
             <a:noFill/>
           </a:ln>
+          <a:effectLst/>
         </p:spPr>
         <p:style>
           <a:lnRef idx="1">
@@ -2280,6 +2283,7 @@
           <a:ln>
             <a:noFill/>
           </a:ln>
+          <a:effectLst/>
         </p:spPr>
         <p:style>
           <a:lnRef idx="1">
@@ -2323,6 +2327,7 @@
           <a:ln>
             <a:noFill/>
           </a:ln>
+          <a:effectLst/>
         </p:spPr>
         <p:style>
           <a:lnRef idx="1">
@@ -2366,6 +2371,7 @@
           <a:ln>
             <a:noFill/>
           </a:ln>
+          <a:effectLst/>
         </p:spPr>
         <p:style>
           <a:lnRef idx="1">
@@ -2704,6 +2710,7 @@
           <a:ln>
             <a:noFill/>
           </a:ln>
+          <a:effectLst/>
         </p:spPr>
         <p:style>
           <a:lnRef idx="1">
@@ -3046,6 +3053,7 @@
           <a:ln>
             <a:noFill/>
           </a:ln>
+          <a:effectLst/>
         </p:spPr>
         <p:style>
           <a:lnRef idx="1">
@@ -3438,6 +3446,7 @@
           <a:ln>
             <a:noFill/>
           </a:ln>
+          <a:effectLst/>
         </p:spPr>
         <p:style>
           <a:lnRef idx="1">
@@ -3652,6 +3661,7 @@
           <a:ln>
             <a:noFill/>
           </a:ln>
+          <a:effectLst/>
         </p:spPr>
         <p:style>
           <a:lnRef idx="1">
@@ -3728,8 +3738,8 @@
         </p:nvSpPr>
         <p:spPr>
           <a:xfrm>
-            <a:off x="914400" y="2834640"/>
-            <a:ext cx="6035040" cy="1051560"/>
+            <a:off x="594360" y="1828800"/>
+            <a:ext cx="6720840" cy="3886200"/>
           </a:xfrm>
           <a:prstGeom prst="rect">
             <a:avLst/>
@@ -4870,6 +4880,7 @@
           <a:ln>
             <a:noFill/>
           </a:ln>
+          <a:effectLst/>
         </p:spPr>
         <p:style>
           <a:lnRef idx="1">
@@ -6834,8 +6845,8 @@
         </p:nvSpPr>
         <p:spPr>
           <a:xfrm>
-            <a:off x="914400" y="2834640"/>
-            <a:ext cx="6035040" cy="1051560"/>
+            <a:off x="594360" y="1828800"/>
+            <a:ext cx="6720840" cy="3886200"/>
           </a:xfrm>
           <a:prstGeom prst="rect">
             <a:avLst/>

</xml_diff>

<commit_message>
Add complete light and dark slide editions with visible gradient artwork
</commit_message>
<xml_diff>
--- a/slides/planb-starter.pptx
+++ b/slides/planb-starter.pptx
@@ -216,6 +216,9 @@
             <a:p>
               <a:pPr>
                 <a:defRPr sz="1500">
+                  <a:solidFill>
+                    <a:srgbClr val="030B20"/>
+                  </a:solidFill>
                   <a:latin typeface="Inter"/>
                 </a:defRPr>
               </a:pPr>
@@ -249,6 +252,9 @@
           <a:p>
             <a:pPr>
               <a:defRPr sz="1500">
+                <a:solidFill>
+                  <a:srgbClr val="030B20"/>
+                </a:solidFill>
                 <a:latin typeface="Inter"/>
               </a:defRPr>
             </a:pPr>
@@ -269,7 +275,15 @@
         </c:scaling>
         <c:delete val="0"/>
         <c:axPos val="b"/>
-        <c:majorGridlines/>
+        <c:majorGridlines>
+          <c:spPr>
+            <a:ln>
+              <a:solidFill>
+                <a:srgbClr val="DCEAF6"/>
+              </a:solidFill>
+            </a:ln>
+          </c:spPr>
+        </c:majorGridlines>
         <c:majorTickMark val="out"/>
         <c:minorTickMark val="none"/>
         <c:tickLblPos val="nextTo"/>
@@ -279,6 +293,9 @@
           <a:p>
             <a:pPr>
               <a:defRPr sz="1200">
+                <a:solidFill>
+                  <a:srgbClr val="030B20"/>
+                </a:solidFill>
                 <a:latin typeface="Inter"/>
               </a:defRPr>
             </a:pPr>
@@ -290,6 +307,14 @@
     </c:plotArea>
     <c:dispBlanksAs val="gap"/>
   </c:chart>
+  <c:spPr>
+    <a:solidFill>
+      <a:srgbClr val="fffefa"/>
+    </a:solidFill>
+    <a:ln>
+      <a:noFill/>
+    </a:ln>
+  </c:spPr>
   <c:txPr>
     <a:bodyPr/>
     <a:lstStyle/>
@@ -841,7 +866,7 @@
           <a:lstStyle/>
           <a:p>
             <a:r>
-              <a:t>SECTION. Use between major topics, not before every slide. Navy is a presentation divider, not the default dark UI theme. Gold is the single accent. Keep the statement short.</a:t>
+              <a:t>SECTION. Use between major topics, not before every slide. The background follows the selected light or dark edition. The gradient is the brand signal. Keep the statement short.</a:t>
             </a:r>
           </a:p>
         </p:txBody>
@@ -1358,7 +1383,7 @@
 
 <file path=ppt/slideLayouts/slideLayout1.xml><?xml version="1.0" encoding="utf-8"?>
 <p:sldLayout xmlns:a="http://schemas.openxmlformats.org/drawingml/2006/main" xmlns:r="http://schemas.openxmlformats.org/officeDocument/2006/relationships" xmlns:p="http://schemas.openxmlformats.org/presentationml/2006/main" type="cust" preserve="1" showMasterSp="1">
-  <p:cSld name="Plan B / Cover">
+  <p:cSld name="Plan B / Light / Cover">
     <p:bg>
       <p:bgPr>
         <a:solidFill>
@@ -1383,282 +1408,35 @@
       </p:grpSpPr>
       <p:sp>
         <p:nvSpPr>
-          <p:cNvPr id="2" name="Plan B Foundation"/>
-          <p:cNvSpPr txBox="1"/>
-          <p:nvPr/>
-        </p:nvSpPr>
-        <p:spPr>
-          <a:xfrm>
-            <a:off x="594360" y="6382512"/>
-            <a:ext cx="3657600" cy="228600"/>
-          </a:xfrm>
-          <a:prstGeom prst="rect">
-            <a:avLst/>
-          </a:prstGeom>
-          <a:noFill/>
-        </p:spPr>
-        <p:txBody>
-          <a:bodyPr wrap="square" lIns="0" rIns="0" tIns="0" bIns="0">
-            <a:spAutoFit/>
-          </a:bodyPr>
-          <a:lstStyle/>
-          <a:p>
-            <a:pPr algn="l" marL="0" indent="0">
-              <a:defRPr sz="1100" b="1">
-                <a:solidFill>
-                  <a:srgbClr val="082952"/>
-                </a:solidFill>
-                <a:latin typeface="Inter"/>
-              </a:defRPr>
-              <a:lnSpc>
-                <a:spcPct val="112000"/>
-              </a:lnSpc>
-              <a:spcAft>
-                <a:spcPts val="1200"/>
-              </a:spcAft>
-              <a:buNone/>
-            </a:pPr>
-            <a:r>
-              <a:t>Plan B Foundation</a:t>
-            </a:r>
-          </a:p>
-        </p:txBody>
-      </p:sp>
-      <p:sp>
-        <p:nvSpPr>
-          <p:cNvPr id="3" name="Civic Digital Commons"/>
-          <p:cNvSpPr txBox="1"/>
-          <p:nvPr/>
-        </p:nvSpPr>
-        <p:spPr>
-          <a:xfrm>
-            <a:off x="8595360" y="6382512"/>
-            <a:ext cx="2971800" cy="228600"/>
-          </a:xfrm>
-          <a:prstGeom prst="rect">
-            <a:avLst/>
-          </a:prstGeom>
-          <a:noFill/>
-        </p:spPr>
-        <p:txBody>
-          <a:bodyPr wrap="square" lIns="0" rIns="0" tIns="0" bIns="0">
-            <a:spAutoFit/>
-          </a:bodyPr>
-          <a:lstStyle/>
-          <a:p>
-            <a:pPr algn="l" marL="0" indent="0">
-              <a:defRPr sz="1100" b="0">
-                <a:solidFill>
-                  <a:srgbClr val="082952"/>
-                </a:solidFill>
-                <a:latin typeface="Inter"/>
-              </a:defRPr>
-              <a:lnSpc>
-                <a:spcPct val="112000"/>
-              </a:lnSpc>
-              <a:spcAft>
-                <a:spcPts val="1200"/>
-              </a:spcAft>
-              <a:buNone/>
-            </a:pPr>
-            <a:r>
-              <a:t>Civic Digital Commons</a:t>
-            </a:r>
-          </a:p>
-        </p:txBody>
-      </p:sp>
-      <p:sp>
-        <p:nvSpPr>
-          <p:cNvPr id="4" name="Placeholder 0"/>
-          <p:cNvSpPr txBox="1"/>
-          <p:nvPr>
-            <p:ph type="title" idx="0"/>
-          </p:nvPr>
-        </p:nvSpPr>
-        <p:spPr>
-          <a:xfrm>
-            <a:off x="594360" y="1234440"/>
-            <a:ext cx="6675120" cy="1965960"/>
-          </a:xfrm>
-          <a:prstGeom prst="rect">
-            <a:avLst/>
-          </a:prstGeom>
-          <a:noFill/>
-        </p:spPr>
-        <p:txBody>
-          <a:bodyPr wrap="square" lIns="0" rIns="0" tIns="0" bIns="0">
-            <a:spAutoFit/>
-          </a:bodyPr>
-          <a:lstStyle/>
-          <a:p>
-            <a:pPr algn="l" marL="0" indent="0">
-              <a:defRPr sz="4800" b="1">
-                <a:solidFill>
-                  <a:srgbClr val="082952"/>
-                </a:solidFill>
-                <a:latin typeface="Inter"/>
-              </a:defRPr>
-              <a:lnSpc>
-                <a:spcPct val="112000"/>
-              </a:lnSpc>
-              <a:spcAft>
-                <a:spcPts val="1200"/>
-              </a:spcAft>
-              <a:buNone/>
-            </a:pPr>
-            <a:r>
-              <a:t>[Presentation</a:t>
-            </a:r>
-          </a:p>
-          <a:p>
-            <a:pPr algn="l" marL="0" indent="0">
-              <a:defRPr sz="4800" b="1">
-                <a:solidFill>
-                  <a:srgbClr val="082952"/>
-                </a:solidFill>
-                <a:latin typeface="Inter"/>
-              </a:defRPr>
-              <a:lnSpc>
-                <a:spcPct val="112000"/>
-              </a:lnSpc>
-              <a:spcAft>
-                <a:spcPts val="1200"/>
-              </a:spcAft>
-              <a:buNone/>
-            </a:pPr>
-            <a:r>
-              <a:t>title]</a:t>
-            </a:r>
-          </a:p>
-        </p:txBody>
-      </p:sp>
-      <p:sp>
-        <p:nvSpPr>
-          <p:cNvPr id="5" name="Placeholder 1"/>
-          <p:cNvSpPr txBox="1"/>
-          <p:nvPr>
-            <p:ph type="subTitle" idx="1"/>
-          </p:nvPr>
-        </p:nvSpPr>
-        <p:spPr>
-          <a:xfrm>
-            <a:off x="621792" y="3566160"/>
-            <a:ext cx="6217920" cy="822960"/>
-          </a:xfrm>
-          <a:prstGeom prst="rect">
-            <a:avLst/>
-          </a:prstGeom>
-          <a:noFill/>
-        </p:spPr>
-        <p:txBody>
-          <a:bodyPr wrap="square" lIns="0" rIns="0" tIns="0" bIns="0">
-            <a:spAutoFit/>
-          </a:bodyPr>
-          <a:lstStyle/>
-          <a:p>
-            <a:pPr algn="l" marL="0" indent="0">
-              <a:defRPr sz="2400" b="0">
-                <a:solidFill>
-                  <a:srgbClr val="030B20"/>
-                </a:solidFill>
-                <a:latin typeface="Inter"/>
-              </a:defRPr>
-              <a:lnSpc>
-                <a:spcPct val="112000"/>
-              </a:lnSpc>
-              <a:spcAft>
-                <a:spcPts val="1200"/>
-              </a:spcAft>
-              <a:buNone/>
-            </a:pPr>
-            <a:r>
-              <a:t>[A clear sentence about the civic purpose]</a:t>
-            </a:r>
-          </a:p>
-        </p:txBody>
-      </p:sp>
-      <p:sp>
-        <p:nvSpPr>
-          <p:cNvPr id="6" name="Placeholder 2"/>
-          <p:cNvSpPr txBox="1"/>
-          <p:nvPr>
-            <p:ph type="body" idx="2"/>
-          </p:nvPr>
-        </p:nvSpPr>
-        <p:spPr>
-          <a:xfrm>
-            <a:off x="621792" y="5074920"/>
-            <a:ext cx="5943600" cy="731520"/>
-          </a:xfrm>
-          <a:prstGeom prst="rect">
-            <a:avLst/>
-          </a:prstGeom>
-          <a:noFill/>
-        </p:spPr>
-        <p:txBody>
-          <a:bodyPr wrap="square" lIns="0" rIns="0" tIns="0" bIns="0">
-            <a:spAutoFit/>
-          </a:bodyPr>
-          <a:lstStyle/>
-          <a:p>
-            <a:pPr algn="l" marL="0" indent="0">
-              <a:defRPr sz="1700" b="0">
-                <a:solidFill>
-                  <a:srgbClr val="030B20"/>
-                </a:solidFill>
-                <a:latin typeface="Inter"/>
-              </a:defRPr>
-              <a:lnSpc>
-                <a:spcPct val="112000"/>
-              </a:lnSpc>
-              <a:spcAft>
-                <a:spcPts val="1200"/>
-              </a:spcAft>
-              <a:buNone/>
-            </a:pPr>
-            <a:r>
-              <a:t>[Presenter / team]</a:t>
-            </a:r>
-          </a:p>
-          <a:p>
-            <a:pPr algn="l" marL="0" indent="0">
-              <a:defRPr sz="1700" b="0">
-                <a:solidFill>
-                  <a:srgbClr val="030B20"/>
-                </a:solidFill>
-                <a:latin typeface="Inter"/>
-              </a:defRPr>
-              <a:lnSpc>
-                <a:spcPct val="112000"/>
-              </a:lnSpc>
-              <a:spcAft>
-                <a:spcPts val="1200"/>
-              </a:spcAft>
-              <a:buNone/>
-            </a:pPr>
-            <a:r>
-              <a:t>[Event · date]</a:t>
-            </a:r>
-          </a:p>
-        </p:txBody>
-      </p:sp>
-      <p:sp>
-        <p:nvSpPr>
-          <p:cNvPr id="7" name="Rectangle 6"/>
+          <p:cNvPr id="2" name="Plan B / Network energy gradient"/>
           <p:cNvSpPr/>
           <p:nvPr/>
         </p:nvSpPr>
         <p:spPr>
           <a:xfrm>
-            <a:off x="7818120" y="0"/>
-            <a:ext cx="4379976" cy="6080760"/>
-          </a:xfrm>
-          <a:prstGeom prst="rect">
-            <a:avLst/>
-          </a:prstGeom>
-          <a:solidFill>
-            <a:srgbClr val="082952"/>
-          </a:solidFill>
+            <a:off x="594360" y="6163056"/>
+            <a:ext cx="10972800" cy="91440"/>
+          </a:xfrm>
+          <a:prstGeom prst="rect">
+            <a:avLst/>
+          </a:prstGeom>
+          <a:gradFill rotWithShape="1">
+            <a:gsLst>
+              <a:gs pos="0">
+                <a:srgbClr val="FFB604"/>
+              </a:gs>
+              <a:gs pos="28000">
+                <a:srgbClr val="FF5DB1"/>
+              </a:gs>
+              <a:gs pos="58000">
+                <a:srgbClr val="7468FF"/>
+              </a:gs>
+              <a:gs pos="100000">
+                <a:srgbClr val="23F5FF"/>
+              </a:gs>
+            </a:gsLst>
+            <a:lin ang="0" scaled="1"/>
+          </a:gradFill>
           <a:ln>
             <a:noFill/>
           </a:ln>
@@ -1686,9 +1464,314 @@
           </a:p>
         </p:txBody>
       </p:sp>
+      <p:sp>
+        <p:nvSpPr>
+          <p:cNvPr id="3" name="Plan B Foundation"/>
+          <p:cNvSpPr txBox="1"/>
+          <p:nvPr/>
+        </p:nvSpPr>
+        <p:spPr>
+          <a:xfrm>
+            <a:off x="594360" y="6382512"/>
+            <a:ext cx="3657600" cy="228600"/>
+          </a:xfrm>
+          <a:prstGeom prst="rect">
+            <a:avLst/>
+          </a:prstGeom>
+          <a:noFill/>
+        </p:spPr>
+        <p:txBody>
+          <a:bodyPr wrap="square" lIns="0" rIns="0" tIns="0" bIns="0">
+            <a:spAutoFit/>
+          </a:bodyPr>
+          <a:lstStyle/>
+          <a:p>
+            <a:pPr algn="l" marL="0" indent="0">
+              <a:defRPr sz="1100" b="1">
+                <a:solidFill>
+                  <a:srgbClr val="082952"/>
+                </a:solidFill>
+                <a:latin typeface="Inter"/>
+              </a:defRPr>
+              <a:lnSpc>
+                <a:spcPct val="112000"/>
+              </a:lnSpc>
+              <a:spcAft>
+                <a:spcPts val="1200"/>
+              </a:spcAft>
+              <a:buNone/>
+            </a:pPr>
+            <a:r>
+              <a:t>Plan B Foundation</a:t>
+            </a:r>
+          </a:p>
+        </p:txBody>
+      </p:sp>
+      <p:sp>
+        <p:nvSpPr>
+          <p:cNvPr id="4" name="Civic Digital Commons"/>
+          <p:cNvSpPr txBox="1"/>
+          <p:nvPr/>
+        </p:nvSpPr>
+        <p:spPr>
+          <a:xfrm>
+            <a:off x="8595360" y="6382512"/>
+            <a:ext cx="2971800" cy="228600"/>
+          </a:xfrm>
+          <a:prstGeom prst="rect">
+            <a:avLst/>
+          </a:prstGeom>
+          <a:noFill/>
+        </p:spPr>
+        <p:txBody>
+          <a:bodyPr wrap="square" lIns="0" rIns="0" tIns="0" bIns="0">
+            <a:spAutoFit/>
+          </a:bodyPr>
+          <a:lstStyle/>
+          <a:p>
+            <a:pPr algn="l" marL="0" indent="0">
+              <a:defRPr sz="1100" b="0">
+                <a:solidFill>
+                  <a:srgbClr val="082952"/>
+                </a:solidFill>
+                <a:latin typeface="Inter"/>
+              </a:defRPr>
+              <a:lnSpc>
+                <a:spcPct val="112000"/>
+              </a:lnSpc>
+              <a:spcAft>
+                <a:spcPts val="1200"/>
+              </a:spcAft>
+              <a:buNone/>
+            </a:pPr>
+            <a:r>
+              <a:t>Civic Digital Commons</a:t>
+            </a:r>
+          </a:p>
+        </p:txBody>
+      </p:sp>
+      <p:sp>
+        <p:nvSpPr>
+          <p:cNvPr id="5" name="Placeholder 0"/>
+          <p:cNvSpPr txBox="1"/>
+          <p:nvPr>
+            <p:ph type="title" idx="0"/>
+          </p:nvPr>
+        </p:nvSpPr>
+        <p:spPr>
+          <a:xfrm>
+            <a:off x="594360" y="1234440"/>
+            <a:ext cx="6675120" cy="1965960"/>
+          </a:xfrm>
+          <a:prstGeom prst="rect">
+            <a:avLst/>
+          </a:prstGeom>
+          <a:noFill/>
+        </p:spPr>
+        <p:txBody>
+          <a:bodyPr wrap="square" lIns="0" rIns="0" tIns="0" bIns="0">
+            <a:spAutoFit/>
+          </a:bodyPr>
+          <a:lstStyle/>
+          <a:p>
+            <a:pPr algn="l" marL="0" indent="0">
+              <a:defRPr sz="4800" b="1">
+                <a:solidFill>
+                  <a:srgbClr val="082952"/>
+                </a:solidFill>
+                <a:latin typeface="Inter"/>
+              </a:defRPr>
+              <a:lnSpc>
+                <a:spcPct val="112000"/>
+              </a:lnSpc>
+              <a:spcAft>
+                <a:spcPts val="1200"/>
+              </a:spcAft>
+              <a:buNone/>
+            </a:pPr>
+            <a:r>
+              <a:t>[Presentation</a:t>
+            </a:r>
+          </a:p>
+          <a:p>
+            <a:pPr algn="l" marL="0" indent="0">
+              <a:defRPr sz="4800" b="1">
+                <a:solidFill>
+                  <a:srgbClr val="082952"/>
+                </a:solidFill>
+                <a:latin typeface="Inter"/>
+              </a:defRPr>
+              <a:lnSpc>
+                <a:spcPct val="112000"/>
+              </a:lnSpc>
+              <a:spcAft>
+                <a:spcPts val="1200"/>
+              </a:spcAft>
+              <a:buNone/>
+            </a:pPr>
+            <a:r>
+              <a:t>title]</a:t>
+            </a:r>
+          </a:p>
+        </p:txBody>
+      </p:sp>
+      <p:sp>
+        <p:nvSpPr>
+          <p:cNvPr id="6" name="Placeholder 1"/>
+          <p:cNvSpPr txBox="1"/>
+          <p:nvPr>
+            <p:ph type="subTitle" idx="1"/>
+          </p:nvPr>
+        </p:nvSpPr>
+        <p:spPr>
+          <a:xfrm>
+            <a:off x="621792" y="3566160"/>
+            <a:ext cx="6217920" cy="822960"/>
+          </a:xfrm>
+          <a:prstGeom prst="rect">
+            <a:avLst/>
+          </a:prstGeom>
+          <a:noFill/>
+        </p:spPr>
+        <p:txBody>
+          <a:bodyPr wrap="square" lIns="0" rIns="0" tIns="0" bIns="0">
+            <a:spAutoFit/>
+          </a:bodyPr>
+          <a:lstStyle/>
+          <a:p>
+            <a:pPr algn="l" marL="0" indent="0">
+              <a:defRPr sz="2400" b="0">
+                <a:solidFill>
+                  <a:srgbClr val="030B20"/>
+                </a:solidFill>
+                <a:latin typeface="Inter"/>
+              </a:defRPr>
+              <a:lnSpc>
+                <a:spcPct val="112000"/>
+              </a:lnSpc>
+              <a:spcAft>
+                <a:spcPts val="1200"/>
+              </a:spcAft>
+              <a:buNone/>
+            </a:pPr>
+            <a:r>
+              <a:t>[A clear sentence about the civic purpose]</a:t>
+            </a:r>
+          </a:p>
+        </p:txBody>
+      </p:sp>
+      <p:sp>
+        <p:nvSpPr>
+          <p:cNvPr id="7" name="Placeholder 2"/>
+          <p:cNvSpPr txBox="1"/>
+          <p:nvPr>
+            <p:ph type="body" idx="2"/>
+          </p:nvPr>
+        </p:nvSpPr>
+        <p:spPr>
+          <a:xfrm>
+            <a:off x="621792" y="5074920"/>
+            <a:ext cx="5943600" cy="731520"/>
+          </a:xfrm>
+          <a:prstGeom prst="rect">
+            <a:avLst/>
+          </a:prstGeom>
+          <a:noFill/>
+        </p:spPr>
+        <p:txBody>
+          <a:bodyPr wrap="square" lIns="0" rIns="0" tIns="0" bIns="0">
+            <a:spAutoFit/>
+          </a:bodyPr>
+          <a:lstStyle/>
+          <a:p>
+            <a:pPr algn="l" marL="0" indent="0">
+              <a:defRPr sz="1700" b="0">
+                <a:solidFill>
+                  <a:srgbClr val="030B20"/>
+                </a:solidFill>
+                <a:latin typeface="Inter"/>
+              </a:defRPr>
+              <a:lnSpc>
+                <a:spcPct val="112000"/>
+              </a:lnSpc>
+              <a:spcAft>
+                <a:spcPts val="1200"/>
+              </a:spcAft>
+              <a:buNone/>
+            </a:pPr>
+            <a:r>
+              <a:t>[Presenter / team]</a:t>
+            </a:r>
+          </a:p>
+          <a:p>
+            <a:pPr algn="l" marL="0" indent="0">
+              <a:defRPr sz="1700" b="0">
+                <a:solidFill>
+                  <a:srgbClr val="030B20"/>
+                </a:solidFill>
+                <a:latin typeface="Inter"/>
+              </a:defRPr>
+              <a:lnSpc>
+                <a:spcPct val="112000"/>
+              </a:lnSpc>
+              <a:spcAft>
+                <a:spcPts val="1200"/>
+              </a:spcAft>
+              <a:buNone/>
+            </a:pPr>
+            <a:r>
+              <a:t>[Event · date]</a:t>
+            </a:r>
+          </a:p>
+        </p:txBody>
+      </p:sp>
+      <p:sp>
+        <p:nvSpPr>
+          <p:cNvPr id="8" name="Rectangle 7"/>
+          <p:cNvSpPr/>
+          <p:nvPr/>
+        </p:nvSpPr>
+        <p:spPr>
+          <a:xfrm>
+            <a:off x="7818120" y="0"/>
+            <a:ext cx="4379976" cy="6080760"/>
+          </a:xfrm>
+          <a:prstGeom prst="rect">
+            <a:avLst/>
+          </a:prstGeom>
+          <a:solidFill>
+            <a:srgbClr val="082952"/>
+          </a:solidFill>
+          <a:ln>
+            <a:noFill/>
+          </a:ln>
+          <a:effectLst/>
+        </p:spPr>
+        <p:style>
+          <a:lnRef idx="1">
+            <a:schemeClr val="accent1"/>
+          </a:lnRef>
+          <a:fillRef idx="3">
+            <a:schemeClr val="accent1"/>
+          </a:fillRef>
+          <a:effectRef idx="2">
+            <a:schemeClr val="accent1"/>
+          </a:effectRef>
+          <a:fontRef idx="minor">
+            <a:schemeClr val="lt1"/>
+          </a:fontRef>
+        </p:style>
+        <p:txBody>
+          <a:bodyPr rtlCol="0" anchor="ctr"/>
+          <a:lstStyle/>
+          <a:p>
+            <a:pPr algn="ctr"/>
+          </a:p>
+        </p:txBody>
+      </p:sp>
       <p:pic>
         <p:nvPicPr>
-          <p:cNvPr id="8" name="Original Lugano's Plan B mark" descr="Lugano's Plan B original logo; existing mark, not a new Foundation logo"/>
+          <p:cNvPr id="9" name="Original Lugano's Plan B mark" descr="Lugano's Plan B original logo; existing mark, not a new Foundation logo"/>
           <p:cNvPicPr>
             <a:picLocks noChangeAspect="1"/>
           </p:cNvPicPr>
@@ -1716,7 +1799,7 @@
       </p:pic>
       <p:sp>
         <p:nvSpPr>
-          <p:cNvPr id="9" name="Open.&#10;Capable.&#10;Curious.&#10;Grounded."/>
+          <p:cNvPr id="10" name="Open.&#10;Capable.&#10;Curious.&#10;Grounded."/>
           <p:cNvSpPr txBox="1"/>
           <p:nvPr/>
         </p:nvSpPr>
@@ -1819,35 +1902,35 @@
       </p:sp>
       <p:sp>
         <p:nvSpPr>
-          <p:cNvPr id="10" name="Rectangle 9"/>
+          <p:cNvPr id="11" name="Plan B / Network energy gradient"/>
           <p:cNvSpPr/>
           <p:nvPr/>
         </p:nvSpPr>
         <p:spPr>
           <a:xfrm>
-            <a:off x="7818120" y="6016752"/>
-            <a:ext cx="4379976" cy="64008"/>
-          </a:xfrm>
+            <a:off x="7818120" y="5715000"/>
+            <a:ext cx="4379976" cy="365760"/>
+          </a:xfrm>
+          <a:prstGeom prst="rect">
+            <a:avLst/>
+          </a:prstGeom>
           <a:gradFill rotWithShape="1">
             <a:gsLst>
               <a:gs pos="0">
-                <a:srgbClr val="ffb604"/>
+                <a:srgbClr val="FFB604"/>
               </a:gs>
               <a:gs pos="28000">
-                <a:srgbClr val="ff5db1"/>
+                <a:srgbClr val="FF5DB1"/>
               </a:gs>
               <a:gs pos="58000">
-                <a:srgbClr val="7468ff"/>
+                <a:srgbClr val="7468FF"/>
               </a:gs>
               <a:gs pos="100000">
-                <a:srgbClr val="23f5ff"/>
+                <a:srgbClr val="23F5FF"/>
               </a:gs>
             </a:gsLst>
             <a:lin ang="0" scaled="1"/>
           </a:gradFill>
-          <a:prstGeom prst="rect">
-            <a:avLst/>
-          </a:prstGeom>
           <a:ln>
             <a:noFill/>
           </a:ln>
@@ -1890,7 +1973,7 @@
 
 <file path=ppt/slideLayouts/slideLayout10.xml><?xml version="1.0" encoding="utf-8"?>
 <p:sldLayout xmlns:a="http://schemas.openxmlformats.org/drawingml/2006/main" xmlns:r="http://schemas.openxmlformats.org/officeDocument/2006/relationships" xmlns:p="http://schemas.openxmlformats.org/presentationml/2006/main" type="cust" preserve="1" showMasterSp="1">
-  <p:cSld name="Plan B / Template guide">
+  <p:cSld name="Plan B / Light / Template guide">
     <p:bg>
       <p:bgPr>
         <a:solidFill>
@@ -1915,327 +1998,35 @@
       </p:grpSpPr>
       <p:sp>
         <p:nvSpPr>
-          <p:cNvPr id="2" name="Plan B Foundation"/>
-          <p:cNvSpPr txBox="1"/>
-          <p:nvPr/>
-        </p:nvSpPr>
-        <p:spPr>
-          <a:xfrm>
-            <a:off x="594360" y="6382512"/>
-            <a:ext cx="3657600" cy="228600"/>
-          </a:xfrm>
-          <a:prstGeom prst="rect">
-            <a:avLst/>
-          </a:prstGeom>
-          <a:noFill/>
-        </p:spPr>
-        <p:txBody>
-          <a:bodyPr wrap="square" lIns="0" rIns="0" tIns="0" bIns="0">
-            <a:spAutoFit/>
-          </a:bodyPr>
-          <a:lstStyle/>
-          <a:p>
-            <a:pPr algn="l" marL="0" indent="0">
-              <a:defRPr sz="1100" b="1">
-                <a:solidFill>
-                  <a:srgbClr val="082952"/>
-                </a:solidFill>
-                <a:latin typeface="Inter"/>
-              </a:defRPr>
-              <a:lnSpc>
-                <a:spcPct val="112000"/>
-              </a:lnSpc>
-              <a:spcAft>
-                <a:spcPts val="1200"/>
-              </a:spcAft>
-              <a:buNone/>
-            </a:pPr>
-            <a:r>
-              <a:t>Plan B Foundation</a:t>
-            </a:r>
-          </a:p>
-        </p:txBody>
-      </p:sp>
-      <p:sp>
-        <p:nvSpPr>
-          <p:cNvPr id="3" name="Civic Digital Commons"/>
-          <p:cNvSpPr txBox="1"/>
-          <p:nvPr/>
-        </p:nvSpPr>
-        <p:spPr>
-          <a:xfrm>
-            <a:off x="8595360" y="6382512"/>
-            <a:ext cx="2971800" cy="228600"/>
-          </a:xfrm>
-          <a:prstGeom prst="rect">
-            <a:avLst/>
-          </a:prstGeom>
-          <a:noFill/>
-        </p:spPr>
-        <p:txBody>
-          <a:bodyPr wrap="square" lIns="0" rIns="0" tIns="0" bIns="0">
-            <a:spAutoFit/>
-          </a:bodyPr>
-          <a:lstStyle/>
-          <a:p>
-            <a:pPr algn="l" marL="0" indent="0">
-              <a:defRPr sz="1100" b="0">
-                <a:solidFill>
-                  <a:srgbClr val="082952"/>
-                </a:solidFill>
-                <a:latin typeface="Inter"/>
-              </a:defRPr>
-              <a:lnSpc>
-                <a:spcPct val="112000"/>
-              </a:lnSpc>
-              <a:spcAft>
-                <a:spcPts val="1200"/>
-              </a:spcAft>
-              <a:buNone/>
-            </a:pPr>
-            <a:r>
-              <a:t>Civic Digital Commons</a:t>
-            </a:r>
-          </a:p>
-        </p:txBody>
-      </p:sp>
-      <p:sp>
-        <p:nvSpPr>
-          <p:cNvPr id="4" name="Placeholder 0"/>
-          <p:cNvSpPr txBox="1"/>
-          <p:nvPr>
-            <p:ph type="title" idx="0"/>
-          </p:nvPr>
-        </p:nvSpPr>
-        <p:spPr>
-          <a:xfrm>
-            <a:off x="594360" y="502920"/>
-            <a:ext cx="10972800" cy="1005840"/>
-          </a:xfrm>
-          <a:prstGeom prst="rect">
-            <a:avLst/>
-          </a:prstGeom>
-          <a:noFill/>
-        </p:spPr>
-        <p:txBody>
-          <a:bodyPr wrap="square" lIns="0" rIns="0" tIns="0" bIns="0">
-            <a:spAutoFit/>
-          </a:bodyPr>
-          <a:lstStyle/>
-          <a:p>
-            <a:pPr algn="l" marL="0" indent="0">
-              <a:defRPr sz="3600" b="1">
-                <a:solidFill>
-                  <a:srgbClr val="082952"/>
-                </a:solidFill>
-                <a:latin typeface="Inter"/>
-              </a:defRPr>
-              <a:lnSpc>
-                <a:spcPct val="112000"/>
-              </a:lnSpc>
-              <a:spcAft>
-                <a:spcPts val="1200"/>
-              </a:spcAft>
-              <a:buNone/>
-            </a:pPr>
-            <a:r>
-              <a:t>Make it yours. Keep it Plan B.</a:t>
-            </a:r>
-          </a:p>
-        </p:txBody>
-      </p:sp>
-      <p:sp>
-        <p:nvSpPr>
-          <p:cNvPr id="5" name="Placeholder 1"/>
-          <p:cNvSpPr txBox="1"/>
-          <p:nvPr>
-            <p:ph type="body" idx="1"/>
-          </p:nvPr>
-        </p:nvSpPr>
-        <p:spPr>
-          <a:xfrm>
-            <a:off x="594360" y="1508760"/>
-            <a:ext cx="10698480" cy="685800"/>
-          </a:xfrm>
-          <a:prstGeom prst="rect">
-            <a:avLst/>
-          </a:prstGeom>
-          <a:noFill/>
-        </p:spPr>
-        <p:txBody>
-          <a:bodyPr wrap="square" lIns="0" rIns="0" tIns="0" bIns="0">
-            <a:spAutoFit/>
-          </a:bodyPr>
-          <a:lstStyle/>
-          <a:p>
-            <a:pPr algn="l" marL="0" indent="0">
-              <a:defRPr sz="1900" b="0">
-                <a:solidFill>
-                  <a:srgbClr val="030B20"/>
-                </a:solidFill>
-                <a:latin typeface="Inter"/>
-              </a:defRPr>
-              <a:lnSpc>
-                <a:spcPct val="112000"/>
-              </a:lnSpc>
-              <a:spcAft>
-                <a:spcPts val="1200"/>
-              </a:spcAft>
-              <a:buNone/>
-            </a:pPr>
-            <a:r>
-              <a:t>Delete this guidance slide before presenting.</a:t>
-            </a:r>
-          </a:p>
-        </p:txBody>
-      </p:sp>
-      <p:sp>
-        <p:nvSpPr>
-          <p:cNvPr id="6" name="Placeholder 2"/>
-          <p:cNvSpPr txBox="1"/>
-          <p:nvPr>
-            <p:ph type="body" idx="2"/>
-          </p:nvPr>
-        </p:nvSpPr>
-        <p:spPr>
-          <a:xfrm>
-            <a:off x="640080" y="2514600"/>
-            <a:ext cx="5120640" cy="2651760"/>
-          </a:xfrm>
-          <a:prstGeom prst="rect">
-            <a:avLst/>
-          </a:prstGeom>
-          <a:noFill/>
-        </p:spPr>
-        <p:txBody>
-          <a:bodyPr wrap="square" lIns="0" rIns="0" tIns="0" bIns="0">
-            <a:spAutoFit/>
-          </a:bodyPr>
-          <a:lstStyle/>
-          <a:p>
-            <a:pPr algn="l" marL="0" indent="0">
-              <a:defRPr sz="2300" b="0">
-                <a:solidFill>
-                  <a:srgbClr val="030B20"/>
-                </a:solidFill>
-                <a:latin typeface="Inter"/>
-              </a:defRPr>
-              <a:lnSpc>
-                <a:spcPct val="112000"/>
-              </a:lnSpc>
-              <a:spcAft>
-                <a:spcPts val="1200"/>
-              </a:spcAft>
-              <a:buNone/>
-            </a:pPr>
-            <a:r>
-              <a:t>Use the layouts</a:t>
-            </a:r>
-          </a:p>
-          <a:p>
-            <a:pPr algn="l" marL="0" indent="0">
-              <a:defRPr sz="2300" b="0">
-                <a:solidFill>
-                  <a:srgbClr val="030B20"/>
-                </a:solidFill>
-                <a:latin typeface="Inter"/>
-              </a:defRPr>
-              <a:lnSpc>
-                <a:spcPct val="112000"/>
-              </a:lnSpc>
-              <a:spcAft>
-                <a:spcPts val="1200"/>
-              </a:spcAft>
-              <a:buNone/>
-            </a:pPr>
-            <a:r>
-              <a:t>Install Inter, then choose Home → New Slide. Replace bracketed prompts. Duplicate the chart or table example to retain its styling.</a:t>
-            </a:r>
-          </a:p>
-        </p:txBody>
-      </p:sp>
-      <p:sp>
-        <p:nvSpPr>
-          <p:cNvPr id="7" name="Placeholder 3"/>
-          <p:cNvSpPr txBox="1"/>
-          <p:nvPr>
-            <p:ph type="body" idx="3"/>
-          </p:nvPr>
-        </p:nvSpPr>
-        <p:spPr>
-          <a:xfrm>
-            <a:off x="6400800" y="2514600"/>
-            <a:ext cx="5120640" cy="2651760"/>
-          </a:xfrm>
-          <a:prstGeom prst="rect">
-            <a:avLst/>
-          </a:prstGeom>
-          <a:noFill/>
-        </p:spPr>
-        <p:txBody>
-          <a:bodyPr wrap="square" lIns="0" rIns="0" tIns="0" bIns="0">
-            <a:spAutoFit/>
-          </a:bodyPr>
-          <a:lstStyle/>
-          <a:p>
-            <a:pPr algn="l" marL="0" indent="0">
-              <a:defRPr sz="2300" b="0">
-                <a:solidFill>
-                  <a:srgbClr val="030B20"/>
-                </a:solidFill>
-                <a:latin typeface="Inter"/>
-              </a:defRPr>
-              <a:lnSpc>
-                <a:spcPct val="112000"/>
-              </a:lnSpc>
-              <a:spcAft>
-                <a:spcPts val="1200"/>
-              </a:spcAft>
-              <a:buNone/>
-            </a:pPr>
-            <a:r>
-              <a:t>Keep it clear</a:t>
-            </a:r>
-          </a:p>
-          <a:p>
-            <a:pPr algn="l" marL="0" indent="0">
-              <a:defRPr sz="2300" b="0">
-                <a:solidFill>
-                  <a:srgbClr val="030B20"/>
-                </a:solidFill>
-                <a:latin typeface="Inter"/>
-              </a:defRPr>
-              <a:lnSpc>
-                <a:spcPct val="112000"/>
-              </a:lnSpc>
-              <a:spcAft>
-                <a:spcPts val="1200"/>
-              </a:spcAft>
-              <a:buNone/>
-            </a:pPr>
-            <a:r>
-              <a:t>One idea per slide. Use navy and warm white. Choose gold or a small gradient as the exceptional signal. Aim for 20pt or larger body text.</a:t>
-            </a:r>
-          </a:p>
-        </p:txBody>
-      </p:sp>
-      <p:sp>
-        <p:nvSpPr>
-          <p:cNvPr id="8" name="Rectangle 7"/>
+          <p:cNvPr id="2" name="Plan B / Network energy gradient"/>
           <p:cNvSpPr/>
           <p:nvPr/>
         </p:nvSpPr>
         <p:spPr>
           <a:xfrm>
-            <a:off x="640080" y="5486400"/>
-            <a:ext cx="365760" cy="228600"/>
-          </a:xfrm>
-          <a:prstGeom prst="rect">
-            <a:avLst/>
-          </a:prstGeom>
-          <a:solidFill>
-            <a:srgbClr val="082952"/>
-          </a:solidFill>
+            <a:off x="594360" y="6163056"/>
+            <a:ext cx="10972800" cy="91440"/>
+          </a:xfrm>
+          <a:prstGeom prst="rect">
+            <a:avLst/>
+          </a:prstGeom>
+          <a:gradFill rotWithShape="1">
+            <a:gsLst>
+              <a:gs pos="0">
+                <a:srgbClr val="FFB604"/>
+              </a:gs>
+              <a:gs pos="28000">
+                <a:srgbClr val="FF5DB1"/>
+              </a:gs>
+              <a:gs pos="58000">
+                <a:srgbClr val="7468FF"/>
+              </a:gs>
+              <a:gs pos="100000">
+                <a:srgbClr val="23F5FF"/>
+              </a:gs>
+            </a:gsLst>
+            <a:lin ang="0" scaled="1"/>
+          </a:gradFill>
           <a:ln>
             <a:noFill/>
           </a:ln>
@@ -2265,20 +2056,326 @@
       </p:sp>
       <p:sp>
         <p:nvSpPr>
+          <p:cNvPr id="3" name="Plan B Foundation"/>
+          <p:cNvSpPr txBox="1"/>
+          <p:nvPr/>
+        </p:nvSpPr>
+        <p:spPr>
+          <a:xfrm>
+            <a:off x="594360" y="6382512"/>
+            <a:ext cx="3657600" cy="228600"/>
+          </a:xfrm>
+          <a:prstGeom prst="rect">
+            <a:avLst/>
+          </a:prstGeom>
+          <a:noFill/>
+        </p:spPr>
+        <p:txBody>
+          <a:bodyPr wrap="square" lIns="0" rIns="0" tIns="0" bIns="0">
+            <a:spAutoFit/>
+          </a:bodyPr>
+          <a:lstStyle/>
+          <a:p>
+            <a:pPr algn="l" marL="0" indent="0">
+              <a:defRPr sz="1100" b="1">
+                <a:solidFill>
+                  <a:srgbClr val="082952"/>
+                </a:solidFill>
+                <a:latin typeface="Inter"/>
+              </a:defRPr>
+              <a:lnSpc>
+                <a:spcPct val="112000"/>
+              </a:lnSpc>
+              <a:spcAft>
+                <a:spcPts val="1200"/>
+              </a:spcAft>
+              <a:buNone/>
+            </a:pPr>
+            <a:r>
+              <a:t>Plan B Foundation</a:t>
+            </a:r>
+          </a:p>
+        </p:txBody>
+      </p:sp>
+      <p:sp>
+        <p:nvSpPr>
+          <p:cNvPr id="4" name="Civic Digital Commons"/>
+          <p:cNvSpPr txBox="1"/>
+          <p:nvPr/>
+        </p:nvSpPr>
+        <p:spPr>
+          <a:xfrm>
+            <a:off x="8595360" y="6382512"/>
+            <a:ext cx="2971800" cy="228600"/>
+          </a:xfrm>
+          <a:prstGeom prst="rect">
+            <a:avLst/>
+          </a:prstGeom>
+          <a:noFill/>
+        </p:spPr>
+        <p:txBody>
+          <a:bodyPr wrap="square" lIns="0" rIns="0" tIns="0" bIns="0">
+            <a:spAutoFit/>
+          </a:bodyPr>
+          <a:lstStyle/>
+          <a:p>
+            <a:pPr algn="l" marL="0" indent="0">
+              <a:defRPr sz="1100" b="0">
+                <a:solidFill>
+                  <a:srgbClr val="082952"/>
+                </a:solidFill>
+                <a:latin typeface="Inter"/>
+              </a:defRPr>
+              <a:lnSpc>
+                <a:spcPct val="112000"/>
+              </a:lnSpc>
+              <a:spcAft>
+                <a:spcPts val="1200"/>
+              </a:spcAft>
+              <a:buNone/>
+            </a:pPr>
+            <a:r>
+              <a:t>Civic Digital Commons</a:t>
+            </a:r>
+          </a:p>
+        </p:txBody>
+      </p:sp>
+      <p:sp>
+        <p:nvSpPr>
+          <p:cNvPr id="5" name="Placeholder 0"/>
+          <p:cNvSpPr txBox="1"/>
+          <p:nvPr>
+            <p:ph type="title" idx="0"/>
+          </p:nvPr>
+        </p:nvSpPr>
+        <p:spPr>
+          <a:xfrm>
+            <a:off x="594360" y="502920"/>
+            <a:ext cx="10972800" cy="1005840"/>
+          </a:xfrm>
+          <a:prstGeom prst="rect">
+            <a:avLst/>
+          </a:prstGeom>
+          <a:noFill/>
+        </p:spPr>
+        <p:txBody>
+          <a:bodyPr wrap="square" lIns="0" rIns="0" tIns="0" bIns="0">
+            <a:spAutoFit/>
+          </a:bodyPr>
+          <a:lstStyle/>
+          <a:p>
+            <a:pPr algn="l" marL="0" indent="0">
+              <a:defRPr sz="3600" b="1">
+                <a:solidFill>
+                  <a:srgbClr val="082952"/>
+                </a:solidFill>
+                <a:latin typeface="Inter"/>
+              </a:defRPr>
+              <a:lnSpc>
+                <a:spcPct val="112000"/>
+              </a:lnSpc>
+              <a:spcAft>
+                <a:spcPts val="1200"/>
+              </a:spcAft>
+              <a:buNone/>
+            </a:pPr>
+            <a:r>
+              <a:t>Make it yours. Keep it Plan B.</a:t>
+            </a:r>
+          </a:p>
+        </p:txBody>
+      </p:sp>
+      <p:sp>
+        <p:nvSpPr>
+          <p:cNvPr id="6" name="Placeholder 1"/>
+          <p:cNvSpPr txBox="1"/>
+          <p:nvPr>
+            <p:ph type="body" idx="1"/>
+          </p:nvPr>
+        </p:nvSpPr>
+        <p:spPr>
+          <a:xfrm>
+            <a:off x="594360" y="1508760"/>
+            <a:ext cx="10698480" cy="685800"/>
+          </a:xfrm>
+          <a:prstGeom prst="rect">
+            <a:avLst/>
+          </a:prstGeom>
+          <a:noFill/>
+        </p:spPr>
+        <p:txBody>
+          <a:bodyPr wrap="square" lIns="0" rIns="0" tIns="0" bIns="0">
+            <a:spAutoFit/>
+          </a:bodyPr>
+          <a:lstStyle/>
+          <a:p>
+            <a:pPr algn="l" marL="0" indent="0">
+              <a:defRPr sz="1900" b="0">
+                <a:solidFill>
+                  <a:srgbClr val="030B20"/>
+                </a:solidFill>
+                <a:latin typeface="Inter"/>
+              </a:defRPr>
+              <a:lnSpc>
+                <a:spcPct val="112000"/>
+              </a:lnSpc>
+              <a:spcAft>
+                <a:spcPts val="1200"/>
+              </a:spcAft>
+              <a:buNone/>
+            </a:pPr>
+            <a:r>
+              <a:t>Delete this guidance slide before presenting.</a:t>
+            </a:r>
+          </a:p>
+        </p:txBody>
+      </p:sp>
+      <p:sp>
+        <p:nvSpPr>
+          <p:cNvPr id="7" name="Placeholder 2"/>
+          <p:cNvSpPr txBox="1"/>
+          <p:nvPr>
+            <p:ph type="body" idx="2"/>
+          </p:nvPr>
+        </p:nvSpPr>
+        <p:spPr>
+          <a:xfrm>
+            <a:off x="640080" y="2514600"/>
+            <a:ext cx="5120640" cy="2651760"/>
+          </a:xfrm>
+          <a:prstGeom prst="rect">
+            <a:avLst/>
+          </a:prstGeom>
+          <a:noFill/>
+        </p:spPr>
+        <p:txBody>
+          <a:bodyPr wrap="square" lIns="0" rIns="0" tIns="0" bIns="0">
+            <a:spAutoFit/>
+          </a:bodyPr>
+          <a:lstStyle/>
+          <a:p>
+            <a:pPr algn="l" marL="0" indent="0">
+              <a:defRPr sz="2300" b="0">
+                <a:solidFill>
+                  <a:srgbClr val="030B20"/>
+                </a:solidFill>
+                <a:latin typeface="Inter"/>
+              </a:defRPr>
+              <a:lnSpc>
+                <a:spcPct val="112000"/>
+              </a:lnSpc>
+              <a:spcAft>
+                <a:spcPts val="1200"/>
+              </a:spcAft>
+              <a:buNone/>
+            </a:pPr>
+            <a:r>
+              <a:t>Use the layouts</a:t>
+            </a:r>
+          </a:p>
+          <a:p>
+            <a:pPr algn="l" marL="0" indent="0">
+              <a:defRPr sz="2300" b="0">
+                <a:solidFill>
+                  <a:srgbClr val="030B20"/>
+                </a:solidFill>
+                <a:latin typeface="Inter"/>
+              </a:defRPr>
+              <a:lnSpc>
+                <a:spcPct val="112000"/>
+              </a:lnSpc>
+              <a:spcAft>
+                <a:spcPts val="1200"/>
+              </a:spcAft>
+              <a:buNone/>
+            </a:pPr>
+            <a:r>
+              <a:t>Install Inter, then choose Home → New Slide. Replace bracketed prompts. Duplicate the chart or table example to retain its styling.</a:t>
+            </a:r>
+          </a:p>
+        </p:txBody>
+      </p:sp>
+      <p:sp>
+        <p:nvSpPr>
+          <p:cNvPr id="8" name="Placeholder 3"/>
+          <p:cNvSpPr txBox="1"/>
+          <p:nvPr>
+            <p:ph type="body" idx="3"/>
+          </p:nvPr>
+        </p:nvSpPr>
+        <p:spPr>
+          <a:xfrm>
+            <a:off x="6400800" y="2514600"/>
+            <a:ext cx="5120640" cy="2651760"/>
+          </a:xfrm>
+          <a:prstGeom prst="rect">
+            <a:avLst/>
+          </a:prstGeom>
+          <a:noFill/>
+        </p:spPr>
+        <p:txBody>
+          <a:bodyPr wrap="square" lIns="0" rIns="0" tIns="0" bIns="0">
+            <a:spAutoFit/>
+          </a:bodyPr>
+          <a:lstStyle/>
+          <a:p>
+            <a:pPr algn="l" marL="0" indent="0">
+              <a:defRPr sz="2300" b="0">
+                <a:solidFill>
+                  <a:srgbClr val="030B20"/>
+                </a:solidFill>
+                <a:latin typeface="Inter"/>
+              </a:defRPr>
+              <a:lnSpc>
+                <a:spcPct val="112000"/>
+              </a:lnSpc>
+              <a:spcAft>
+                <a:spcPts val="1200"/>
+              </a:spcAft>
+              <a:buNone/>
+            </a:pPr>
+            <a:r>
+              <a:t>Keep it clear</a:t>
+            </a:r>
+          </a:p>
+          <a:p>
+            <a:pPr algn="l" marL="0" indent="0">
+              <a:defRPr sz="2300" b="0">
+                <a:solidFill>
+                  <a:srgbClr val="030B20"/>
+                </a:solidFill>
+                <a:latin typeface="Inter"/>
+              </a:defRPr>
+              <a:lnSpc>
+                <a:spcPct val="112000"/>
+              </a:lnSpc>
+              <a:spcAft>
+                <a:spcPts val="1200"/>
+              </a:spcAft>
+              <a:buNone/>
+            </a:pPr>
+            <a:r>
+              <a:t>One idea per slide. Keep the selected light or dark palette. Preserve the gradient band and keep text on solid grounds. Aim for 20pt or larger body text.</a:t>
+            </a:r>
+          </a:p>
+        </p:txBody>
+      </p:sp>
+      <p:sp>
+        <p:nvSpPr>
           <p:cNvPr id="9" name="Rectangle 8"/>
           <p:cNvSpPr/>
           <p:nvPr/>
         </p:nvSpPr>
         <p:spPr>
           <a:xfrm>
-            <a:off x="1188719" y="5486400"/>
+            <a:off x="640080" y="5486400"/>
             <a:ext cx="365760" cy="228600"/>
           </a:xfrm>
           <a:prstGeom prst="rect">
             <a:avLst/>
           </a:prstGeom>
           <a:solidFill>
-            <a:srgbClr val="4F97E9"/>
+            <a:srgbClr val="082952"/>
           </a:solidFill>
           <a:ln>
             <a:noFill/>
@@ -2315,14 +2412,14 @@
         </p:nvSpPr>
         <p:spPr>
           <a:xfrm>
-            <a:off x="1737360" y="5486400"/>
+            <a:off x="1188719" y="5486400"/>
             <a:ext cx="365760" cy="228600"/>
           </a:xfrm>
           <a:prstGeom prst="rect">
             <a:avLst/>
           </a:prstGeom>
           <a:solidFill>
-            <a:srgbClr val="FFB604"/>
+            <a:srgbClr val="4F97E9"/>
           </a:solidFill>
           <a:ln>
             <a:noFill/>
@@ -2359,14 +2456,14 @@
         </p:nvSpPr>
         <p:spPr>
           <a:xfrm>
-            <a:off x="2286000" y="5486400"/>
+            <a:off x="1737360" y="5486400"/>
             <a:ext cx="365760" cy="228600"/>
           </a:xfrm>
           <a:prstGeom prst="rect">
             <a:avLst/>
           </a:prstGeom>
           <a:solidFill>
-            <a:srgbClr val="FFFEFA"/>
+            <a:srgbClr val="FFB604"/>
           </a:solidFill>
           <a:ln>
             <a:noFill/>
@@ -2397,7 +2494,51 @@
       </p:sp>
       <p:sp>
         <p:nvSpPr>
-          <p:cNvPr id="12" name="Full guidance: plan-b.foundation/brandin"/>
+          <p:cNvPr id="12" name="Rectangle 11"/>
+          <p:cNvSpPr/>
+          <p:nvPr/>
+        </p:nvSpPr>
+        <p:spPr>
+          <a:xfrm>
+            <a:off x="2286000" y="5486400"/>
+            <a:ext cx="365760" cy="228600"/>
+          </a:xfrm>
+          <a:prstGeom prst="rect">
+            <a:avLst/>
+          </a:prstGeom>
+          <a:solidFill>
+            <a:srgbClr val="FFFEFA"/>
+          </a:solidFill>
+          <a:ln>
+            <a:noFill/>
+          </a:ln>
+          <a:effectLst/>
+        </p:spPr>
+        <p:style>
+          <a:lnRef idx="1">
+            <a:schemeClr val="accent1"/>
+          </a:lnRef>
+          <a:fillRef idx="3">
+            <a:schemeClr val="accent1"/>
+          </a:fillRef>
+          <a:effectRef idx="2">
+            <a:schemeClr val="accent1"/>
+          </a:effectRef>
+          <a:fontRef idx="minor">
+            <a:schemeClr val="lt1"/>
+          </a:fontRef>
+        </p:style>
+        <p:txBody>
+          <a:bodyPr rtlCol="0" anchor="ctr"/>
+          <a:lstStyle/>
+          <a:p>
+            <a:pPr algn="ctr"/>
+          </a:p>
+        </p:txBody>
+      </p:sp>
+      <p:sp>
+        <p:nvSpPr>
+          <p:cNvPr id="13" name="Full guidance: plan-b.foundation/brandin"/>
           <p:cNvSpPr txBox="1"/>
           <p:nvPr/>
         </p:nvSpPr>
@@ -2453,7 +2594,7 @@
 
 <file path=ppt/slideLayouts/slideLayout11.xml><?xml version="1.0" encoding="utf-8"?>
 <p:sldLayout xmlns:a="http://schemas.openxmlformats.org/drawingml/2006/main" xmlns:r="http://schemas.openxmlformats.org/officeDocument/2006/relationships" xmlns:p="http://schemas.openxmlformats.org/presentationml/2006/main" type="cust" preserve="1" showMasterSp="1">
-  <p:cSld name="Plan B / Blank">
+  <p:cSld name="Plan B / Light / Blank">
     <p:bg>
       <p:bgPr>
         <a:solidFill>
@@ -2476,6 +2617,64 @@
           <a:chExt cx="0" cy="0"/>
         </a:xfrm>
       </p:grpSpPr>
+      <p:sp>
+        <p:nvSpPr>
+          <p:cNvPr id="2" name="Plan B / Network energy gradient"/>
+          <p:cNvSpPr/>
+          <p:nvPr/>
+        </p:nvSpPr>
+        <p:spPr>
+          <a:xfrm>
+            <a:off x="594360" y="6163056"/>
+            <a:ext cx="10972800" cy="91440"/>
+          </a:xfrm>
+          <a:prstGeom prst="rect">
+            <a:avLst/>
+          </a:prstGeom>
+          <a:gradFill rotWithShape="1">
+            <a:gsLst>
+              <a:gs pos="0">
+                <a:srgbClr val="FFB604"/>
+              </a:gs>
+              <a:gs pos="28000">
+                <a:srgbClr val="FF5DB1"/>
+              </a:gs>
+              <a:gs pos="58000">
+                <a:srgbClr val="7468FF"/>
+              </a:gs>
+              <a:gs pos="100000">
+                <a:srgbClr val="23F5FF"/>
+              </a:gs>
+            </a:gsLst>
+            <a:lin ang="0" scaled="1"/>
+          </a:gradFill>
+          <a:ln>
+            <a:noFill/>
+          </a:ln>
+          <a:effectLst/>
+        </p:spPr>
+        <p:style>
+          <a:lnRef idx="1">
+            <a:schemeClr val="accent1"/>
+          </a:lnRef>
+          <a:fillRef idx="3">
+            <a:schemeClr val="accent1"/>
+          </a:fillRef>
+          <a:effectRef idx="2">
+            <a:schemeClr val="accent1"/>
+          </a:effectRef>
+          <a:fontRef idx="minor">
+            <a:schemeClr val="lt1"/>
+          </a:fontRef>
+        </p:style>
+        <p:txBody>
+          <a:bodyPr rtlCol="0" anchor="ctr"/>
+          <a:lstStyle/>
+          <a:p>
+            <a:pPr algn="ctr"/>
+          </a:p>
+        </p:txBody>
+      </p:sp>
     </p:spTree>
     <p:extLst>
       <p:ext uri="{BB962C8B-B14F-4D97-AF65-F5344CB8AC3E}">
@@ -2491,11 +2690,11 @@
 
 <file path=ppt/slideLayouts/slideLayout2.xml><?xml version="1.0" encoding="utf-8"?>
 <p:sldLayout xmlns:a="http://schemas.openxmlformats.org/drawingml/2006/main" xmlns:r="http://schemas.openxmlformats.org/officeDocument/2006/relationships" xmlns:p="http://schemas.openxmlformats.org/presentationml/2006/main" type="cust" preserve="1" showMasterSp="1">
-  <p:cSld name="Plan B / Section">
+  <p:cSld name="Plan B / Light / Section">
     <p:bg>
       <p:bgPr>
         <a:solidFill>
-          <a:srgbClr val="082952"/>
+          <a:srgbClr val="F3F9FF"/>
         </a:solidFill>
         <a:effectLst/>
       </p:bgPr>
@@ -2516,7 +2715,65 @@
       </p:grpSpPr>
       <p:sp>
         <p:nvSpPr>
-          <p:cNvPr id="2" name="Plan B Foundation"/>
+          <p:cNvPr id="2" name="Plan B / Network energy gradient"/>
+          <p:cNvSpPr/>
+          <p:nvPr/>
+        </p:nvSpPr>
+        <p:spPr>
+          <a:xfrm>
+            <a:off x="594360" y="6163056"/>
+            <a:ext cx="10972800" cy="91440"/>
+          </a:xfrm>
+          <a:prstGeom prst="rect">
+            <a:avLst/>
+          </a:prstGeom>
+          <a:gradFill rotWithShape="1">
+            <a:gsLst>
+              <a:gs pos="0">
+                <a:srgbClr val="FFB604"/>
+              </a:gs>
+              <a:gs pos="28000">
+                <a:srgbClr val="FF5DB1"/>
+              </a:gs>
+              <a:gs pos="58000">
+                <a:srgbClr val="7468FF"/>
+              </a:gs>
+              <a:gs pos="100000">
+                <a:srgbClr val="23F5FF"/>
+              </a:gs>
+            </a:gsLst>
+            <a:lin ang="0" scaled="1"/>
+          </a:gradFill>
+          <a:ln>
+            <a:noFill/>
+          </a:ln>
+          <a:effectLst/>
+        </p:spPr>
+        <p:style>
+          <a:lnRef idx="1">
+            <a:schemeClr val="accent1"/>
+          </a:lnRef>
+          <a:fillRef idx="3">
+            <a:schemeClr val="accent1"/>
+          </a:fillRef>
+          <a:effectRef idx="2">
+            <a:schemeClr val="accent1"/>
+          </a:effectRef>
+          <a:fontRef idx="minor">
+            <a:schemeClr val="lt1"/>
+          </a:fontRef>
+        </p:style>
+        <p:txBody>
+          <a:bodyPr rtlCol="0" anchor="ctr"/>
+          <a:lstStyle/>
+          <a:p>
+            <a:pPr algn="ctr"/>
+          </a:p>
+        </p:txBody>
+      </p:sp>
+      <p:sp>
+        <p:nvSpPr>
+          <p:cNvPr id="3" name="Plan B Foundation"/>
           <p:cNvSpPr txBox="1"/>
           <p:nvPr/>
         </p:nvSpPr>
@@ -2539,7 +2796,7 @@
             <a:pPr algn="l" marL="0" indent="0">
               <a:defRPr sz="1100" b="1">
                 <a:solidFill>
-                  <a:srgbClr val="FFFEFA"/>
+                  <a:srgbClr val="082952"/>
                 </a:solidFill>
                 <a:latin typeface="Inter"/>
               </a:defRPr>
@@ -2559,7 +2816,7 @@
       </p:sp>
       <p:sp>
         <p:nvSpPr>
-          <p:cNvPr id="3" name="Civic Digital Commons"/>
+          <p:cNvPr id="4" name="Civic Digital Commons"/>
           <p:cNvSpPr txBox="1"/>
           <p:nvPr/>
         </p:nvSpPr>
@@ -2582,7 +2839,7 @@
             <a:pPr algn="l" marL="0" indent="0">
               <a:defRPr sz="1100" b="0">
                 <a:solidFill>
-                  <a:srgbClr val="FFFEFA"/>
+                  <a:srgbClr val="082952"/>
                 </a:solidFill>
                 <a:latin typeface="Inter"/>
               </a:defRPr>
@@ -2602,7 +2859,7 @@
       </p:sp>
       <p:sp>
         <p:nvSpPr>
-          <p:cNvPr id="4" name="Placeholder 0"/>
+          <p:cNvPr id="5" name="Placeholder 0"/>
           <p:cNvSpPr txBox="1"/>
           <p:nvPr>
             <p:ph type="title" idx="0"/>
@@ -2627,7 +2884,7 @@
             <a:pPr algn="l" marL="0" indent="0">
               <a:defRPr sz="4800" b="1">
                 <a:solidFill>
-                  <a:srgbClr val="FFFEFA"/>
+                  <a:srgbClr val="082952"/>
                 </a:solidFill>
                 <a:latin typeface="Inter"/>
               </a:defRPr>
@@ -2647,7 +2904,7 @@
       </p:sp>
       <p:sp>
         <p:nvSpPr>
-          <p:cNvPr id="5" name="Placeholder 1"/>
+          <p:cNvPr id="6" name="Placeholder 1"/>
           <p:cNvSpPr txBox="1"/>
           <p:nvPr>
             <p:ph type="body" idx="1"/>
@@ -2672,7 +2929,7 @@
             <a:pPr algn="l" marL="0" indent="0">
               <a:defRPr sz="2500" b="0">
                 <a:solidFill>
-                  <a:srgbClr val="FFFEFA"/>
+                  <a:srgbClr val="030B20"/>
                 </a:solidFill>
                 <a:latin typeface="Inter"/>
               </a:defRPr>
@@ -2692,21 +2949,35 @@
       </p:sp>
       <p:sp>
         <p:nvSpPr>
-          <p:cNvPr id="6" name="Rectangle 5"/>
+          <p:cNvPr id="7" name="Plan B / Network energy gradient"/>
           <p:cNvSpPr/>
           <p:nvPr/>
         </p:nvSpPr>
         <p:spPr>
           <a:xfrm>
-            <a:off x="777240" y="1325880"/>
-            <a:ext cx="594360" cy="73152"/>
-          </a:xfrm>
-          <a:prstGeom prst="rect">
-            <a:avLst/>
-          </a:prstGeom>
-          <a:solidFill>
-            <a:srgbClr val="FFB604"/>
-          </a:solidFill>
+            <a:off x="777240" y="1234440"/>
+            <a:ext cx="3291840" cy="201168"/>
+          </a:xfrm>
+          <a:prstGeom prst="rect">
+            <a:avLst/>
+          </a:prstGeom>
+          <a:gradFill rotWithShape="1">
+            <a:gsLst>
+              <a:gs pos="0">
+                <a:srgbClr val="FFB604"/>
+              </a:gs>
+              <a:gs pos="28000">
+                <a:srgbClr val="FF5DB1"/>
+              </a:gs>
+              <a:gs pos="58000">
+                <a:srgbClr val="7468FF"/>
+              </a:gs>
+              <a:gs pos="100000">
+                <a:srgbClr val="23F5FF"/>
+              </a:gs>
+            </a:gsLst>
+            <a:lin ang="0" scaled="1"/>
+          </a:gradFill>
           <a:ln>
             <a:noFill/>
           </a:ln>
@@ -2749,7 +3020,7 @@
 
 <file path=ppt/slideLayouts/slideLayout3.xml><?xml version="1.0" encoding="utf-8"?>
 <p:sldLayout xmlns:a="http://schemas.openxmlformats.org/drawingml/2006/main" xmlns:r="http://schemas.openxmlformats.org/officeDocument/2006/relationships" xmlns:p="http://schemas.openxmlformats.org/presentationml/2006/main" type="cust" preserve="1" showMasterSp="1">
-  <p:cSld name="Plan B / Title and content">
+  <p:cSld name="Plan B / Light / Title and content">
     <p:bg>
       <p:bgPr>
         <a:solidFill>
@@ -2774,282 +3045,35 @@
       </p:grpSpPr>
       <p:sp>
         <p:nvSpPr>
-          <p:cNvPr id="2" name="Plan B Foundation"/>
-          <p:cNvSpPr txBox="1"/>
-          <p:nvPr/>
-        </p:nvSpPr>
-        <p:spPr>
-          <a:xfrm>
-            <a:off x="594360" y="6382512"/>
-            <a:ext cx="3657600" cy="228600"/>
-          </a:xfrm>
-          <a:prstGeom prst="rect">
-            <a:avLst/>
-          </a:prstGeom>
-          <a:noFill/>
-        </p:spPr>
-        <p:txBody>
-          <a:bodyPr wrap="square" lIns="0" rIns="0" tIns="0" bIns="0">
-            <a:spAutoFit/>
-          </a:bodyPr>
-          <a:lstStyle/>
-          <a:p>
-            <a:pPr algn="l" marL="0" indent="0">
-              <a:defRPr sz="1100" b="1">
-                <a:solidFill>
-                  <a:srgbClr val="082952"/>
-                </a:solidFill>
-                <a:latin typeface="Inter"/>
-              </a:defRPr>
-              <a:lnSpc>
-                <a:spcPct val="112000"/>
-              </a:lnSpc>
-              <a:spcAft>
-                <a:spcPts val="1200"/>
-              </a:spcAft>
-              <a:buNone/>
-            </a:pPr>
-            <a:r>
-              <a:t>Plan B Foundation</a:t>
-            </a:r>
-          </a:p>
-        </p:txBody>
-      </p:sp>
-      <p:sp>
-        <p:nvSpPr>
-          <p:cNvPr id="3" name="Civic Digital Commons"/>
-          <p:cNvSpPr txBox="1"/>
-          <p:nvPr/>
-        </p:nvSpPr>
-        <p:spPr>
-          <a:xfrm>
-            <a:off x="8595360" y="6382512"/>
-            <a:ext cx="2971800" cy="228600"/>
-          </a:xfrm>
-          <a:prstGeom prst="rect">
-            <a:avLst/>
-          </a:prstGeom>
-          <a:noFill/>
-        </p:spPr>
-        <p:txBody>
-          <a:bodyPr wrap="square" lIns="0" rIns="0" tIns="0" bIns="0">
-            <a:spAutoFit/>
-          </a:bodyPr>
-          <a:lstStyle/>
-          <a:p>
-            <a:pPr algn="l" marL="0" indent="0">
-              <a:defRPr sz="1100" b="0">
-                <a:solidFill>
-                  <a:srgbClr val="082952"/>
-                </a:solidFill>
-                <a:latin typeface="Inter"/>
-              </a:defRPr>
-              <a:lnSpc>
-                <a:spcPct val="112000"/>
-              </a:lnSpc>
-              <a:spcAft>
-                <a:spcPts val="1200"/>
-              </a:spcAft>
-              <a:buNone/>
-            </a:pPr>
-            <a:r>
-              <a:t>Civic Digital Commons</a:t>
-            </a:r>
-          </a:p>
-        </p:txBody>
-      </p:sp>
-      <p:sp>
-        <p:nvSpPr>
-          <p:cNvPr id="4" name="Placeholder 0"/>
-          <p:cNvSpPr txBox="1"/>
-          <p:nvPr>
-            <p:ph type="title" idx="0"/>
-          </p:nvPr>
-        </p:nvSpPr>
-        <p:spPr>
-          <a:xfrm>
-            <a:off x="594360" y="502920"/>
-            <a:ext cx="10972800" cy="1005840"/>
-          </a:xfrm>
-          <a:prstGeom prst="rect">
-            <a:avLst/>
-          </a:prstGeom>
-          <a:noFill/>
-        </p:spPr>
-        <p:txBody>
-          <a:bodyPr wrap="square" lIns="0" rIns="0" tIns="0" bIns="0">
-            <a:spAutoFit/>
-          </a:bodyPr>
-          <a:lstStyle/>
-          <a:p>
-            <a:pPr algn="l" marL="0" indent="0">
-              <a:defRPr sz="3600" b="1">
-                <a:solidFill>
-                  <a:srgbClr val="082952"/>
-                </a:solidFill>
-                <a:latin typeface="Inter"/>
-              </a:defRPr>
-              <a:lnSpc>
-                <a:spcPct val="112000"/>
-              </a:lnSpc>
-              <a:spcAft>
-                <a:spcPts val="1200"/>
-              </a:spcAft>
-              <a:buNone/>
-            </a:pPr>
-            <a:r>
-              <a:t>[Lead with the point]</a:t>
-            </a:r>
-          </a:p>
-        </p:txBody>
-      </p:sp>
-      <p:sp>
-        <p:nvSpPr>
-          <p:cNvPr id="5" name="Placeholder 1"/>
-          <p:cNvSpPr txBox="1"/>
-          <p:nvPr>
-            <p:ph type="body" idx="1"/>
-          </p:nvPr>
-        </p:nvSpPr>
-        <p:spPr>
-          <a:xfrm>
-            <a:off x="594360" y="1508760"/>
-            <a:ext cx="10698480" cy="685800"/>
-          </a:xfrm>
-          <a:prstGeom prst="rect">
-            <a:avLst/>
-          </a:prstGeom>
-          <a:noFill/>
-        </p:spPr>
-        <p:txBody>
-          <a:bodyPr wrap="square" lIns="0" rIns="0" tIns="0" bIns="0">
-            <a:spAutoFit/>
-          </a:bodyPr>
-          <a:lstStyle/>
-          <a:p>
-            <a:pPr algn="l" marL="0" indent="0">
-              <a:defRPr sz="1900" b="0">
-                <a:solidFill>
-                  <a:srgbClr val="030B20"/>
-                </a:solidFill>
-                <a:latin typeface="Inter"/>
-              </a:defRPr>
-              <a:lnSpc>
-                <a:spcPct val="112000"/>
-              </a:lnSpc>
-              <a:spcAft>
-                <a:spcPts val="1200"/>
-              </a:spcAft>
-              <a:buNone/>
-            </a:pPr>
-            <a:r>
-              <a:t>[Explain why this matters to the audience]</a:t>
-            </a:r>
-          </a:p>
-        </p:txBody>
-      </p:sp>
-      <p:sp>
-        <p:nvSpPr>
-          <p:cNvPr id="6" name="Placeholder 2"/>
-          <p:cNvSpPr txBox="1"/>
-          <p:nvPr>
-            <p:ph type="body" idx="2"/>
-          </p:nvPr>
-        </p:nvSpPr>
-        <p:spPr>
-          <a:xfrm>
-            <a:off x="777240" y="2606040"/>
-            <a:ext cx="10332720" cy="2651760"/>
-          </a:xfrm>
-          <a:prstGeom prst="rect">
-            <a:avLst/>
-          </a:prstGeom>
-          <a:noFill/>
-        </p:spPr>
-        <p:txBody>
-          <a:bodyPr wrap="square" lIns="0" rIns="0" tIns="0" bIns="0">
-            <a:spAutoFit/>
-          </a:bodyPr>
-          <a:lstStyle/>
-          <a:p>
-            <a:pPr algn="l" marL="0" indent="0">
-              <a:defRPr sz="2700" b="0">
-                <a:solidFill>
-                  <a:srgbClr val="030B20"/>
-                </a:solidFill>
-                <a:latin typeface="Inter"/>
-              </a:defRPr>
-              <a:lnSpc>
-                <a:spcPct val="112000"/>
-              </a:lnSpc>
-              <a:spcAft>
-                <a:spcPts val="1200"/>
-              </a:spcAft>
-              <a:buNone/>
-            </a:pPr>
-            <a:r>
-              <a:t>[First idea — one concise sentence]</a:t>
-            </a:r>
-          </a:p>
-          <a:p>
-            <a:pPr algn="l" marL="0" indent="0">
-              <a:defRPr sz="2700" b="0">
-                <a:solidFill>
-                  <a:srgbClr val="030B20"/>
-                </a:solidFill>
-                <a:latin typeface="Inter"/>
-              </a:defRPr>
-              <a:lnSpc>
-                <a:spcPct val="112000"/>
-              </a:lnSpc>
-              <a:spcAft>
-                <a:spcPts val="1200"/>
-              </a:spcAft>
-              <a:buNone/>
-            </a:pPr>
-            <a:r>
-              <a:t>[Second idea — one concise sentence]</a:t>
-            </a:r>
-          </a:p>
-          <a:p>
-            <a:pPr algn="l" marL="0" indent="0">
-              <a:defRPr sz="2700" b="0">
-                <a:solidFill>
-                  <a:srgbClr val="030B20"/>
-                </a:solidFill>
-                <a:latin typeface="Inter"/>
-              </a:defRPr>
-              <a:lnSpc>
-                <a:spcPct val="112000"/>
-              </a:lnSpc>
-              <a:spcAft>
-                <a:spcPts val="1200"/>
-              </a:spcAft>
-              <a:buNone/>
-            </a:pPr>
-            <a:r>
-              <a:t>[Third idea — one concise sentence]</a:t>
-            </a:r>
-          </a:p>
-        </p:txBody>
-      </p:sp>
-      <p:sp>
-        <p:nvSpPr>
-          <p:cNvPr id="7" name="Rectangle 6"/>
+          <p:cNvPr id="2" name="Plan B / Network energy gradient"/>
           <p:cNvSpPr/>
           <p:nvPr/>
         </p:nvSpPr>
         <p:spPr>
           <a:xfrm>
-            <a:off x="594360" y="2487168"/>
-            <a:ext cx="64008" cy="2377440"/>
-          </a:xfrm>
-          <a:prstGeom prst="rect">
-            <a:avLst/>
-          </a:prstGeom>
-          <a:solidFill>
-            <a:srgbClr val="4F97E9"/>
-          </a:solidFill>
+            <a:off x="594360" y="6163056"/>
+            <a:ext cx="10972800" cy="91440"/>
+          </a:xfrm>
+          <a:prstGeom prst="rect">
+            <a:avLst/>
+          </a:prstGeom>
+          <a:gradFill rotWithShape="1">
+            <a:gsLst>
+              <a:gs pos="0">
+                <a:srgbClr val="FFB604"/>
+              </a:gs>
+              <a:gs pos="28000">
+                <a:srgbClr val="FF5DB1"/>
+              </a:gs>
+              <a:gs pos="58000">
+                <a:srgbClr val="7468FF"/>
+              </a:gs>
+              <a:gs pos="100000">
+                <a:srgbClr val="23F5FF"/>
+              </a:gs>
+            </a:gsLst>
+            <a:lin ang="0" scaled="1"/>
+          </a:gradFill>
           <a:ln>
             <a:noFill/>
           </a:ln>
@@ -3074,6 +3098,267 @@
           <a:lstStyle/>
           <a:p>
             <a:pPr algn="ctr"/>
+          </a:p>
+        </p:txBody>
+      </p:sp>
+      <p:sp>
+        <p:nvSpPr>
+          <p:cNvPr id="3" name="Plan B Foundation"/>
+          <p:cNvSpPr txBox="1"/>
+          <p:nvPr/>
+        </p:nvSpPr>
+        <p:spPr>
+          <a:xfrm>
+            <a:off x="594360" y="6382512"/>
+            <a:ext cx="3657600" cy="228600"/>
+          </a:xfrm>
+          <a:prstGeom prst="rect">
+            <a:avLst/>
+          </a:prstGeom>
+          <a:noFill/>
+        </p:spPr>
+        <p:txBody>
+          <a:bodyPr wrap="square" lIns="0" rIns="0" tIns="0" bIns="0">
+            <a:spAutoFit/>
+          </a:bodyPr>
+          <a:lstStyle/>
+          <a:p>
+            <a:pPr algn="l" marL="0" indent="0">
+              <a:defRPr sz="1100" b="1">
+                <a:solidFill>
+                  <a:srgbClr val="082952"/>
+                </a:solidFill>
+                <a:latin typeface="Inter"/>
+              </a:defRPr>
+              <a:lnSpc>
+                <a:spcPct val="112000"/>
+              </a:lnSpc>
+              <a:spcAft>
+                <a:spcPts val="1200"/>
+              </a:spcAft>
+              <a:buNone/>
+            </a:pPr>
+            <a:r>
+              <a:t>Plan B Foundation</a:t>
+            </a:r>
+          </a:p>
+        </p:txBody>
+      </p:sp>
+      <p:sp>
+        <p:nvSpPr>
+          <p:cNvPr id="4" name="Civic Digital Commons"/>
+          <p:cNvSpPr txBox="1"/>
+          <p:nvPr/>
+        </p:nvSpPr>
+        <p:spPr>
+          <a:xfrm>
+            <a:off x="8595360" y="6382512"/>
+            <a:ext cx="2971800" cy="228600"/>
+          </a:xfrm>
+          <a:prstGeom prst="rect">
+            <a:avLst/>
+          </a:prstGeom>
+          <a:noFill/>
+        </p:spPr>
+        <p:txBody>
+          <a:bodyPr wrap="square" lIns="0" rIns="0" tIns="0" bIns="0">
+            <a:spAutoFit/>
+          </a:bodyPr>
+          <a:lstStyle/>
+          <a:p>
+            <a:pPr algn="l" marL="0" indent="0">
+              <a:defRPr sz="1100" b="0">
+                <a:solidFill>
+                  <a:srgbClr val="082952"/>
+                </a:solidFill>
+                <a:latin typeface="Inter"/>
+              </a:defRPr>
+              <a:lnSpc>
+                <a:spcPct val="112000"/>
+              </a:lnSpc>
+              <a:spcAft>
+                <a:spcPts val="1200"/>
+              </a:spcAft>
+              <a:buNone/>
+            </a:pPr>
+            <a:r>
+              <a:t>Civic Digital Commons</a:t>
+            </a:r>
+          </a:p>
+        </p:txBody>
+      </p:sp>
+      <p:sp>
+        <p:nvSpPr>
+          <p:cNvPr id="5" name="Placeholder 0"/>
+          <p:cNvSpPr txBox="1"/>
+          <p:nvPr>
+            <p:ph type="title" idx="0"/>
+          </p:nvPr>
+        </p:nvSpPr>
+        <p:spPr>
+          <a:xfrm>
+            <a:off x="594360" y="502920"/>
+            <a:ext cx="10972800" cy="1005840"/>
+          </a:xfrm>
+          <a:prstGeom prst="rect">
+            <a:avLst/>
+          </a:prstGeom>
+          <a:noFill/>
+        </p:spPr>
+        <p:txBody>
+          <a:bodyPr wrap="square" lIns="0" rIns="0" tIns="0" bIns="0">
+            <a:spAutoFit/>
+          </a:bodyPr>
+          <a:lstStyle/>
+          <a:p>
+            <a:pPr algn="l" marL="0" indent="0">
+              <a:defRPr sz="3600" b="1">
+                <a:solidFill>
+                  <a:srgbClr val="082952"/>
+                </a:solidFill>
+                <a:latin typeface="Inter"/>
+              </a:defRPr>
+              <a:lnSpc>
+                <a:spcPct val="112000"/>
+              </a:lnSpc>
+              <a:spcAft>
+                <a:spcPts val="1200"/>
+              </a:spcAft>
+              <a:buNone/>
+            </a:pPr>
+            <a:r>
+              <a:t>[Lead with the point]</a:t>
+            </a:r>
+          </a:p>
+        </p:txBody>
+      </p:sp>
+      <p:sp>
+        <p:nvSpPr>
+          <p:cNvPr id="6" name="Placeholder 1"/>
+          <p:cNvSpPr txBox="1"/>
+          <p:nvPr>
+            <p:ph type="body" idx="1"/>
+          </p:nvPr>
+        </p:nvSpPr>
+        <p:spPr>
+          <a:xfrm>
+            <a:off x="594360" y="1508760"/>
+            <a:ext cx="10698480" cy="685800"/>
+          </a:xfrm>
+          <a:prstGeom prst="rect">
+            <a:avLst/>
+          </a:prstGeom>
+          <a:noFill/>
+        </p:spPr>
+        <p:txBody>
+          <a:bodyPr wrap="square" lIns="0" rIns="0" tIns="0" bIns="0">
+            <a:spAutoFit/>
+          </a:bodyPr>
+          <a:lstStyle/>
+          <a:p>
+            <a:pPr algn="l" marL="0" indent="0">
+              <a:defRPr sz="1900" b="0">
+                <a:solidFill>
+                  <a:srgbClr val="030B20"/>
+                </a:solidFill>
+                <a:latin typeface="Inter"/>
+              </a:defRPr>
+              <a:lnSpc>
+                <a:spcPct val="112000"/>
+              </a:lnSpc>
+              <a:spcAft>
+                <a:spcPts val="1200"/>
+              </a:spcAft>
+              <a:buNone/>
+            </a:pPr>
+            <a:r>
+              <a:t>[Explain why this matters to the audience]</a:t>
+            </a:r>
+          </a:p>
+        </p:txBody>
+      </p:sp>
+      <p:sp>
+        <p:nvSpPr>
+          <p:cNvPr id="7" name="Placeholder 2"/>
+          <p:cNvSpPr txBox="1"/>
+          <p:nvPr>
+            <p:ph type="body" idx="2"/>
+          </p:nvPr>
+        </p:nvSpPr>
+        <p:spPr>
+          <a:xfrm>
+            <a:off x="777240" y="2606040"/>
+            <a:ext cx="10332720" cy="2651760"/>
+          </a:xfrm>
+          <a:prstGeom prst="rect">
+            <a:avLst/>
+          </a:prstGeom>
+          <a:noFill/>
+        </p:spPr>
+        <p:txBody>
+          <a:bodyPr wrap="square" lIns="0" rIns="0" tIns="0" bIns="0">
+            <a:spAutoFit/>
+          </a:bodyPr>
+          <a:lstStyle/>
+          <a:p>
+            <a:pPr algn="l" marL="0" indent="0">
+              <a:defRPr sz="2700" b="0">
+                <a:solidFill>
+                  <a:srgbClr val="030B20"/>
+                </a:solidFill>
+                <a:latin typeface="Inter"/>
+              </a:defRPr>
+              <a:lnSpc>
+                <a:spcPct val="112000"/>
+              </a:lnSpc>
+              <a:spcAft>
+                <a:spcPts val="1200"/>
+              </a:spcAft>
+              <a:buNone/>
+            </a:pPr>
+            <a:r>
+              <a:t>[First idea — one concise sentence]</a:t>
+            </a:r>
+          </a:p>
+          <a:p>
+            <a:pPr algn="l" marL="0" indent="0">
+              <a:defRPr sz="2700" b="0">
+                <a:solidFill>
+                  <a:srgbClr val="030B20"/>
+                </a:solidFill>
+                <a:latin typeface="Inter"/>
+              </a:defRPr>
+              <a:lnSpc>
+                <a:spcPct val="112000"/>
+              </a:lnSpc>
+              <a:spcAft>
+                <a:spcPts val="1200"/>
+              </a:spcAft>
+              <a:buNone/>
+            </a:pPr>
+            <a:r>
+              <a:t>[Second idea — one concise sentence]</a:t>
+            </a:r>
+          </a:p>
+          <a:p>
+            <a:pPr algn="l" marL="0" indent="0">
+              <a:defRPr sz="2700" b="0">
+                <a:solidFill>
+                  <a:srgbClr val="030B20"/>
+                </a:solidFill>
+                <a:latin typeface="Inter"/>
+              </a:defRPr>
+              <a:lnSpc>
+                <a:spcPct val="112000"/>
+              </a:lnSpc>
+              <a:spcAft>
+                <a:spcPts val="1200"/>
+              </a:spcAft>
+              <a:buNone/>
+            </a:pPr>
+            <a:r>
+              <a:t>[Third idea — one concise sentence]</a:t>
+            </a:r>
           </a:p>
         </p:txBody>
       </p:sp>
@@ -3092,7 +3377,7 @@
 
 <file path=ppt/slideLayouts/slideLayout4.xml><?xml version="1.0" encoding="utf-8"?>
 <p:sldLayout xmlns:a="http://schemas.openxmlformats.org/drawingml/2006/main" xmlns:r="http://schemas.openxmlformats.org/officeDocument/2006/relationships" xmlns:p="http://schemas.openxmlformats.org/presentationml/2006/main" type="cust" preserve="1" showMasterSp="1">
-  <p:cSld name="Plan B / Two columns">
+  <p:cSld name="Plan B / Light / Two columns">
     <p:bg>
       <p:bgPr>
         <a:solidFill>
@@ -3117,7 +3402,65 @@
       </p:grpSpPr>
       <p:sp>
         <p:nvSpPr>
-          <p:cNvPr id="2" name="Plan B Foundation"/>
+          <p:cNvPr id="2" name="Plan B / Network energy gradient"/>
+          <p:cNvSpPr/>
+          <p:nvPr/>
+        </p:nvSpPr>
+        <p:spPr>
+          <a:xfrm>
+            <a:off x="594360" y="6163056"/>
+            <a:ext cx="10972800" cy="91440"/>
+          </a:xfrm>
+          <a:prstGeom prst="rect">
+            <a:avLst/>
+          </a:prstGeom>
+          <a:gradFill rotWithShape="1">
+            <a:gsLst>
+              <a:gs pos="0">
+                <a:srgbClr val="FFB604"/>
+              </a:gs>
+              <a:gs pos="28000">
+                <a:srgbClr val="FF5DB1"/>
+              </a:gs>
+              <a:gs pos="58000">
+                <a:srgbClr val="7468FF"/>
+              </a:gs>
+              <a:gs pos="100000">
+                <a:srgbClr val="23F5FF"/>
+              </a:gs>
+            </a:gsLst>
+            <a:lin ang="0" scaled="1"/>
+          </a:gradFill>
+          <a:ln>
+            <a:noFill/>
+          </a:ln>
+          <a:effectLst/>
+        </p:spPr>
+        <p:style>
+          <a:lnRef idx="1">
+            <a:schemeClr val="accent1"/>
+          </a:lnRef>
+          <a:fillRef idx="3">
+            <a:schemeClr val="accent1"/>
+          </a:fillRef>
+          <a:effectRef idx="2">
+            <a:schemeClr val="accent1"/>
+          </a:effectRef>
+          <a:fontRef idx="minor">
+            <a:schemeClr val="lt1"/>
+          </a:fontRef>
+        </p:style>
+        <p:txBody>
+          <a:bodyPr rtlCol="0" anchor="ctr"/>
+          <a:lstStyle/>
+          <a:p>
+            <a:pPr algn="ctr"/>
+          </a:p>
+        </p:txBody>
+      </p:sp>
+      <p:sp>
+        <p:nvSpPr>
+          <p:cNvPr id="3" name="Plan B Foundation"/>
           <p:cNvSpPr txBox="1"/>
           <p:nvPr/>
         </p:nvSpPr>
@@ -3160,7 +3503,7 @@
       </p:sp>
       <p:sp>
         <p:nvSpPr>
-          <p:cNvPr id="3" name="Civic Digital Commons"/>
+          <p:cNvPr id="4" name="Civic Digital Commons"/>
           <p:cNvSpPr txBox="1"/>
           <p:nvPr/>
         </p:nvSpPr>
@@ -3203,7 +3546,7 @@
       </p:sp>
       <p:sp>
         <p:nvSpPr>
-          <p:cNvPr id="4" name="Placeholder 0"/>
+          <p:cNvPr id="5" name="Placeholder 0"/>
           <p:cNvSpPr txBox="1"/>
           <p:nvPr>
             <p:ph type="title" idx="0"/>
@@ -3248,7 +3591,7 @@
       </p:sp>
       <p:sp>
         <p:nvSpPr>
-          <p:cNvPr id="5" name="Placeholder 1"/>
+          <p:cNvPr id="6" name="Placeholder 1"/>
           <p:cNvSpPr txBox="1"/>
           <p:nvPr>
             <p:ph type="body" idx="1"/>
@@ -3293,7 +3636,7 @@
       </p:sp>
       <p:sp>
         <p:nvSpPr>
-          <p:cNvPr id="6" name="Placeholder 2"/>
+          <p:cNvPr id="7" name="Placeholder 2"/>
           <p:cNvSpPr txBox="1"/>
           <p:nvPr>
             <p:ph type="body" idx="2"/>
@@ -3338,7 +3681,7 @@
       </p:sp>
       <p:sp>
         <p:nvSpPr>
-          <p:cNvPr id="7" name="Placeholder 3"/>
+          <p:cNvPr id="8" name="Placeholder 3"/>
           <p:cNvSpPr txBox="1"/>
           <p:nvPr>
             <p:ph type="body" idx="3"/>
@@ -3383,7 +3726,7 @@
       </p:sp>
       <p:sp>
         <p:nvSpPr>
-          <p:cNvPr id="8" name="Placeholder 4"/>
+          <p:cNvPr id="9" name="Placeholder 4"/>
           <p:cNvSpPr txBox="1"/>
           <p:nvPr>
             <p:ph type="body" idx="4"/>
@@ -3428,7 +3771,7 @@
       </p:sp>
       <p:sp>
         <p:nvSpPr>
-          <p:cNvPr id="9" name="Rectangle 8"/>
+          <p:cNvPr id="10" name="Rectangle 9"/>
           <p:cNvSpPr/>
           <p:nvPr/>
         </p:nvSpPr>
@@ -3441,7 +3784,7 @@
             <a:avLst/>
           </a:prstGeom>
           <a:solidFill>
-            <a:srgbClr val="B0D3F1"/>
+            <a:srgbClr val="DCEAF6"/>
           </a:solidFill>
           <a:ln>
             <a:noFill/>
@@ -3485,7 +3828,7 @@
 
 <file path=ppt/slideLayouts/slideLayout5.xml><?xml version="1.0" encoding="utf-8"?>
 <p:sldLayout xmlns:a="http://schemas.openxmlformats.org/drawingml/2006/main" xmlns:r="http://schemas.openxmlformats.org/officeDocument/2006/relationships" xmlns:p="http://schemas.openxmlformats.org/presentationml/2006/main" type="cust" preserve="1" showMasterSp="1">
-  <p:cSld name="Plan B / Image and story">
+  <p:cSld name="Plan B / Light / Image and story">
     <p:bg>
       <p:bgPr>
         <a:solidFill>
@@ -3510,154 +3853,35 @@
       </p:grpSpPr>
       <p:sp>
         <p:nvSpPr>
-          <p:cNvPr id="2" name="Plan B Foundation"/>
-          <p:cNvSpPr txBox="1"/>
-          <p:nvPr/>
-        </p:nvSpPr>
-        <p:spPr>
-          <a:xfrm>
-            <a:off x="594360" y="6382512"/>
-            <a:ext cx="3657600" cy="228600"/>
-          </a:xfrm>
-          <a:prstGeom prst="rect">
-            <a:avLst/>
-          </a:prstGeom>
-          <a:noFill/>
-        </p:spPr>
-        <p:txBody>
-          <a:bodyPr wrap="square" lIns="0" rIns="0" tIns="0" bIns="0">
-            <a:spAutoFit/>
-          </a:bodyPr>
-          <a:lstStyle/>
-          <a:p>
-            <a:pPr algn="l" marL="0" indent="0">
-              <a:defRPr sz="1100" b="1">
-                <a:solidFill>
-                  <a:srgbClr val="082952"/>
-                </a:solidFill>
-                <a:latin typeface="Inter"/>
-              </a:defRPr>
-              <a:lnSpc>
-                <a:spcPct val="112000"/>
-              </a:lnSpc>
-              <a:spcAft>
-                <a:spcPts val="1200"/>
-              </a:spcAft>
-              <a:buNone/>
-            </a:pPr>
-            <a:r>
-              <a:t>Plan B Foundation</a:t>
-            </a:r>
-          </a:p>
-        </p:txBody>
-      </p:sp>
-      <p:sp>
-        <p:nvSpPr>
-          <p:cNvPr id="3" name="Civic Digital Commons"/>
-          <p:cNvSpPr txBox="1"/>
-          <p:nvPr/>
-        </p:nvSpPr>
-        <p:spPr>
-          <a:xfrm>
-            <a:off x="8595360" y="6382512"/>
-            <a:ext cx="2971800" cy="228600"/>
-          </a:xfrm>
-          <a:prstGeom prst="rect">
-            <a:avLst/>
-          </a:prstGeom>
-          <a:noFill/>
-        </p:spPr>
-        <p:txBody>
-          <a:bodyPr wrap="square" lIns="0" rIns="0" tIns="0" bIns="0">
-            <a:spAutoFit/>
-          </a:bodyPr>
-          <a:lstStyle/>
-          <a:p>
-            <a:pPr algn="l" marL="0" indent="0">
-              <a:defRPr sz="1100" b="0">
-                <a:solidFill>
-                  <a:srgbClr val="082952"/>
-                </a:solidFill>
-                <a:latin typeface="Inter"/>
-              </a:defRPr>
-              <a:lnSpc>
-                <a:spcPct val="112000"/>
-              </a:lnSpc>
-              <a:spcAft>
-                <a:spcPts val="1200"/>
-              </a:spcAft>
-              <a:buNone/>
-            </a:pPr>
-            <a:r>
-              <a:t>Civic Digital Commons</a:t>
-            </a:r>
-          </a:p>
-        </p:txBody>
-      </p:sp>
-      <p:sp>
-        <p:nvSpPr>
-          <p:cNvPr id="4" name="Placeholder 0"/>
-          <p:cNvSpPr txBox="1"/>
-          <p:nvPr>
-            <p:ph type="title" idx="0"/>
-          </p:nvPr>
-        </p:nvSpPr>
-        <p:spPr>
-          <a:xfrm>
-            <a:off x="594360" y="502920"/>
-            <a:ext cx="10972800" cy="1005840"/>
-          </a:xfrm>
-          <a:prstGeom prst="rect">
-            <a:avLst/>
-          </a:prstGeom>
-          <a:noFill/>
-        </p:spPr>
-        <p:txBody>
-          <a:bodyPr wrap="square" lIns="0" rIns="0" tIns="0" bIns="0">
-            <a:spAutoFit/>
-          </a:bodyPr>
-          <a:lstStyle/>
-          <a:p>
-            <a:pPr algn="l" marL="0" indent="0">
-              <a:defRPr sz="3600" b="1">
-                <a:solidFill>
-                  <a:srgbClr val="082952"/>
-                </a:solidFill>
-                <a:latin typeface="Inter"/>
-              </a:defRPr>
-              <a:lnSpc>
-                <a:spcPct val="112000"/>
-              </a:lnSpc>
-              <a:spcAft>
-                <a:spcPts val="1200"/>
-              </a:spcAft>
-              <a:buNone/>
-            </a:pPr>
-            <a:r>
-              <a:t>[Make the place visible]</a:t>
-            </a:r>
-          </a:p>
-        </p:txBody>
-      </p:sp>
-      <p:sp>
-        <p:nvSpPr>
-          <p:cNvPr id="5" name="Rounded Rectangle 4"/>
+          <p:cNvPr id="2" name="Plan B / Network energy gradient"/>
           <p:cNvSpPr/>
           <p:nvPr/>
         </p:nvSpPr>
         <p:spPr>
           <a:xfrm>
-            <a:off x="594360" y="1828800"/>
-            <a:ext cx="6720840" cy="3886200"/>
-          </a:xfrm>
-          <a:prstGeom prst="roundRect">
-            <a:avLst>
-              <a:gd name="adj" fmla="val 12000"/>
-            </a:avLst>
-          </a:prstGeom>
-          <a:solidFill>
-            <a:srgbClr val="F3F9FF"/>
-          </a:solidFill>
+            <a:off x="594360" y="6163056"/>
+            <a:ext cx="10972800" cy="91440"/>
+          </a:xfrm>
+          <a:prstGeom prst="rect">
+            <a:avLst/>
+          </a:prstGeom>
+          <a:gradFill rotWithShape="1">
+            <a:gsLst>
+              <a:gs pos="0">
+                <a:srgbClr val="FFB604"/>
+              </a:gs>
+              <a:gs pos="28000">
+                <a:srgbClr val="FF5DB1"/>
+              </a:gs>
+              <a:gs pos="58000">
+                <a:srgbClr val="7468FF"/>
+              </a:gs>
+              <a:gs pos="100000">
+                <a:srgbClr val="23F5FF"/>
+              </a:gs>
+            </a:gsLst>
+            <a:lin ang="0" scaled="1"/>
+          </a:gradFill>
           <a:ln>
             <a:noFill/>
           </a:ln>
@@ -3687,7 +3911,184 @@
       </p:sp>
       <p:sp>
         <p:nvSpPr>
-          <p:cNvPr id="6" name="Insert a documentary photograph"/>
+          <p:cNvPr id="3" name="Plan B Foundation"/>
+          <p:cNvSpPr txBox="1"/>
+          <p:nvPr/>
+        </p:nvSpPr>
+        <p:spPr>
+          <a:xfrm>
+            <a:off x="594360" y="6382512"/>
+            <a:ext cx="3657600" cy="228600"/>
+          </a:xfrm>
+          <a:prstGeom prst="rect">
+            <a:avLst/>
+          </a:prstGeom>
+          <a:noFill/>
+        </p:spPr>
+        <p:txBody>
+          <a:bodyPr wrap="square" lIns="0" rIns="0" tIns="0" bIns="0">
+            <a:spAutoFit/>
+          </a:bodyPr>
+          <a:lstStyle/>
+          <a:p>
+            <a:pPr algn="l" marL="0" indent="0">
+              <a:defRPr sz="1100" b="1">
+                <a:solidFill>
+                  <a:srgbClr val="082952"/>
+                </a:solidFill>
+                <a:latin typeface="Inter"/>
+              </a:defRPr>
+              <a:lnSpc>
+                <a:spcPct val="112000"/>
+              </a:lnSpc>
+              <a:spcAft>
+                <a:spcPts val="1200"/>
+              </a:spcAft>
+              <a:buNone/>
+            </a:pPr>
+            <a:r>
+              <a:t>Plan B Foundation</a:t>
+            </a:r>
+          </a:p>
+        </p:txBody>
+      </p:sp>
+      <p:sp>
+        <p:nvSpPr>
+          <p:cNvPr id="4" name="Civic Digital Commons"/>
+          <p:cNvSpPr txBox="1"/>
+          <p:nvPr/>
+        </p:nvSpPr>
+        <p:spPr>
+          <a:xfrm>
+            <a:off x="8595360" y="6382512"/>
+            <a:ext cx="2971800" cy="228600"/>
+          </a:xfrm>
+          <a:prstGeom prst="rect">
+            <a:avLst/>
+          </a:prstGeom>
+          <a:noFill/>
+        </p:spPr>
+        <p:txBody>
+          <a:bodyPr wrap="square" lIns="0" rIns="0" tIns="0" bIns="0">
+            <a:spAutoFit/>
+          </a:bodyPr>
+          <a:lstStyle/>
+          <a:p>
+            <a:pPr algn="l" marL="0" indent="0">
+              <a:defRPr sz="1100" b="0">
+                <a:solidFill>
+                  <a:srgbClr val="082952"/>
+                </a:solidFill>
+                <a:latin typeface="Inter"/>
+              </a:defRPr>
+              <a:lnSpc>
+                <a:spcPct val="112000"/>
+              </a:lnSpc>
+              <a:spcAft>
+                <a:spcPts val="1200"/>
+              </a:spcAft>
+              <a:buNone/>
+            </a:pPr>
+            <a:r>
+              <a:t>Civic Digital Commons</a:t>
+            </a:r>
+          </a:p>
+        </p:txBody>
+      </p:sp>
+      <p:sp>
+        <p:nvSpPr>
+          <p:cNvPr id="5" name="Placeholder 0"/>
+          <p:cNvSpPr txBox="1"/>
+          <p:nvPr>
+            <p:ph type="title" idx="0"/>
+          </p:nvPr>
+        </p:nvSpPr>
+        <p:spPr>
+          <a:xfrm>
+            <a:off x="594360" y="502920"/>
+            <a:ext cx="10972800" cy="1005840"/>
+          </a:xfrm>
+          <a:prstGeom prst="rect">
+            <a:avLst/>
+          </a:prstGeom>
+          <a:noFill/>
+        </p:spPr>
+        <p:txBody>
+          <a:bodyPr wrap="square" lIns="0" rIns="0" tIns="0" bIns="0">
+            <a:spAutoFit/>
+          </a:bodyPr>
+          <a:lstStyle/>
+          <a:p>
+            <a:pPr algn="l" marL="0" indent="0">
+              <a:defRPr sz="3600" b="1">
+                <a:solidFill>
+                  <a:srgbClr val="082952"/>
+                </a:solidFill>
+                <a:latin typeface="Inter"/>
+              </a:defRPr>
+              <a:lnSpc>
+                <a:spcPct val="112000"/>
+              </a:lnSpc>
+              <a:spcAft>
+                <a:spcPts val="1200"/>
+              </a:spcAft>
+              <a:buNone/>
+            </a:pPr>
+            <a:r>
+              <a:t>[Make the place visible]</a:t>
+            </a:r>
+          </a:p>
+        </p:txBody>
+      </p:sp>
+      <p:sp>
+        <p:nvSpPr>
+          <p:cNvPr id="6" name="Rounded Rectangle 5"/>
+          <p:cNvSpPr/>
+          <p:nvPr/>
+        </p:nvSpPr>
+        <p:spPr>
+          <a:xfrm>
+            <a:off x="594360" y="1828800"/>
+            <a:ext cx="6720840" cy="3886200"/>
+          </a:xfrm>
+          <a:prstGeom prst="roundRect">
+            <a:avLst>
+              <a:gd name="adj" fmla="val 12000"/>
+            </a:avLst>
+          </a:prstGeom>
+          <a:solidFill>
+            <a:srgbClr val="F3F9FF"/>
+          </a:solidFill>
+          <a:ln>
+            <a:noFill/>
+          </a:ln>
+          <a:effectLst/>
+        </p:spPr>
+        <p:style>
+          <a:lnRef idx="1">
+            <a:schemeClr val="accent1"/>
+          </a:lnRef>
+          <a:fillRef idx="3">
+            <a:schemeClr val="accent1"/>
+          </a:fillRef>
+          <a:effectRef idx="2">
+            <a:schemeClr val="accent1"/>
+          </a:effectRef>
+          <a:fontRef idx="minor">
+            <a:schemeClr val="lt1"/>
+          </a:fontRef>
+        </p:style>
+        <p:txBody>
+          <a:bodyPr rtlCol="0" anchor="ctr"/>
+          <a:lstStyle/>
+          <a:p>
+            <a:pPr algn="ctr"/>
+          </a:p>
+        </p:txBody>
+      </p:sp>
+      <p:sp>
+        <p:nvSpPr>
+          <p:cNvPr id="7" name="Insert a documentary photograph"/>
           <p:cNvSpPr txBox="1"/>
           <p:nvPr/>
         </p:nvSpPr>
@@ -3730,7 +4131,7 @@
       </p:sp>
       <p:sp>
         <p:nvSpPr>
-          <p:cNvPr id="7" name="Placeholder 1"/>
+          <p:cNvPr id="8" name="Placeholder 1"/>
           <p:cNvSpPr txBox="1"/>
           <p:nvPr>
             <p:ph type="pic" idx="1"/>
@@ -3775,7 +4176,7 @@
       </p:sp>
       <p:sp>
         <p:nvSpPr>
-          <p:cNvPr id="8" name="Placeholder 2"/>
+          <p:cNvPr id="9" name="Placeholder 2"/>
           <p:cNvSpPr txBox="1"/>
           <p:nvPr>
             <p:ph type="body" idx="2"/>
@@ -3820,7 +4221,7 @@
       </p:sp>
       <p:sp>
         <p:nvSpPr>
-          <p:cNvPr id="9" name="Placeholder 3"/>
+          <p:cNvPr id="10" name="Placeholder 3"/>
           <p:cNvSpPr txBox="1"/>
           <p:nvPr>
             <p:ph type="body" idx="3"/>
@@ -3865,7 +4266,7 @@
       </p:sp>
       <p:sp>
         <p:nvSpPr>
-          <p:cNvPr id="10" name="Placeholder 4"/>
+          <p:cNvPr id="11" name="Placeholder 4"/>
           <p:cNvSpPr txBox="1"/>
           <p:nvPr>
             <p:ph type="body" idx="4"/>
@@ -3923,7 +4324,7 @@
 
 <file path=ppt/slideLayouts/slideLayout6.xml><?xml version="1.0" encoding="utf-8"?>
 <p:sldLayout xmlns:a="http://schemas.openxmlformats.org/drawingml/2006/main" xmlns:r="http://schemas.openxmlformats.org/officeDocument/2006/relationships" xmlns:p="http://schemas.openxmlformats.org/presentationml/2006/main" type="cust" preserve="1" showMasterSp="1">
-  <p:cSld name="Plan B / Chart and takeaway">
+  <p:cSld name="Plan B / Light / Chart and takeaway">
     <p:bg>
       <p:bgPr>
         <a:solidFill>
@@ -3948,7 +4349,65 @@
       </p:grpSpPr>
       <p:sp>
         <p:nvSpPr>
-          <p:cNvPr id="2" name="Plan B Foundation"/>
+          <p:cNvPr id="2" name="Plan B / Network energy gradient"/>
+          <p:cNvSpPr/>
+          <p:nvPr/>
+        </p:nvSpPr>
+        <p:spPr>
+          <a:xfrm>
+            <a:off x="594360" y="6163056"/>
+            <a:ext cx="10972800" cy="91440"/>
+          </a:xfrm>
+          <a:prstGeom prst="rect">
+            <a:avLst/>
+          </a:prstGeom>
+          <a:gradFill rotWithShape="1">
+            <a:gsLst>
+              <a:gs pos="0">
+                <a:srgbClr val="FFB604"/>
+              </a:gs>
+              <a:gs pos="28000">
+                <a:srgbClr val="FF5DB1"/>
+              </a:gs>
+              <a:gs pos="58000">
+                <a:srgbClr val="7468FF"/>
+              </a:gs>
+              <a:gs pos="100000">
+                <a:srgbClr val="23F5FF"/>
+              </a:gs>
+            </a:gsLst>
+            <a:lin ang="0" scaled="1"/>
+          </a:gradFill>
+          <a:ln>
+            <a:noFill/>
+          </a:ln>
+          <a:effectLst/>
+        </p:spPr>
+        <p:style>
+          <a:lnRef idx="1">
+            <a:schemeClr val="accent1"/>
+          </a:lnRef>
+          <a:fillRef idx="3">
+            <a:schemeClr val="accent1"/>
+          </a:fillRef>
+          <a:effectRef idx="2">
+            <a:schemeClr val="accent1"/>
+          </a:effectRef>
+          <a:fontRef idx="minor">
+            <a:schemeClr val="lt1"/>
+          </a:fontRef>
+        </p:style>
+        <p:txBody>
+          <a:bodyPr rtlCol="0" anchor="ctr"/>
+          <a:lstStyle/>
+          <a:p>
+            <a:pPr algn="ctr"/>
+          </a:p>
+        </p:txBody>
+      </p:sp>
+      <p:sp>
+        <p:nvSpPr>
+          <p:cNvPr id="3" name="Plan B Foundation"/>
           <p:cNvSpPr txBox="1"/>
           <p:nvPr/>
         </p:nvSpPr>
@@ -3991,7 +4450,7 @@
       </p:sp>
       <p:sp>
         <p:nvSpPr>
-          <p:cNvPr id="3" name="Civic Digital Commons"/>
+          <p:cNvPr id="4" name="Civic Digital Commons"/>
           <p:cNvSpPr txBox="1"/>
           <p:nvPr/>
         </p:nvSpPr>
@@ -4034,7 +4493,7 @@
       </p:sp>
       <p:sp>
         <p:nvSpPr>
-          <p:cNvPr id="4" name="Placeholder 0"/>
+          <p:cNvPr id="5" name="Placeholder 0"/>
           <p:cNvSpPr txBox="1"/>
           <p:nvPr>
             <p:ph type="title" idx="0"/>
@@ -4079,7 +4538,7 @@
       </p:sp>
       <p:sp>
         <p:nvSpPr>
-          <p:cNvPr id="5" name="Placeholder 1"/>
+          <p:cNvPr id="6" name="Placeholder 1"/>
           <p:cNvSpPr txBox="1"/>
           <p:nvPr>
             <p:ph type="body" idx="1"/>
@@ -4124,7 +4583,7 @@
       </p:sp>
       <p:sp>
         <p:nvSpPr>
-          <p:cNvPr id="6" name="Placeholder 2"/>
+          <p:cNvPr id="7" name="Placeholder 2"/>
           <p:cNvSpPr txBox="1"/>
           <p:nvPr>
             <p:ph type="chart" idx="2"/>
@@ -4169,7 +4628,7 @@
       </p:sp>
       <p:sp>
         <p:nvSpPr>
-          <p:cNvPr id="7" name="Placeholder 3"/>
+          <p:cNvPr id="8" name="Placeholder 3"/>
           <p:cNvSpPr txBox="1"/>
           <p:nvPr>
             <p:ph type="body" idx="3"/>
@@ -4214,7 +4673,7 @@
       </p:sp>
       <p:sp>
         <p:nvSpPr>
-          <p:cNvPr id="8" name="Placeholder 4"/>
+          <p:cNvPr id="9" name="Placeholder 4"/>
           <p:cNvSpPr txBox="1"/>
           <p:nvPr>
             <p:ph type="body" idx="4"/>
@@ -4259,7 +4718,7 @@
       </p:sp>
       <p:sp>
         <p:nvSpPr>
-          <p:cNvPr id="9" name="Placeholder 5"/>
+          <p:cNvPr id="10" name="Placeholder 5"/>
           <p:cNvSpPr txBox="1"/>
           <p:nvPr>
             <p:ph type="body" idx="5"/>
@@ -4317,7 +4776,7 @@
 
 <file path=ppt/slideLayouts/slideLayout7.xml><?xml version="1.0" encoding="utf-8"?>
 <p:sldLayout xmlns:a="http://schemas.openxmlformats.org/drawingml/2006/main" xmlns:r="http://schemas.openxmlformats.org/officeDocument/2006/relationships" xmlns:p="http://schemas.openxmlformats.org/presentationml/2006/main" type="cust" preserve="1" showMasterSp="1">
-  <p:cSld name="Plan B / Table">
+  <p:cSld name="Plan B / Light / Table">
     <p:bg>
       <p:bgPr>
         <a:solidFill>
@@ -4342,7 +4801,65 @@
       </p:grpSpPr>
       <p:sp>
         <p:nvSpPr>
-          <p:cNvPr id="2" name="Plan B Foundation"/>
+          <p:cNvPr id="2" name="Plan B / Network energy gradient"/>
+          <p:cNvSpPr/>
+          <p:nvPr/>
+        </p:nvSpPr>
+        <p:spPr>
+          <a:xfrm>
+            <a:off x="594360" y="6163056"/>
+            <a:ext cx="10972800" cy="91440"/>
+          </a:xfrm>
+          <a:prstGeom prst="rect">
+            <a:avLst/>
+          </a:prstGeom>
+          <a:gradFill rotWithShape="1">
+            <a:gsLst>
+              <a:gs pos="0">
+                <a:srgbClr val="FFB604"/>
+              </a:gs>
+              <a:gs pos="28000">
+                <a:srgbClr val="FF5DB1"/>
+              </a:gs>
+              <a:gs pos="58000">
+                <a:srgbClr val="7468FF"/>
+              </a:gs>
+              <a:gs pos="100000">
+                <a:srgbClr val="23F5FF"/>
+              </a:gs>
+            </a:gsLst>
+            <a:lin ang="0" scaled="1"/>
+          </a:gradFill>
+          <a:ln>
+            <a:noFill/>
+          </a:ln>
+          <a:effectLst/>
+        </p:spPr>
+        <p:style>
+          <a:lnRef idx="1">
+            <a:schemeClr val="accent1"/>
+          </a:lnRef>
+          <a:fillRef idx="3">
+            <a:schemeClr val="accent1"/>
+          </a:fillRef>
+          <a:effectRef idx="2">
+            <a:schemeClr val="accent1"/>
+          </a:effectRef>
+          <a:fontRef idx="minor">
+            <a:schemeClr val="lt1"/>
+          </a:fontRef>
+        </p:style>
+        <p:txBody>
+          <a:bodyPr rtlCol="0" anchor="ctr"/>
+          <a:lstStyle/>
+          <a:p>
+            <a:pPr algn="ctr"/>
+          </a:p>
+        </p:txBody>
+      </p:sp>
+      <p:sp>
+        <p:nvSpPr>
+          <p:cNvPr id="3" name="Plan B Foundation"/>
           <p:cNvSpPr txBox="1"/>
           <p:nvPr/>
         </p:nvSpPr>
@@ -4385,7 +4902,7 @@
       </p:sp>
       <p:sp>
         <p:nvSpPr>
-          <p:cNvPr id="3" name="Civic Digital Commons"/>
+          <p:cNvPr id="4" name="Civic Digital Commons"/>
           <p:cNvSpPr txBox="1"/>
           <p:nvPr/>
         </p:nvSpPr>
@@ -4428,7 +4945,7 @@
       </p:sp>
       <p:sp>
         <p:nvSpPr>
-          <p:cNvPr id="4" name="Placeholder 0"/>
+          <p:cNvPr id="5" name="Placeholder 0"/>
           <p:cNvSpPr txBox="1"/>
           <p:nvPr>
             <p:ph type="title" idx="0"/>
@@ -4473,7 +4990,7 @@
       </p:sp>
       <p:sp>
         <p:nvSpPr>
-          <p:cNvPr id="5" name="Placeholder 1"/>
+          <p:cNvPr id="6" name="Placeholder 1"/>
           <p:cNvSpPr txBox="1"/>
           <p:nvPr>
             <p:ph type="body" idx="1"/>
@@ -4518,7 +5035,7 @@
       </p:sp>
       <p:sp>
         <p:nvSpPr>
-          <p:cNvPr id="6" name="Placeholder 2"/>
+          <p:cNvPr id="7" name="Placeholder 2"/>
           <p:cNvSpPr txBox="1"/>
           <p:nvPr>
             <p:ph type="tbl" idx="2"/>
@@ -4563,7 +5080,7 @@
       </p:sp>
       <p:sp>
         <p:nvSpPr>
-          <p:cNvPr id="7" name="Placeholder 3"/>
+          <p:cNvPr id="8" name="Placeholder 3"/>
           <p:cNvSpPr txBox="1"/>
           <p:nvPr>
             <p:ph type="body" idx="3"/>
@@ -4621,7 +5138,7 @@
 
 <file path=ppt/slideLayouts/slideLayout8.xml><?xml version="1.0" encoding="utf-8"?>
 <p:sldLayout xmlns:a="http://schemas.openxmlformats.org/drawingml/2006/main" xmlns:r="http://schemas.openxmlformats.org/officeDocument/2006/relationships" xmlns:p="http://schemas.openxmlformats.org/presentationml/2006/main" type="cust" preserve="1" showMasterSp="1">
-  <p:cSld name="Plan B / Quotation">
+  <p:cSld name="Plan B / Light / Quotation">
     <p:bg>
       <p:bgPr>
         <a:solidFill>
@@ -4646,7 +5163,65 @@
       </p:grpSpPr>
       <p:sp>
         <p:nvSpPr>
-          <p:cNvPr id="2" name="Plan B Foundation"/>
+          <p:cNvPr id="2" name="Plan B / Network energy gradient"/>
+          <p:cNvSpPr/>
+          <p:nvPr/>
+        </p:nvSpPr>
+        <p:spPr>
+          <a:xfrm>
+            <a:off x="594360" y="6163056"/>
+            <a:ext cx="10972800" cy="91440"/>
+          </a:xfrm>
+          <a:prstGeom prst="rect">
+            <a:avLst/>
+          </a:prstGeom>
+          <a:gradFill rotWithShape="1">
+            <a:gsLst>
+              <a:gs pos="0">
+                <a:srgbClr val="FFB604"/>
+              </a:gs>
+              <a:gs pos="28000">
+                <a:srgbClr val="FF5DB1"/>
+              </a:gs>
+              <a:gs pos="58000">
+                <a:srgbClr val="7468FF"/>
+              </a:gs>
+              <a:gs pos="100000">
+                <a:srgbClr val="23F5FF"/>
+              </a:gs>
+            </a:gsLst>
+            <a:lin ang="0" scaled="1"/>
+          </a:gradFill>
+          <a:ln>
+            <a:noFill/>
+          </a:ln>
+          <a:effectLst/>
+        </p:spPr>
+        <p:style>
+          <a:lnRef idx="1">
+            <a:schemeClr val="accent1"/>
+          </a:lnRef>
+          <a:fillRef idx="3">
+            <a:schemeClr val="accent1"/>
+          </a:fillRef>
+          <a:effectRef idx="2">
+            <a:schemeClr val="accent1"/>
+          </a:effectRef>
+          <a:fontRef idx="minor">
+            <a:schemeClr val="lt1"/>
+          </a:fontRef>
+        </p:style>
+        <p:txBody>
+          <a:bodyPr rtlCol="0" anchor="ctr"/>
+          <a:lstStyle/>
+          <a:p>
+            <a:pPr algn="ctr"/>
+          </a:p>
+        </p:txBody>
+      </p:sp>
+      <p:sp>
+        <p:nvSpPr>
+          <p:cNvPr id="3" name="Plan B Foundation"/>
           <p:cNvSpPr txBox="1"/>
           <p:nvPr/>
         </p:nvSpPr>
@@ -4689,7 +5264,7 @@
       </p:sp>
       <p:sp>
         <p:nvSpPr>
-          <p:cNvPr id="3" name="Civic Digital Commons"/>
+          <p:cNvPr id="4" name="Civic Digital Commons"/>
           <p:cNvSpPr txBox="1"/>
           <p:nvPr/>
         </p:nvSpPr>
@@ -4732,7 +5307,7 @@
       </p:sp>
       <p:sp>
         <p:nvSpPr>
-          <p:cNvPr id="4" name="Placeholder 0"/>
+          <p:cNvPr id="5" name="Placeholder 0"/>
           <p:cNvSpPr txBox="1"/>
           <p:nvPr>
             <p:ph type="title" idx="0"/>
@@ -4797,7 +5372,7 @@
       </p:sp>
       <p:sp>
         <p:nvSpPr>
-          <p:cNvPr id="5" name="Placeholder 1"/>
+          <p:cNvPr id="6" name="Placeholder 1"/>
           <p:cNvSpPr txBox="1"/>
           <p:nvPr>
             <p:ph type="body" idx="1"/>
@@ -4862,21 +5437,35 @@
       </p:sp>
       <p:sp>
         <p:nvSpPr>
-          <p:cNvPr id="6" name="Rectangle 5"/>
+          <p:cNvPr id="7" name="Plan B / Network energy gradient"/>
           <p:cNvSpPr/>
           <p:nvPr/>
         </p:nvSpPr>
         <p:spPr>
           <a:xfrm>
             <a:off x="777240" y="960120"/>
-            <a:ext cx="640080" cy="73152"/>
-          </a:xfrm>
-          <a:prstGeom prst="rect">
-            <a:avLst/>
-          </a:prstGeom>
-          <a:solidFill>
-            <a:srgbClr val="FFB604"/>
-          </a:solidFill>
+            <a:ext cx="2560320" cy="146304"/>
+          </a:xfrm>
+          <a:prstGeom prst="rect">
+            <a:avLst/>
+          </a:prstGeom>
+          <a:gradFill rotWithShape="1">
+            <a:gsLst>
+              <a:gs pos="0">
+                <a:srgbClr val="FFB604"/>
+              </a:gs>
+              <a:gs pos="28000">
+                <a:srgbClr val="FF5DB1"/>
+              </a:gs>
+              <a:gs pos="58000">
+                <a:srgbClr val="7468FF"/>
+              </a:gs>
+              <a:gs pos="100000">
+                <a:srgbClr val="23F5FF"/>
+              </a:gs>
+            </a:gsLst>
+            <a:lin ang="0" scaled="1"/>
+          </a:gradFill>
           <a:ln>
             <a:noFill/>
           </a:ln>
@@ -4919,7 +5508,7 @@
 
 <file path=ppt/slideLayouts/slideLayout9.xml><?xml version="1.0" encoding="utf-8"?>
 <p:sldLayout xmlns:a="http://schemas.openxmlformats.org/drawingml/2006/main" xmlns:r="http://schemas.openxmlformats.org/officeDocument/2006/relationships" xmlns:p="http://schemas.openxmlformats.org/presentationml/2006/main" type="cust" preserve="1" showMasterSp="1">
-  <p:cSld name="Plan B / Next steps">
+  <p:cSld name="Plan B / Light / Next steps">
     <p:bg>
       <p:bgPr>
         <a:solidFill>
@@ -4944,7 +5533,65 @@
       </p:grpSpPr>
       <p:sp>
         <p:nvSpPr>
-          <p:cNvPr id="2" name="Plan B Foundation"/>
+          <p:cNvPr id="2" name="Plan B / Network energy gradient"/>
+          <p:cNvSpPr/>
+          <p:nvPr/>
+        </p:nvSpPr>
+        <p:spPr>
+          <a:xfrm>
+            <a:off x="594360" y="6163056"/>
+            <a:ext cx="10972800" cy="91440"/>
+          </a:xfrm>
+          <a:prstGeom prst="rect">
+            <a:avLst/>
+          </a:prstGeom>
+          <a:gradFill rotWithShape="1">
+            <a:gsLst>
+              <a:gs pos="0">
+                <a:srgbClr val="FFB604"/>
+              </a:gs>
+              <a:gs pos="28000">
+                <a:srgbClr val="FF5DB1"/>
+              </a:gs>
+              <a:gs pos="58000">
+                <a:srgbClr val="7468FF"/>
+              </a:gs>
+              <a:gs pos="100000">
+                <a:srgbClr val="23F5FF"/>
+              </a:gs>
+            </a:gsLst>
+            <a:lin ang="0" scaled="1"/>
+          </a:gradFill>
+          <a:ln>
+            <a:noFill/>
+          </a:ln>
+          <a:effectLst/>
+        </p:spPr>
+        <p:style>
+          <a:lnRef idx="1">
+            <a:schemeClr val="accent1"/>
+          </a:lnRef>
+          <a:fillRef idx="3">
+            <a:schemeClr val="accent1"/>
+          </a:fillRef>
+          <a:effectRef idx="2">
+            <a:schemeClr val="accent1"/>
+          </a:effectRef>
+          <a:fontRef idx="minor">
+            <a:schemeClr val="lt1"/>
+          </a:fontRef>
+        </p:style>
+        <p:txBody>
+          <a:bodyPr rtlCol="0" anchor="ctr"/>
+          <a:lstStyle/>
+          <a:p>
+            <a:pPr algn="ctr"/>
+          </a:p>
+        </p:txBody>
+      </p:sp>
+      <p:sp>
+        <p:nvSpPr>
+          <p:cNvPr id="3" name="Plan B Foundation"/>
           <p:cNvSpPr txBox="1"/>
           <p:nvPr/>
         </p:nvSpPr>
@@ -4987,7 +5634,7 @@
       </p:sp>
       <p:sp>
         <p:nvSpPr>
-          <p:cNvPr id="3" name="Civic Digital Commons"/>
+          <p:cNvPr id="4" name="Civic Digital Commons"/>
           <p:cNvSpPr txBox="1"/>
           <p:nvPr/>
         </p:nvSpPr>
@@ -5030,7 +5677,7 @@
       </p:sp>
       <p:sp>
         <p:nvSpPr>
-          <p:cNvPr id="4" name="Placeholder 0"/>
+          <p:cNvPr id="5" name="Placeholder 0"/>
           <p:cNvSpPr txBox="1"/>
           <p:nvPr>
             <p:ph type="title" idx="0"/>
@@ -5075,7 +5722,7 @@
       </p:sp>
       <p:sp>
         <p:nvSpPr>
-          <p:cNvPr id="5" name="Placeholder 1"/>
+          <p:cNvPr id="6" name="Placeholder 1"/>
           <p:cNvSpPr txBox="1"/>
           <p:nvPr>
             <p:ph type="body" idx="1"/>
@@ -5120,7 +5767,7 @@
       </p:sp>
       <p:sp>
         <p:nvSpPr>
-          <p:cNvPr id="6" name="Placeholder 2"/>
+          <p:cNvPr id="7" name="Placeholder 2"/>
           <p:cNvSpPr txBox="1"/>
           <p:nvPr>
             <p:ph type="body" idx="2"/>
@@ -5185,7 +5832,7 @@
       </p:sp>
       <p:sp>
         <p:nvSpPr>
-          <p:cNvPr id="7" name="Placeholder 3"/>
+          <p:cNvPr id="8" name="Placeholder 3"/>
           <p:cNvSpPr txBox="1"/>
           <p:nvPr>
             <p:ph type="body" idx="3"/>
@@ -5230,7 +5877,7 @@
       </p:sp>
       <p:sp>
         <p:nvSpPr>
-          <p:cNvPr id="8" name="Placeholder 4"/>
+          <p:cNvPr id="9" name="Placeholder 4"/>
           <p:cNvSpPr txBox="1"/>
           <p:nvPr>
             <p:ph type="body" idx="4"/>
@@ -5295,7 +5942,7 @@
       </p:sp>
       <p:sp>
         <p:nvSpPr>
-          <p:cNvPr id="9" name="Placeholder 5"/>
+          <p:cNvPr id="10" name="Placeholder 5"/>
           <p:cNvSpPr txBox="1"/>
           <p:nvPr>
             <p:ph type="body" idx="5"/>
@@ -5340,7 +5987,7 @@
       </p:sp>
       <p:sp>
         <p:nvSpPr>
-          <p:cNvPr id="10" name="Placeholder 6"/>
+          <p:cNvPr id="11" name="Placeholder 6"/>
           <p:cNvSpPr txBox="1"/>
           <p:nvPr>
             <p:ph type="body" idx="6"/>
@@ -5405,7 +6052,7 @@
       </p:sp>
       <p:sp>
         <p:nvSpPr>
-          <p:cNvPr id="11" name="Placeholder 7"/>
+          <p:cNvPr id="12" name="Placeholder 7"/>
           <p:cNvSpPr txBox="1"/>
           <p:nvPr>
             <p:ph type="body" idx="7"/>
@@ -5777,7 +6424,7 @@
       <p:grpSpPr/>
       <p:sp>
         <p:nvSpPr>
-          <p:cNvPr id="4" name="Placeholder 0"/>
+          <p:cNvPr id="5" name="Placeholder 0"/>
           <p:cNvSpPr txBox="1"/>
           <p:nvPr>
             <p:ph type="title" idx="0"/>
@@ -5842,7 +6489,7 @@
       </p:sp>
       <p:sp>
         <p:nvSpPr>
-          <p:cNvPr id="5" name="Placeholder 1"/>
+          <p:cNvPr id="6" name="Placeholder 1"/>
           <p:cNvSpPr txBox="1"/>
           <p:nvPr>
             <p:ph type="subTitle" idx="1"/>
@@ -5887,7 +6534,7 @@
       </p:sp>
       <p:sp>
         <p:nvSpPr>
-          <p:cNvPr id="6" name="Placeholder 2"/>
+          <p:cNvPr id="7" name="Placeholder 2"/>
           <p:cNvSpPr txBox="1"/>
           <p:nvPr>
             <p:ph type="body" idx="2"/>
@@ -5978,7 +6625,7 @@
       <p:grpSpPr/>
       <p:sp>
         <p:nvSpPr>
-          <p:cNvPr id="4" name="Placeholder 0"/>
+          <p:cNvPr id="5" name="Placeholder 0"/>
           <p:cNvSpPr txBox="1"/>
           <p:nvPr>
             <p:ph type="title" idx="0"/>
@@ -6023,7 +6670,7 @@
       </p:sp>
       <p:sp>
         <p:nvSpPr>
-          <p:cNvPr id="5" name="Placeholder 1"/>
+          <p:cNvPr id="6" name="Placeholder 1"/>
           <p:cNvSpPr txBox="1"/>
           <p:nvPr>
             <p:ph type="body" idx="1"/>
@@ -6068,7 +6715,7 @@
       </p:sp>
       <p:sp>
         <p:nvSpPr>
-          <p:cNvPr id="6" name="Placeholder 2"/>
+          <p:cNvPr id="7" name="Placeholder 2"/>
           <p:cNvSpPr txBox="1"/>
           <p:nvPr>
             <p:ph type="body" idx="2"/>
@@ -6133,7 +6780,7 @@
       </p:sp>
       <p:sp>
         <p:nvSpPr>
-          <p:cNvPr id="7" name="Placeholder 3"/>
+          <p:cNvPr id="8" name="Placeholder 3"/>
           <p:cNvSpPr txBox="1"/>
           <p:nvPr>
             <p:ph type="body" idx="3"/>
@@ -6191,7 +6838,7 @@
               <a:buNone/>
             </a:pPr>
             <a:r>
-              <a:t>One idea per slide. Use navy and warm white. Choose gold or a small gradient as the exceptional signal. Aim for 20pt or larger body text.</a:t>
+              <a:t>One idea per slide. Keep the selected light or dark palette. Preserve the gradient band and keep text on solid grounds. Aim for 20pt or larger body text.</a:t>
             </a:r>
           </a:p>
         </p:txBody>
@@ -6210,7 +6857,7 @@
     <p:bg>
       <p:bgPr>
         <a:solidFill>
-          <a:srgbClr val="082952"/>
+          <a:srgbClr val="F3F9FF"/>
         </a:solidFill>
         <a:effectLst/>
       </p:bgPr>
@@ -6224,7 +6871,7 @@
       <p:grpSpPr/>
       <p:sp>
         <p:nvSpPr>
-          <p:cNvPr id="4" name="Placeholder 0"/>
+          <p:cNvPr id="5" name="Placeholder 0"/>
           <p:cNvSpPr txBox="1"/>
           <p:nvPr>
             <p:ph type="title" idx="0"/>
@@ -6249,7 +6896,7 @@
             <a:pPr algn="l" marL="0" indent="0">
               <a:defRPr sz="4800" b="1">
                 <a:solidFill>
-                  <a:srgbClr val="FFFEFA"/>
+                  <a:srgbClr val="082952"/>
                 </a:solidFill>
                 <a:latin typeface="Inter"/>
               </a:defRPr>
@@ -6269,7 +6916,7 @@
       </p:sp>
       <p:sp>
         <p:nvSpPr>
-          <p:cNvPr id="5" name="Placeholder 1"/>
+          <p:cNvPr id="6" name="Placeholder 1"/>
           <p:cNvSpPr txBox="1"/>
           <p:nvPr>
             <p:ph type="body" idx="1"/>
@@ -6294,7 +6941,7 @@
             <a:pPr algn="l" marL="0" indent="0">
               <a:defRPr sz="2500" b="0">
                 <a:solidFill>
-                  <a:srgbClr val="FFFEFA"/>
+                  <a:srgbClr val="030B20"/>
                 </a:solidFill>
                 <a:latin typeface="Inter"/>
               </a:defRPr>
@@ -6340,7 +6987,7 @@
       <p:grpSpPr/>
       <p:sp>
         <p:nvSpPr>
-          <p:cNvPr id="4" name="Placeholder 0"/>
+          <p:cNvPr id="5" name="Placeholder 0"/>
           <p:cNvSpPr txBox="1"/>
           <p:nvPr>
             <p:ph type="title" idx="0"/>
@@ -6385,7 +7032,7 @@
       </p:sp>
       <p:sp>
         <p:nvSpPr>
-          <p:cNvPr id="5" name="Placeholder 1"/>
+          <p:cNvPr id="6" name="Placeholder 1"/>
           <p:cNvSpPr txBox="1"/>
           <p:nvPr>
             <p:ph type="body" idx="1"/>
@@ -6430,7 +7077,7 @@
       </p:sp>
       <p:sp>
         <p:nvSpPr>
-          <p:cNvPr id="6" name="Placeholder 2"/>
+          <p:cNvPr id="7" name="Placeholder 2"/>
           <p:cNvSpPr txBox="1"/>
           <p:nvPr>
             <p:ph type="body" idx="2"/>
@@ -6541,7 +7188,7 @@
       <p:grpSpPr/>
       <p:sp>
         <p:nvSpPr>
-          <p:cNvPr id="4" name="Placeholder 0"/>
+          <p:cNvPr id="5" name="Placeholder 0"/>
           <p:cNvSpPr txBox="1"/>
           <p:nvPr>
             <p:ph type="title" idx="0"/>
@@ -6586,7 +7233,7 @@
       </p:sp>
       <p:sp>
         <p:nvSpPr>
-          <p:cNvPr id="5" name="Placeholder 1"/>
+          <p:cNvPr id="6" name="Placeholder 1"/>
           <p:cNvSpPr txBox="1"/>
           <p:nvPr>
             <p:ph type="body" idx="1"/>
@@ -6631,7 +7278,7 @@
       </p:sp>
       <p:sp>
         <p:nvSpPr>
-          <p:cNvPr id="6" name="Placeholder 2"/>
+          <p:cNvPr id="7" name="Placeholder 2"/>
           <p:cNvSpPr txBox="1"/>
           <p:nvPr>
             <p:ph type="body" idx="2"/>
@@ -6676,7 +7323,7 @@
       </p:sp>
       <p:sp>
         <p:nvSpPr>
-          <p:cNvPr id="7" name="Placeholder 3"/>
+          <p:cNvPr id="8" name="Placeholder 3"/>
           <p:cNvSpPr txBox="1"/>
           <p:nvPr>
             <p:ph type="body" idx="3"/>
@@ -6721,7 +7368,7 @@
       </p:sp>
       <p:sp>
         <p:nvSpPr>
-          <p:cNvPr id="8" name="Placeholder 4"/>
+          <p:cNvPr id="9" name="Placeholder 4"/>
           <p:cNvSpPr txBox="1"/>
           <p:nvPr>
             <p:ph type="body" idx="4"/>
@@ -6792,7 +7439,7 @@
       <p:grpSpPr/>
       <p:sp>
         <p:nvSpPr>
-          <p:cNvPr id="4" name="Placeholder 0"/>
+          <p:cNvPr id="5" name="Placeholder 0"/>
           <p:cNvSpPr txBox="1"/>
           <p:nvPr>
             <p:ph type="title" idx="0"/>
@@ -6837,7 +7484,7 @@
       </p:sp>
       <p:sp>
         <p:nvSpPr>
-          <p:cNvPr id="7" name="Placeholder 1"/>
+          <p:cNvPr id="8" name="Placeholder 1"/>
           <p:cNvSpPr txBox="1"/>
           <p:nvPr>
             <p:ph type="pic" idx="1"/>
@@ -6882,7 +7529,7 @@
       </p:sp>
       <p:sp>
         <p:nvSpPr>
-          <p:cNvPr id="8" name="Placeholder 2"/>
+          <p:cNvPr id="9" name="Placeholder 2"/>
           <p:cNvSpPr txBox="1"/>
           <p:nvPr>
             <p:ph type="body" idx="2"/>
@@ -6927,7 +7574,7 @@
       </p:sp>
       <p:sp>
         <p:nvSpPr>
-          <p:cNvPr id="9" name="Placeholder 3"/>
+          <p:cNvPr id="10" name="Placeholder 3"/>
           <p:cNvSpPr txBox="1"/>
           <p:nvPr>
             <p:ph type="body" idx="3"/>
@@ -6972,7 +7619,7 @@
       </p:sp>
       <p:sp>
         <p:nvSpPr>
-          <p:cNvPr id="10" name="Placeholder 4"/>
+          <p:cNvPr id="11" name="Placeholder 4"/>
           <p:cNvSpPr txBox="1"/>
           <p:nvPr>
             <p:ph type="body" idx="4"/>
@@ -7043,7 +7690,7 @@
       <p:grpSpPr/>
       <p:sp>
         <p:nvSpPr>
-          <p:cNvPr id="4" name="Placeholder 0"/>
+          <p:cNvPr id="5" name="Placeholder 0"/>
           <p:cNvSpPr txBox="1"/>
           <p:nvPr>
             <p:ph type="title" idx="0"/>
@@ -7088,7 +7735,7 @@
       </p:sp>
       <p:sp>
         <p:nvSpPr>
-          <p:cNvPr id="5" name="Placeholder 1"/>
+          <p:cNvPr id="6" name="Placeholder 1"/>
           <p:cNvSpPr txBox="1"/>
           <p:nvPr>
             <p:ph type="body" idx="1"/>
@@ -7133,7 +7780,7 @@
       </p:sp>
       <p:sp>
         <p:nvSpPr>
-          <p:cNvPr id="7" name="Placeholder 3"/>
+          <p:cNvPr id="8" name="Placeholder 3"/>
           <p:cNvSpPr txBox="1"/>
           <p:nvPr>
             <p:ph type="body" idx="3"/>
@@ -7178,7 +7825,7 @@
       </p:sp>
       <p:sp>
         <p:nvSpPr>
-          <p:cNvPr id="8" name="Placeholder 4"/>
+          <p:cNvPr id="9" name="Placeholder 4"/>
           <p:cNvSpPr txBox="1"/>
           <p:nvPr>
             <p:ph type="body" idx="4"/>
@@ -7223,7 +7870,7 @@
       </p:sp>
       <p:sp>
         <p:nvSpPr>
-          <p:cNvPr id="9" name="Placeholder 5"/>
+          <p:cNvPr id="10" name="Placeholder 5"/>
           <p:cNvSpPr txBox="1"/>
           <p:nvPr>
             <p:ph type="body" idx="5"/>
@@ -7268,7 +7915,7 @@
       </p:sp>
       <p:graphicFrame>
         <p:nvGraphicFramePr>
-          <p:cNvPr id="10" name="Chart 9"/>
+          <p:cNvPr id="11" name="Chart 10"/>
           <p:cNvGraphicFramePr>
             <a:graphicFrameLocks noGrp="1"/>
           </p:cNvGraphicFramePr>
@@ -7312,7 +7959,7 @@
       <p:grpSpPr/>
       <p:sp>
         <p:nvSpPr>
-          <p:cNvPr id="4" name="Placeholder 0"/>
+          <p:cNvPr id="5" name="Placeholder 0"/>
           <p:cNvSpPr txBox="1"/>
           <p:nvPr>
             <p:ph type="title" idx="0"/>
@@ -7357,7 +8004,7 @@
       </p:sp>
       <p:sp>
         <p:nvSpPr>
-          <p:cNvPr id="5" name="Placeholder 1"/>
+          <p:cNvPr id="6" name="Placeholder 1"/>
           <p:cNvSpPr txBox="1"/>
           <p:nvPr>
             <p:ph type="body" idx="1"/>
@@ -7402,7 +8049,7 @@
       </p:sp>
       <p:sp>
         <p:nvSpPr>
-          <p:cNvPr id="7" name="Placeholder 3"/>
+          <p:cNvPr id="8" name="Placeholder 3"/>
           <p:cNvSpPr txBox="1"/>
           <p:nvPr>
             <p:ph type="body" idx="3"/>
@@ -7447,7 +8094,7 @@
       </p:sp>
       <p:graphicFrame>
         <p:nvGraphicFramePr>
-          <p:cNvPr id="8" name="Table 7"/>
+          <p:cNvPr id="9" name="Table 8"/>
           <p:cNvGraphicFramePr>
             <a:graphicFrameLocks noGrp="1"/>
           </p:cNvGraphicFramePr>
@@ -7796,7 +8443,7 @@
       <p:grpSpPr/>
       <p:sp>
         <p:nvSpPr>
-          <p:cNvPr id="4" name="Placeholder 0"/>
+          <p:cNvPr id="5" name="Placeholder 0"/>
           <p:cNvSpPr txBox="1"/>
           <p:nvPr>
             <p:ph type="title" idx="0"/>
@@ -7861,7 +8508,7 @@
       </p:sp>
       <p:sp>
         <p:nvSpPr>
-          <p:cNvPr id="5" name="Placeholder 1"/>
+          <p:cNvPr id="6" name="Placeholder 1"/>
           <p:cNvSpPr txBox="1"/>
           <p:nvPr>
             <p:ph type="body" idx="1"/>
@@ -7952,7 +8599,7 @@
       <p:grpSpPr/>
       <p:sp>
         <p:nvSpPr>
-          <p:cNvPr id="4" name="Placeholder 0"/>
+          <p:cNvPr id="5" name="Placeholder 0"/>
           <p:cNvSpPr txBox="1"/>
           <p:nvPr>
             <p:ph type="title" idx="0"/>
@@ -7997,7 +8644,7 @@
       </p:sp>
       <p:sp>
         <p:nvSpPr>
-          <p:cNvPr id="5" name="Placeholder 1"/>
+          <p:cNvPr id="6" name="Placeholder 1"/>
           <p:cNvSpPr txBox="1"/>
           <p:nvPr>
             <p:ph type="body" idx="1"/>
@@ -8042,7 +8689,7 @@
       </p:sp>
       <p:sp>
         <p:nvSpPr>
-          <p:cNvPr id="6" name="Placeholder 2"/>
+          <p:cNvPr id="7" name="Placeholder 2"/>
           <p:cNvSpPr txBox="1"/>
           <p:nvPr>
             <p:ph type="body" idx="2"/>
@@ -8107,7 +8754,7 @@
       </p:sp>
       <p:sp>
         <p:nvSpPr>
-          <p:cNvPr id="7" name="Placeholder 3"/>
+          <p:cNvPr id="8" name="Placeholder 3"/>
           <p:cNvSpPr txBox="1"/>
           <p:nvPr>
             <p:ph type="body" idx="3"/>
@@ -8152,7 +8799,7 @@
       </p:sp>
       <p:sp>
         <p:nvSpPr>
-          <p:cNvPr id="8" name="Placeholder 4"/>
+          <p:cNvPr id="9" name="Placeholder 4"/>
           <p:cNvSpPr txBox="1"/>
           <p:nvPr>
             <p:ph type="body" idx="4"/>
@@ -8217,7 +8864,7 @@
       </p:sp>
       <p:sp>
         <p:nvSpPr>
-          <p:cNvPr id="9" name="Placeholder 5"/>
+          <p:cNvPr id="10" name="Placeholder 5"/>
           <p:cNvSpPr txBox="1"/>
           <p:nvPr>
             <p:ph type="body" idx="5"/>
@@ -8262,7 +8909,7 @@
       </p:sp>
       <p:sp>
         <p:nvSpPr>
-          <p:cNvPr id="10" name="Placeholder 6"/>
+          <p:cNvPr id="11" name="Placeholder 6"/>
           <p:cNvSpPr txBox="1"/>
           <p:nvPr>
             <p:ph type="body" idx="6"/>
@@ -8327,7 +8974,7 @@
       </p:sp>
       <p:sp>
         <p:nvSpPr>
-          <p:cNvPr id="11" name="Placeholder 7"/>
+          <p:cNvPr id="12" name="Placeholder 7"/>
           <p:cNvSpPr txBox="1"/>
           <p:nvPr>
             <p:ph type="body" idx="7"/>

</xml_diff>